<commit_message>
Fix bar charts, circle positioning, and chart rendering
- Single Likert questions now render as individual horizontal bars
  (one bar per response option) instead of a single stacked bar
- Bars display in correct order: most-positive response at top
  (via invert_yaxis + reversed SPSS code order)
- Circle badges now positioned dynamically based on actual bar positions:
  top-box circle aligns with the top-box bars, bottom-box with bottom-box bars
- Charts rendered at fixed CHART_BOX dimensions (5.50×5.30") to prevent
  stretching distortion when embedded in slides
- Exported AXIS_TOP/AXIS_BOTTOM constants from chart_styles for precise
  slide-coordinate circle placement
- Update annotations_template.yaml to use chart_type: bar for single questions

https://claude.ai/code/session_01VCXkWfprNAwES9BXV74rqk
</commit_message>
<xml_diff>
--- a/sample_data/output.pptx
+++ b/sample_data/output.pptx
@@ -4254,8 +4254,8 @@
         </p:nvSpPr>
         <p:spPr>
           <a:xfrm>
-            <a:off x="4160520" y="2011680"/>
-            <a:ext cx="1371600" cy="1371600"/>
+            <a:off x="4381804" y="1842881"/>
+            <a:ext cx="1316736" cy="1316736"/>
           </a:xfrm>
           <a:prstGeom prst="ellipse">
             <a:avLst/>
@@ -4297,8 +4297,8 @@
         </p:nvSpPr>
         <p:spPr>
           <a:xfrm>
-            <a:off x="4160520" y="2176272"/>
-            <a:ext cx="1371600" cy="754380"/>
+            <a:off x="4381804" y="1974555"/>
+            <a:ext cx="1316736" cy="684702"/>
           </a:xfrm>
           <a:prstGeom prst="rect">
             <a:avLst/>
@@ -4331,8 +4331,8 @@
         </p:nvSpPr>
         <p:spPr>
           <a:xfrm>
-            <a:off x="4160520" y="2862072"/>
-            <a:ext cx="1371600" cy="438912"/>
+            <a:off x="4381804" y="2606588"/>
+            <a:ext cx="1316736" cy="474024"/>
           </a:xfrm>
           <a:prstGeom prst="rect">
             <a:avLst/>
@@ -4365,8 +4365,8 @@
         </p:nvSpPr>
         <p:spPr>
           <a:xfrm>
-            <a:off x="4160520" y="3657600"/>
-            <a:ext cx="1097280" cy="1097280"/>
+            <a:off x="4447641" y="4642043"/>
+            <a:ext cx="1185062" cy="1185062"/>
           </a:xfrm>
           <a:prstGeom prst="ellipse">
             <a:avLst/>
@@ -4408,8 +4408,8 @@
         </p:nvSpPr>
         <p:spPr>
           <a:xfrm>
-            <a:off x="4160520" y="3789273"/>
-            <a:ext cx="1097280" cy="603504"/>
+            <a:off x="4447641" y="4760549"/>
+            <a:ext cx="1185062" cy="616232"/>
           </a:xfrm>
           <a:prstGeom prst="rect">
             <a:avLst/>
@@ -4442,8 +4442,8 @@
         </p:nvSpPr>
         <p:spPr>
           <a:xfrm>
-            <a:off x="4160520" y="4337913"/>
-            <a:ext cx="1097280" cy="351129"/>
+            <a:off x="4447641" y="5329379"/>
+            <a:ext cx="1185062" cy="426622"/>
           </a:xfrm>
           <a:prstGeom prst="rect">
             <a:avLst/>
@@ -4935,8 +4935,8 @@
         </p:nvSpPr>
         <p:spPr>
           <a:xfrm>
-            <a:off x="4160520" y="2011680"/>
-            <a:ext cx="1371600" cy="1371600"/>
+            <a:off x="4381804" y="1842881"/>
+            <a:ext cx="1316736" cy="1316736"/>
           </a:xfrm>
           <a:prstGeom prst="ellipse">
             <a:avLst/>
@@ -4978,8 +4978,8 @@
         </p:nvSpPr>
         <p:spPr>
           <a:xfrm>
-            <a:off x="4160520" y="2176272"/>
-            <a:ext cx="1371600" cy="754380"/>
+            <a:off x="4381804" y="1974555"/>
+            <a:ext cx="1316736" cy="684702"/>
           </a:xfrm>
           <a:prstGeom prst="rect">
             <a:avLst/>
@@ -5012,8 +5012,8 @@
         </p:nvSpPr>
         <p:spPr>
           <a:xfrm>
-            <a:off x="4160520" y="2862072"/>
-            <a:ext cx="1371600" cy="438912"/>
+            <a:off x="4381804" y="2606588"/>
+            <a:ext cx="1316736" cy="474024"/>
           </a:xfrm>
           <a:prstGeom prst="rect">
             <a:avLst/>
@@ -5046,8 +5046,8 @@
         </p:nvSpPr>
         <p:spPr>
           <a:xfrm>
-            <a:off x="4160520" y="3657600"/>
-            <a:ext cx="1097280" cy="1097280"/>
+            <a:off x="4447641" y="4642043"/>
+            <a:ext cx="1185062" cy="1185062"/>
           </a:xfrm>
           <a:prstGeom prst="ellipse">
             <a:avLst/>
@@ -5089,8 +5089,8 @@
         </p:nvSpPr>
         <p:spPr>
           <a:xfrm>
-            <a:off x="4160520" y="3789273"/>
-            <a:ext cx="1097280" cy="603504"/>
+            <a:off x="4447641" y="4760549"/>
+            <a:ext cx="1185062" cy="616232"/>
           </a:xfrm>
           <a:prstGeom prst="rect">
             <a:avLst/>
@@ -5123,8 +5123,8 @@
         </p:nvSpPr>
         <p:spPr>
           <a:xfrm>
-            <a:off x="4160520" y="4337913"/>
-            <a:ext cx="1097280" cy="351129"/>
+            <a:off x="4447641" y="5329379"/>
+            <a:ext cx="1185062" cy="426622"/>
           </a:xfrm>
           <a:prstGeom prst="rect">
             <a:avLst/>
@@ -5471,8 +5471,8 @@
         </p:nvSpPr>
         <p:spPr>
           <a:xfrm>
-            <a:off x="4160520" y="2011680"/>
-            <a:ext cx="1371600" cy="1371600"/>
+            <a:off x="4381804" y="1842881"/>
+            <a:ext cx="1316736" cy="1316736"/>
           </a:xfrm>
           <a:prstGeom prst="ellipse">
             <a:avLst/>
@@ -5514,8 +5514,8 @@
         </p:nvSpPr>
         <p:spPr>
           <a:xfrm>
-            <a:off x="4160520" y="2176272"/>
-            <a:ext cx="1371600" cy="754380"/>
+            <a:off x="4381804" y="1974555"/>
+            <a:ext cx="1316736" cy="684702"/>
           </a:xfrm>
           <a:prstGeom prst="rect">
             <a:avLst/>
@@ -5548,8 +5548,8 @@
         </p:nvSpPr>
         <p:spPr>
           <a:xfrm>
-            <a:off x="4160520" y="2862072"/>
-            <a:ext cx="1371600" cy="438912"/>
+            <a:off x="4381804" y="2606588"/>
+            <a:ext cx="1316736" cy="474024"/>
           </a:xfrm>
           <a:prstGeom prst="rect">
             <a:avLst/>
@@ -5582,8 +5582,8 @@
         </p:nvSpPr>
         <p:spPr>
           <a:xfrm>
-            <a:off x="4160520" y="3657600"/>
-            <a:ext cx="1097280" cy="1097280"/>
+            <a:off x="4447641" y="4642043"/>
+            <a:ext cx="1185062" cy="1185062"/>
           </a:xfrm>
           <a:prstGeom prst="ellipse">
             <a:avLst/>
@@ -5625,8 +5625,8 @@
         </p:nvSpPr>
         <p:spPr>
           <a:xfrm>
-            <a:off x="4160520" y="3789273"/>
-            <a:ext cx="1097280" cy="603504"/>
+            <a:off x="4447641" y="4760549"/>
+            <a:ext cx="1185062" cy="616232"/>
           </a:xfrm>
           <a:prstGeom prst="rect">
             <a:avLst/>
@@ -5659,8 +5659,8 @@
         </p:nvSpPr>
         <p:spPr>
           <a:xfrm>
-            <a:off x="4160520" y="4337913"/>
-            <a:ext cx="1097280" cy="351129"/>
+            <a:off x="4447641" y="5329379"/>
+            <a:ext cx="1185062" cy="426622"/>
           </a:xfrm>
           <a:prstGeom prst="rect">
             <a:avLst/>
@@ -5967,8 +5967,8 @@
         </p:nvSpPr>
         <p:spPr>
           <a:xfrm>
-            <a:off x="4160520" y="2011680"/>
-            <a:ext cx="1371600" cy="1371600"/>
+            <a:off x="4381804" y="1842881"/>
+            <a:ext cx="1316736" cy="1316736"/>
           </a:xfrm>
           <a:prstGeom prst="ellipse">
             <a:avLst/>
@@ -6010,8 +6010,8 @@
         </p:nvSpPr>
         <p:spPr>
           <a:xfrm>
-            <a:off x="4160520" y="2176272"/>
-            <a:ext cx="1371600" cy="754380"/>
+            <a:off x="4381804" y="1974555"/>
+            <a:ext cx="1316736" cy="684702"/>
           </a:xfrm>
           <a:prstGeom prst="rect">
             <a:avLst/>
@@ -6044,8 +6044,8 @@
         </p:nvSpPr>
         <p:spPr>
           <a:xfrm>
-            <a:off x="4160520" y="2862072"/>
-            <a:ext cx="1371600" cy="438912"/>
+            <a:off x="4381804" y="2606588"/>
+            <a:ext cx="1316736" cy="474024"/>
           </a:xfrm>
           <a:prstGeom prst="rect">
             <a:avLst/>
@@ -6078,8 +6078,8 @@
         </p:nvSpPr>
         <p:spPr>
           <a:xfrm>
-            <a:off x="4160520" y="3657600"/>
-            <a:ext cx="1097280" cy="1097280"/>
+            <a:off x="4447641" y="4642043"/>
+            <a:ext cx="1185062" cy="1185062"/>
           </a:xfrm>
           <a:prstGeom prst="ellipse">
             <a:avLst/>
@@ -6121,8 +6121,8 @@
         </p:nvSpPr>
         <p:spPr>
           <a:xfrm>
-            <a:off x="4160520" y="3789273"/>
-            <a:ext cx="1097280" cy="603504"/>
+            <a:off x="4447641" y="4760549"/>
+            <a:ext cx="1185062" cy="616232"/>
           </a:xfrm>
           <a:prstGeom prst="rect">
             <a:avLst/>
@@ -6155,8 +6155,8 @@
         </p:nvSpPr>
         <p:spPr>
           <a:xfrm>
-            <a:off x="4160520" y="4337913"/>
-            <a:ext cx="1097280" cy="351129"/>
+            <a:off x="4447641" y="5329379"/>
+            <a:ext cx="1185062" cy="426622"/>
           </a:xfrm>
           <a:prstGeom prst="rect">
             <a:avLst/>

</xml_diff>

<commit_message>
Add grid slide support, scale-position bar colouring, and dynamic circles
- chart_styles.py: render_simple_bar now accepts bar_colors list for
  per-bar hex colours; draws bars individually in a loop
- slide_builder.py:
  - _scale_bar_colors(): assigns teal (positive), gray (neutral),
    salmon/coral (negative) by top/bottom box membership
  - _bar_circle_center_y(): uses exported AXIS_TOP/AXIS_BOTTOM fractions
    so circle badges align with the exact rendered bar
  - add_grid_slide(): multiple QuestionResult objects → stacked horizontal
    bar with one row per question, Likert-style segment colouring, and
    a legend strip below the chart
  - build_pptx() now handles type: grid slides
- annotations_template.yaml: replace three individual product/service/
  value chart slides with a single type: grid slide combining all three
- output.pptx: regenerated (9 slides including the new grid slide)

https://claude.ai/code/session_01VCXkWfprNAwES9BXV74rqk
</commit_message>
<xml_diff>
--- a/sample_data/output.pptx
+++ b/sample_data/output.pptx
@@ -14,8 +14,6 @@
     <p:sldId id="262" r:id="rId13"/>
     <p:sldId id="263" r:id="rId14"/>
     <p:sldId id="264" r:id="rId15"/>
-    <p:sldId id="265" r:id="rId16"/>
-    <p:sldId id="266" r:id="rId17"/>
   </p:sldIdLst>
   <p:sldSz cx="9144000" cy="6858000" type="screen4x3"/>
   <p:notesSz cx="6858000" cy="9144000"/>
@@ -3251,524 +3249,6 @@
 </p:sld>
 </file>
 
-<file path=ppt/slides/slide10.xml><?xml version="1.0" encoding="utf-8"?>
-<p:sld xmlns:a="http://schemas.openxmlformats.org/drawingml/2006/main" xmlns:p="http://schemas.openxmlformats.org/presentationml/2006/main" xmlns:r="http://schemas.openxmlformats.org/officeDocument/2006/relationships">
-  <p:cSld>
-    <p:spTree>
-      <p:nvGrpSpPr>
-        <p:cNvPr id="1" name=""/>
-        <p:cNvGrpSpPr/>
-        <p:nvPr/>
-      </p:nvGrpSpPr>
-      <p:grpSpPr/>
-      <p:sp>
-        <p:nvSpPr>
-          <p:cNvPr id="2" name="Rectangle 1"/>
-          <p:cNvSpPr/>
-          <p:nvPr/>
-        </p:nvSpPr>
-        <p:spPr>
-          <a:xfrm>
-            <a:off x="0" y="0"/>
-            <a:ext cx="9144000" cy="457200"/>
-          </a:xfrm>
-          <a:prstGeom prst="rect">
-            <a:avLst/>
-          </a:prstGeom>
-          <a:solidFill>
-            <a:srgbClr val="1B5566"/>
-          </a:solidFill>
-          <a:ln>
-            <a:noFill/>
-          </a:ln>
-        </p:spPr>
-        <p:style>
-          <a:lnRef idx="1">
-            <a:schemeClr val="accent1"/>
-          </a:lnRef>
-          <a:fillRef idx="3">
-            <a:schemeClr val="accent1"/>
-          </a:fillRef>
-          <a:effectRef idx="2">
-            <a:schemeClr val="accent1"/>
-          </a:effectRef>
-          <a:fontRef idx="minor">
-            <a:schemeClr val="lt1"/>
-          </a:fontRef>
-        </p:style>
-        <p:txBody>
-          <a:bodyPr rtlCol="0" anchor="ctr"/>
-          <a:lstStyle/>
-          <a:p>
-            <a:pPr algn="ctr"/>
-          </a:p>
-        </p:txBody>
-      </p:sp>
-      <p:sp>
-        <p:nvSpPr>
-          <p:cNvPr id="3" name="TextBox 2"/>
-          <p:cNvSpPr txBox="1"/>
-          <p:nvPr/>
-        </p:nvSpPr>
-        <p:spPr>
-          <a:xfrm>
-            <a:off x="274320" y="457200"/>
-            <a:ext cx="8595360" cy="594360"/>
-          </a:xfrm>
-          <a:prstGeom prst="rect">
-            <a:avLst/>
-          </a:prstGeom>
-          <a:noFill/>
-        </p:spPr>
-        <p:txBody>
-          <a:bodyPr wrap="square">
-            <a:spAutoFit/>
-          </a:bodyPr>
-          <a:lstStyle/>
-          <a:p>
-            <a:pPr algn="l"/>
-            <a:r>
-              <a:rPr sz="1800" b="1" i="0">
-                <a:solidFill>
-                  <a:srgbClr val="D94438"/>
-                </a:solidFill>
-              </a:rPr>
-              <a:t>Respondent region</a:t>
-            </a:r>
-          </a:p>
-        </p:txBody>
-      </p:sp>
-      <p:sp>
-        <p:nvSpPr>
-          <p:cNvPr id="4" name="TextBox 3"/>
-          <p:cNvSpPr txBox="1"/>
-          <p:nvPr/>
-        </p:nvSpPr>
-        <p:spPr>
-          <a:xfrm>
-            <a:off x="274320" y="1051560"/>
-            <a:ext cx="8595360" cy="347472"/>
-          </a:xfrm>
-          <a:prstGeom prst="rect">
-            <a:avLst/>
-          </a:prstGeom>
-          <a:noFill/>
-        </p:spPr>
-        <p:txBody>
-          <a:bodyPr wrap="square">
-            <a:spAutoFit/>
-          </a:bodyPr>
-          <a:lstStyle/>
-          <a:p>
-            <a:pPr algn="l"/>
-            <a:r>
-              <a:rPr sz="1100" b="0" i="1">
-                <a:solidFill>
-                  <a:srgbClr val="58595B"/>
-                </a:solidFill>
-              </a:rPr>
-              <a:t>Which region are you based in? (%)</a:t>
-            </a:r>
-          </a:p>
-        </p:txBody>
-      </p:sp>
-      <p:pic>
-        <p:nvPicPr>
-          <p:cNvPr id="5" name="Picture 4" descr="image.png"/>
-          <p:cNvPicPr>
-            <a:picLocks noChangeAspect="1"/>
-          </p:cNvPicPr>
-          <p:nvPr/>
-        </p:nvPicPr>
-        <p:blipFill>
-          <a:blip r:embed="rId2"/>
-          <a:stretch>
-            <a:fillRect/>
-          </a:stretch>
-        </p:blipFill>
-        <p:spPr>
-          <a:xfrm>
-            <a:off x="274320" y="1444752"/>
-            <a:ext cx="5029200" cy="4846320"/>
-          </a:xfrm>
-          <a:prstGeom prst="rect">
-            <a:avLst/>
-          </a:prstGeom>
-        </p:spPr>
-      </p:pic>
-      <p:sp>
-        <p:nvSpPr>
-          <p:cNvPr id="6" name="TextBox 5"/>
-          <p:cNvSpPr txBox="1"/>
-          <p:nvPr/>
-        </p:nvSpPr>
-        <p:spPr>
-          <a:xfrm>
-            <a:off x="5532120" y="1444752"/>
-            <a:ext cx="3337560" cy="4846320"/>
-          </a:xfrm>
-          <a:prstGeom prst="rect">
-            <a:avLst/>
-          </a:prstGeom>
-          <a:noFill/>
-        </p:spPr>
-        <p:txBody>
-          <a:bodyPr wrap="square">
-            <a:spAutoFit/>
-          </a:bodyPr>
-          <a:lstStyle/>
-          <a:p>
-            <a:r>
-              <a:rPr sz="1000" b="0">
-                <a:solidFill>
-                  <a:srgbClr val="58595B"/>
-                </a:solidFill>
-              </a:rPr>
-              <a:t>Sample is evenly spread across four regions.</a:t>
-            </a:r>
-          </a:p>
-          <a:p>
-            <a:r>
-              <a:rPr sz="1000" b="0">
-                <a:solidFill>
-                  <a:srgbClr val="58595B"/>
-                </a:solidFill>
-              </a:rPr>
-              <a:t>North, South, East and West each represent approximately 25%.</a:t>
-            </a:r>
-          </a:p>
-        </p:txBody>
-      </p:sp>
-      <p:sp>
-        <p:nvSpPr>
-          <p:cNvPr id="7" name="TextBox 6"/>
-          <p:cNvSpPr txBox="1"/>
-          <p:nvPr/>
-        </p:nvSpPr>
-        <p:spPr>
-          <a:xfrm>
-            <a:off x="274320" y="6492240"/>
-            <a:ext cx="8595360" cy="256032"/>
-          </a:xfrm>
-          <a:prstGeom prst="rect">
-            <a:avLst/>
-          </a:prstGeom>
-          <a:noFill/>
-        </p:spPr>
-        <p:txBody>
-          <a:bodyPr wrap="square">
-            <a:spAutoFit/>
-          </a:bodyPr>
-          <a:lstStyle/>
-          <a:p>
-            <a:pPr algn="l"/>
-            <a:r>
-              <a:rPr sz="800" b="0" i="1">
-                <a:solidFill>
-                  <a:srgbClr val="58595B"/>
-                </a:solidFill>
-              </a:rPr>
-              <a:t>Base: all respondents (n=200)</a:t>
-            </a:r>
-          </a:p>
-        </p:txBody>
-      </p:sp>
-      <p:sp>
-        <p:nvSpPr>
-          <p:cNvPr id="8" name="TextBox 7"/>
-          <p:cNvSpPr txBox="1"/>
-          <p:nvPr/>
-        </p:nvSpPr>
-        <p:spPr>
-          <a:xfrm>
-            <a:off x="8503920" y="91440"/>
-            <a:ext cx="457200" cy="274320"/>
-          </a:xfrm>
-          <a:prstGeom prst="rect">
-            <a:avLst/>
-          </a:prstGeom>
-          <a:noFill/>
-        </p:spPr>
-        <p:txBody>
-          <a:bodyPr wrap="square">
-            <a:spAutoFit/>
-          </a:bodyPr>
-          <a:lstStyle/>
-          <a:p>
-            <a:pPr algn="r"/>
-            <a:r>
-              <a:rPr sz="800" b="0" i="0">
-                <a:solidFill>
-                  <a:srgbClr val="FFFFFF"/>
-                </a:solidFill>
-              </a:rPr>
-              <a:t>6</a:t>
-            </a:r>
-          </a:p>
-        </p:txBody>
-      </p:sp>
-    </p:spTree>
-  </p:cSld>
-  <p:clrMapOvr>
-    <a:masterClrMapping/>
-  </p:clrMapOvr>
-</p:sld>
-</file>
-
-<file path=ppt/slides/slide11.xml><?xml version="1.0" encoding="utf-8"?>
-<p:sld xmlns:a="http://schemas.openxmlformats.org/drawingml/2006/main" xmlns:p="http://schemas.openxmlformats.org/presentationml/2006/main" xmlns:r="http://schemas.openxmlformats.org/officeDocument/2006/relationships">
-  <p:cSld>
-    <p:spTree>
-      <p:nvGrpSpPr>
-        <p:cNvPr id="1" name=""/>
-        <p:cNvGrpSpPr/>
-        <p:nvPr/>
-      </p:nvGrpSpPr>
-      <p:grpSpPr/>
-      <p:sp>
-        <p:nvSpPr>
-          <p:cNvPr id="2" name="Rectangle 1"/>
-          <p:cNvSpPr/>
-          <p:nvPr/>
-        </p:nvSpPr>
-        <p:spPr>
-          <a:xfrm>
-            <a:off x="0" y="0"/>
-            <a:ext cx="9144000" cy="457200"/>
-          </a:xfrm>
-          <a:prstGeom prst="rect">
-            <a:avLst/>
-          </a:prstGeom>
-          <a:solidFill>
-            <a:srgbClr val="1B5566"/>
-          </a:solidFill>
-          <a:ln>
-            <a:noFill/>
-          </a:ln>
-        </p:spPr>
-        <p:style>
-          <a:lnRef idx="1">
-            <a:schemeClr val="accent1"/>
-          </a:lnRef>
-          <a:fillRef idx="3">
-            <a:schemeClr val="accent1"/>
-          </a:fillRef>
-          <a:effectRef idx="2">
-            <a:schemeClr val="accent1"/>
-          </a:effectRef>
-          <a:fontRef idx="minor">
-            <a:schemeClr val="lt1"/>
-          </a:fontRef>
-        </p:style>
-        <p:txBody>
-          <a:bodyPr rtlCol="0" anchor="ctr"/>
-          <a:lstStyle/>
-          <a:p>
-            <a:pPr algn="ctr"/>
-          </a:p>
-        </p:txBody>
-      </p:sp>
-      <p:sp>
-        <p:nvSpPr>
-          <p:cNvPr id="3" name="TextBox 2"/>
-          <p:cNvSpPr txBox="1"/>
-          <p:nvPr/>
-        </p:nvSpPr>
-        <p:spPr>
-          <a:xfrm>
-            <a:off x="274320" y="457200"/>
-            <a:ext cx="8595360" cy="594360"/>
-          </a:xfrm>
-          <a:prstGeom prst="rect">
-            <a:avLst/>
-          </a:prstGeom>
-          <a:noFill/>
-        </p:spPr>
-        <p:txBody>
-          <a:bodyPr wrap="square">
-            <a:spAutoFit/>
-          </a:bodyPr>
-          <a:lstStyle/>
-          <a:p>
-            <a:pPr algn="l"/>
-            <a:r>
-              <a:rPr sz="1800" b="1" i="0">
-                <a:solidFill>
-                  <a:srgbClr val="D94438"/>
-                </a:solidFill>
-              </a:rPr>
-              <a:t>Respondent age group</a:t>
-            </a:r>
-          </a:p>
-        </p:txBody>
-      </p:sp>
-      <p:sp>
-        <p:nvSpPr>
-          <p:cNvPr id="4" name="TextBox 3"/>
-          <p:cNvSpPr txBox="1"/>
-          <p:nvPr/>
-        </p:nvSpPr>
-        <p:spPr>
-          <a:xfrm>
-            <a:off x="274320" y="1051560"/>
-            <a:ext cx="8595360" cy="347472"/>
-          </a:xfrm>
-          <a:prstGeom prst="rect">
-            <a:avLst/>
-          </a:prstGeom>
-          <a:noFill/>
-        </p:spPr>
-        <p:txBody>
-          <a:bodyPr wrap="square">
-            <a:spAutoFit/>
-          </a:bodyPr>
-          <a:lstStyle/>
-          <a:p>
-            <a:pPr algn="l"/>
-            <a:r>
-              <a:rPr sz="1100" b="0" i="1">
-                <a:solidFill>
-                  <a:srgbClr val="58595B"/>
-                </a:solidFill>
-              </a:rPr>
-              <a:t>What is your age group? (%)</a:t>
-            </a:r>
-          </a:p>
-        </p:txBody>
-      </p:sp>
-      <p:pic>
-        <p:nvPicPr>
-          <p:cNvPr id="5" name="Picture 4" descr="image.png"/>
-          <p:cNvPicPr>
-            <a:picLocks noChangeAspect="1"/>
-          </p:cNvPicPr>
-          <p:nvPr/>
-        </p:nvPicPr>
-        <p:blipFill>
-          <a:blip r:embed="rId2"/>
-          <a:stretch>
-            <a:fillRect/>
-          </a:stretch>
-        </p:blipFill>
-        <p:spPr>
-          <a:xfrm>
-            <a:off x="274320" y="1444752"/>
-            <a:ext cx="5029200" cy="4846320"/>
-          </a:xfrm>
-          <a:prstGeom prst="rect">
-            <a:avLst/>
-          </a:prstGeom>
-        </p:spPr>
-      </p:pic>
-      <p:sp>
-        <p:nvSpPr>
-          <p:cNvPr id="6" name="TextBox 5"/>
-          <p:cNvSpPr txBox="1"/>
-          <p:nvPr/>
-        </p:nvSpPr>
-        <p:spPr>
-          <a:xfrm>
-            <a:off x="5532120" y="1444752"/>
-            <a:ext cx="3337560" cy="4846320"/>
-          </a:xfrm>
-          <a:prstGeom prst="rect">
-            <a:avLst/>
-          </a:prstGeom>
-          <a:noFill/>
-        </p:spPr>
-        <p:txBody>
-          <a:bodyPr wrap="square">
-            <a:spAutoFit/>
-          </a:bodyPr>
-          <a:lstStyle/>
-          <a:p>
-            <a:r>
-              <a:rPr sz="1000" b="0">
-                <a:solidFill>
-                  <a:srgbClr val="58595B"/>
-                </a:solidFill>
-              </a:rPr>
-              <a:t>Each age band represents roughly 20% of the sample.</a:t>
-            </a:r>
-          </a:p>
-        </p:txBody>
-      </p:sp>
-      <p:sp>
-        <p:nvSpPr>
-          <p:cNvPr id="7" name="TextBox 6"/>
-          <p:cNvSpPr txBox="1"/>
-          <p:nvPr/>
-        </p:nvSpPr>
-        <p:spPr>
-          <a:xfrm>
-            <a:off x="274320" y="6492240"/>
-            <a:ext cx="8595360" cy="256032"/>
-          </a:xfrm>
-          <a:prstGeom prst="rect">
-            <a:avLst/>
-          </a:prstGeom>
-          <a:noFill/>
-        </p:spPr>
-        <p:txBody>
-          <a:bodyPr wrap="square">
-            <a:spAutoFit/>
-          </a:bodyPr>
-          <a:lstStyle/>
-          <a:p>
-            <a:pPr algn="l"/>
-            <a:r>
-              <a:rPr sz="800" b="0" i="1">
-                <a:solidFill>
-                  <a:srgbClr val="58595B"/>
-                </a:solidFill>
-              </a:rPr>
-              <a:t>Base: all respondents (n=200)</a:t>
-            </a:r>
-          </a:p>
-        </p:txBody>
-      </p:sp>
-      <p:sp>
-        <p:nvSpPr>
-          <p:cNvPr id="8" name="TextBox 7"/>
-          <p:cNvSpPr txBox="1"/>
-          <p:nvPr/>
-        </p:nvSpPr>
-        <p:spPr>
-          <a:xfrm>
-            <a:off x="8503920" y="91440"/>
-            <a:ext cx="457200" cy="274320"/>
-          </a:xfrm>
-          <a:prstGeom prst="rect">
-            <a:avLst/>
-          </a:prstGeom>
-          <a:noFill/>
-        </p:spPr>
-        <p:txBody>
-          <a:bodyPr wrap="square">
-            <a:spAutoFit/>
-          </a:bodyPr>
-          <a:lstStyle/>
-          <a:p>
-            <a:pPr algn="r"/>
-            <a:r>
-              <a:rPr sz="800" b="0" i="0">
-                <a:solidFill>
-                  <a:srgbClr val="FFFFFF"/>
-                </a:solidFill>
-              </a:rPr>
-              <a:t>7</a:t>
-            </a:r>
-          </a:p>
-        </p:txBody>
-      </p:sp>
-    </p:spTree>
-  </p:cSld>
-  <p:clrMapOvr>
-    <a:masterClrMapping/>
-  </p:clrMapOvr>
-</p:sld>
-</file>
-
 <file path=ppt/slides/slide2.xml><?xml version="1.0" encoding="utf-8"?>
 <p:sld xmlns:a="http://schemas.openxmlformats.org/drawingml/2006/main" xmlns:p="http://schemas.openxmlformats.org/presentationml/2006/main" xmlns:r="http://schemas.openxmlformats.org/officeDocument/2006/relationships">
   <p:cSld>
@@ -4254,7 +3734,7 @@
         </p:nvSpPr>
         <p:spPr>
           <a:xfrm>
-            <a:off x="4381804" y="1842881"/>
+            <a:off x="4315968" y="1842881"/>
             <a:ext cx="1316736" cy="1316736"/>
           </a:xfrm>
           <a:prstGeom prst="ellipse">
@@ -4297,7 +3777,7 @@
         </p:nvSpPr>
         <p:spPr>
           <a:xfrm>
-            <a:off x="4381804" y="1974555"/>
+            <a:off x="4315968" y="1974555"/>
             <a:ext cx="1316736" cy="684702"/>
           </a:xfrm>
           <a:prstGeom prst="rect">
@@ -4331,7 +3811,7 @@
         </p:nvSpPr>
         <p:spPr>
           <a:xfrm>
-            <a:off x="4381804" y="2606588"/>
+            <a:off x="4315968" y="2606588"/>
             <a:ext cx="1316736" cy="474024"/>
           </a:xfrm>
           <a:prstGeom prst="rect">
@@ -4365,7 +3845,7 @@
         </p:nvSpPr>
         <p:spPr>
           <a:xfrm>
-            <a:off x="4447641" y="4642043"/>
+            <a:off x="4381804" y="4642043"/>
             <a:ext cx="1185062" cy="1185062"/>
           </a:xfrm>
           <a:prstGeom prst="ellipse">
@@ -4408,7 +3888,7 @@
         </p:nvSpPr>
         <p:spPr>
           <a:xfrm>
-            <a:off x="4447641" y="4760549"/>
+            <a:off x="4381804" y="4760549"/>
             <a:ext cx="1185062" cy="616232"/>
           </a:xfrm>
           <a:prstGeom prst="rect">
@@ -4442,7 +3922,7 @@
         </p:nvSpPr>
         <p:spPr>
           <a:xfrm>
-            <a:off x="4447641" y="5329379"/>
+            <a:off x="4381804" y="5329379"/>
             <a:ext cx="1185062" cy="426622"/>
           </a:xfrm>
           <a:prstGeom prst="rect">
@@ -4864,7 +4344,7 @@
                   <a:srgbClr val="D94438"/>
                 </a:solidFill>
               </a:rPr>
-              <a:t>Rating — product quality</a:t>
+              <a:t>Ratings — product quality, customer service &amp; value for money</a:t>
             </a:r>
           </a:p>
         </p:txBody>
@@ -4898,7 +4378,7 @@
                   <a:srgbClr val="58595B"/>
                 </a:solidFill>
               </a:rPr>
-              <a:t>Please rate the quality of our product. (%)</a:t>
+              <a:t>Please rate each of the following. (%)</a:t>
             </a:r>
           </a:p>
         </p:txBody>
@@ -4927,49 +4407,30 @@
           </a:prstGeom>
         </p:spPr>
       </p:pic>
-      <p:sp>
-        <p:nvSpPr>
-          <p:cNvPr id="6" name="Oval 5"/>
-          <p:cNvSpPr/>
+      <p:pic>
+        <p:nvPicPr>
+          <p:cNvPr id="6" name="Picture 5" descr="image.png"/>
+          <p:cNvPicPr>
+            <a:picLocks noChangeAspect="1"/>
+          </p:cNvPicPr>
           <p:nvPr/>
-        </p:nvSpPr>
-        <p:spPr>
-          <a:xfrm>
-            <a:off x="4381804" y="1842881"/>
-            <a:ext cx="1316736" cy="1316736"/>
-          </a:xfrm>
-          <a:prstGeom prst="ellipse">
+        </p:nvPicPr>
+        <p:blipFill>
+          <a:blip r:embed="rId3"/>
+          <a:stretch>
+            <a:fillRect/>
+          </a:stretch>
+        </p:blipFill>
+        <p:spPr>
+          <a:xfrm>
+            <a:off x="274320" y="6336792"/>
+            <a:ext cx="5029200" cy="256032"/>
+          </a:xfrm>
+          <a:prstGeom prst="rect">
             <a:avLst/>
           </a:prstGeom>
-          <a:solidFill>
-            <a:srgbClr val="00B5B8"/>
-          </a:solidFill>
-          <a:ln>
-            <a:noFill/>
-          </a:ln>
-        </p:spPr>
-        <p:style>
-          <a:lnRef idx="1">
-            <a:schemeClr val="accent1"/>
-          </a:lnRef>
-          <a:fillRef idx="3">
-            <a:schemeClr val="accent1"/>
-          </a:fillRef>
-          <a:effectRef idx="2">
-            <a:schemeClr val="accent1"/>
-          </a:effectRef>
-          <a:fontRef idx="minor">
-            <a:schemeClr val="lt1"/>
-          </a:fontRef>
-        </p:style>
-        <p:txBody>
-          <a:bodyPr rtlCol="0" anchor="ctr"/>
-          <a:lstStyle/>
-          <a:p>
-            <a:pPr algn="ctr"/>
-          </a:p>
-        </p:txBody>
-      </p:sp>
+        </p:spPr>
+      </p:pic>
       <p:sp>
         <p:nvSpPr>
           <p:cNvPr id="7" name="TextBox 6"/>
@@ -4978,8 +4439,8 @@
         </p:nvSpPr>
         <p:spPr>
           <a:xfrm>
-            <a:off x="4381804" y="1974555"/>
-            <a:ext cx="1316736" cy="684702"/>
+            <a:off x="5532120" y="1444752"/>
+            <a:ext cx="3337560" cy="4846320"/>
           </a:xfrm>
           <a:prstGeom prst="rect">
             <a:avLst/>
@@ -4992,14 +4453,73 @@
           </a:bodyPr>
           <a:lstStyle/>
           <a:p>
-            <a:pPr algn="ctr"/>
-            <a:r>
-              <a:rPr sz="2000" b="1" i="0">
-                <a:solidFill>
-                  <a:srgbClr val="FFFFFF"/>
+            <a:r>
+              <a:rPr sz="1000" b="0">
+                <a:solidFill>
+                  <a:srgbClr val="58595B"/>
                 </a:solidFill>
               </a:rPr>
-              <a:t>40%</a:t>
+              <a:t>Good/Excellent ratings by measure:</a:t>
+            </a:r>
+          </a:p>
+          <a:p>
+            <a:r>
+              <a:rPr sz="1000" b="0">
+                <a:solidFill>
+                  <a:srgbClr val="58595B"/>
+                </a:solidFill>
+              </a:rPr>
+              <a:t>– Product quality:    XX%</a:t>
+            </a:r>
+          </a:p>
+          <a:p>
+            <a:r>
+              <a:rPr sz="1000" b="0">
+                <a:solidFill>
+                  <a:srgbClr val="58595B"/>
+                </a:solidFill>
+              </a:rPr>
+              <a:t>– Customer service:   XX%</a:t>
+            </a:r>
+          </a:p>
+          <a:p>
+            <a:r>
+              <a:rPr sz="1000" b="0">
+                <a:solidFill>
+                  <a:srgbClr val="58595B"/>
+                </a:solidFill>
+              </a:rPr>
+              <a:t>– Value for money:    XX%</a:t>
+            </a:r>
+          </a:p>
+          <a:p>
+            <a:r>
+              <a:rPr sz="1000" b="0">
+                <a:solidFill>
+                  <a:srgbClr val="58595B"/>
+                </a:solidFill>
+              </a:rPr>
+              <a:t/>
+            </a:r>
+          </a:p>
+          <a:p>
+            <a:r>
+              <a:rPr sz="1000" b="0">
+                <a:solidFill>
+                  <a:srgbClr val="58595B"/>
+                </a:solidFill>
+              </a:rPr>
+              <a:t>Those aged 18–24 were most positive</a:t>
+            </a:r>
+          </a:p>
+          <a:p>
+            <a:r>
+              <a:rPr sz="1000" b="0">
+                <a:solidFill>
+                  <a:srgbClr val="58595B"/>
+                </a:solidFill>
+              </a:rPr>
+              <a:t>about product quality.</a:t>
             </a:r>
           </a:p>
         </p:txBody>
@@ -5012,8 +4532,8 @@
         </p:nvSpPr>
         <p:spPr>
           <a:xfrm>
-            <a:off x="4381804" y="2606588"/>
-            <a:ext cx="1316736" cy="474024"/>
+            <a:off x="274320" y="6492240"/>
+            <a:ext cx="8595360" cy="256032"/>
           </a:xfrm>
           <a:prstGeom prst="rect">
             <a:avLst/>
@@ -5026,244 +4546,6 @@
           </a:bodyPr>
           <a:lstStyle/>
           <a:p>
-            <a:pPr algn="ctr"/>
-            <a:r>
-              <a:rPr sz="1100" b="0" i="0">
-                <a:solidFill>
-                  <a:srgbClr val="FFFFFF"/>
-                </a:solidFill>
-              </a:rPr>
-              <a:t>Good / Excellent</a:t>
-            </a:r>
-          </a:p>
-        </p:txBody>
-      </p:sp>
-      <p:sp>
-        <p:nvSpPr>
-          <p:cNvPr id="9" name="Oval 8"/>
-          <p:cNvSpPr/>
-          <p:nvPr/>
-        </p:nvSpPr>
-        <p:spPr>
-          <a:xfrm>
-            <a:off x="4447641" y="4642043"/>
-            <a:ext cx="1185062" cy="1185062"/>
-          </a:xfrm>
-          <a:prstGeom prst="ellipse">
-            <a:avLst/>
-          </a:prstGeom>
-          <a:solidFill>
-            <a:srgbClr val="D94438"/>
-          </a:solidFill>
-          <a:ln>
-            <a:noFill/>
-          </a:ln>
-        </p:spPr>
-        <p:style>
-          <a:lnRef idx="1">
-            <a:schemeClr val="accent1"/>
-          </a:lnRef>
-          <a:fillRef idx="3">
-            <a:schemeClr val="accent1"/>
-          </a:fillRef>
-          <a:effectRef idx="2">
-            <a:schemeClr val="accent1"/>
-          </a:effectRef>
-          <a:fontRef idx="minor">
-            <a:schemeClr val="lt1"/>
-          </a:fontRef>
-        </p:style>
-        <p:txBody>
-          <a:bodyPr rtlCol="0" anchor="ctr"/>
-          <a:lstStyle/>
-          <a:p>
-            <a:pPr algn="ctr"/>
-          </a:p>
-        </p:txBody>
-      </p:sp>
-      <p:sp>
-        <p:nvSpPr>
-          <p:cNvPr id="10" name="TextBox 9"/>
-          <p:cNvSpPr txBox="1"/>
-          <p:nvPr/>
-        </p:nvSpPr>
-        <p:spPr>
-          <a:xfrm>
-            <a:off x="4447641" y="4760549"/>
-            <a:ext cx="1185062" cy="616232"/>
-          </a:xfrm>
-          <a:prstGeom prst="rect">
-            <a:avLst/>
-          </a:prstGeom>
-          <a:noFill/>
-        </p:spPr>
-        <p:txBody>
-          <a:bodyPr wrap="square">
-            <a:spAutoFit/>
-          </a:bodyPr>
-          <a:lstStyle/>
-          <a:p>
-            <a:pPr algn="ctr"/>
-            <a:r>
-              <a:rPr sz="2000" b="1" i="0">
-                <a:solidFill>
-                  <a:srgbClr val="FFFFFF"/>
-                </a:solidFill>
-              </a:rPr>
-              <a:t>38%</a:t>
-            </a:r>
-          </a:p>
-        </p:txBody>
-      </p:sp>
-      <p:sp>
-        <p:nvSpPr>
-          <p:cNvPr id="11" name="TextBox 10"/>
-          <p:cNvSpPr txBox="1"/>
-          <p:nvPr/>
-        </p:nvSpPr>
-        <p:spPr>
-          <a:xfrm>
-            <a:off x="4447641" y="5329379"/>
-            <a:ext cx="1185062" cy="426622"/>
-          </a:xfrm>
-          <a:prstGeom prst="rect">
-            <a:avLst/>
-          </a:prstGeom>
-          <a:noFill/>
-        </p:spPr>
-        <p:txBody>
-          <a:bodyPr wrap="square">
-            <a:spAutoFit/>
-          </a:bodyPr>
-          <a:lstStyle/>
-          <a:p>
-            <a:pPr algn="ctr"/>
-            <a:r>
-              <a:rPr sz="1100" b="0" i="0">
-                <a:solidFill>
-                  <a:srgbClr val="FFFFFF"/>
-                </a:solidFill>
-              </a:rPr>
-              <a:t>Poor / Very poor</a:t>
-            </a:r>
-          </a:p>
-        </p:txBody>
-      </p:sp>
-      <p:sp>
-        <p:nvSpPr>
-          <p:cNvPr id="12" name="TextBox 11"/>
-          <p:cNvSpPr txBox="1"/>
-          <p:nvPr/>
-        </p:nvSpPr>
-        <p:spPr>
-          <a:xfrm>
-            <a:off x="5532120" y="1444752"/>
-            <a:ext cx="3337560" cy="4846320"/>
-          </a:xfrm>
-          <a:prstGeom prst="rect">
-            <a:avLst/>
-          </a:prstGeom>
-          <a:noFill/>
-        </p:spPr>
-        <p:txBody>
-          <a:bodyPr wrap="square">
-            <a:spAutoFit/>
-          </a:bodyPr>
-          <a:lstStyle/>
-          <a:p>
-            <a:r>
-              <a:rPr sz="1000" b="0">
-                <a:solidFill>
-                  <a:srgbClr val="58595B"/>
-                </a:solidFill>
-              </a:rPr>
-              <a:t>Those aged 18–24 were more likely to rate quality as Excellent.</a:t>
-            </a:r>
-          </a:p>
-          <a:p>
-            <a:r>
-              <a:rPr sz="1000" b="0">
-                <a:solidFill>
-                  <a:srgbClr val="58595B"/>
-                </a:solidFill>
-              </a:rPr>
-              <a:t/>
-            </a:r>
-          </a:p>
-          <a:p>
-            <a:r>
-              <a:rPr sz="1000" b="0">
-                <a:solidFill>
-                  <a:srgbClr val="58595B"/>
-                </a:solidFill>
-              </a:rPr>
-              <a:t>Quality rating by region:</a:t>
-            </a:r>
-          </a:p>
-          <a:p>
-            <a:r>
-              <a:rPr sz="1000" b="0">
-                <a:solidFill>
-                  <a:srgbClr val="58595B"/>
-                </a:solidFill>
-              </a:rPr>
-              <a:t>– North:   XX% Good/Excellent</a:t>
-            </a:r>
-          </a:p>
-          <a:p>
-            <a:r>
-              <a:rPr sz="1000" b="0">
-                <a:solidFill>
-                  <a:srgbClr val="58595B"/>
-                </a:solidFill>
-              </a:rPr>
-              <a:t>– South:   XX% Good/Excellent</a:t>
-            </a:r>
-          </a:p>
-          <a:p>
-            <a:r>
-              <a:rPr sz="1000" b="0">
-                <a:solidFill>
-                  <a:srgbClr val="58595B"/>
-                </a:solidFill>
-              </a:rPr>
-              <a:t>– East:    XX% Good/Excellent</a:t>
-            </a:r>
-          </a:p>
-          <a:p>
-            <a:r>
-              <a:rPr sz="1000" b="0">
-                <a:solidFill>
-                  <a:srgbClr val="58595B"/>
-                </a:solidFill>
-              </a:rPr>
-              <a:t>– West:    XX% Good/Excellent</a:t>
-            </a:r>
-          </a:p>
-        </p:txBody>
-      </p:sp>
-      <p:sp>
-        <p:nvSpPr>
-          <p:cNvPr id="13" name="TextBox 12"/>
-          <p:cNvSpPr txBox="1"/>
-          <p:nvPr/>
-        </p:nvSpPr>
-        <p:spPr>
-          <a:xfrm>
-            <a:off x="274320" y="6492240"/>
-            <a:ext cx="8595360" cy="256032"/>
-          </a:xfrm>
-          <a:prstGeom prst="rect">
-            <a:avLst/>
-          </a:prstGeom>
-          <a:noFill/>
-        </p:spPr>
-        <p:txBody>
-          <a:bodyPr wrap="square">
-            <a:spAutoFit/>
-          </a:bodyPr>
-          <a:lstStyle/>
-          <a:p>
             <a:pPr algn="l"/>
             <a:r>
               <a:rPr sz="800" b="0" i="1">
@@ -5278,7 +4560,7 @@
       </p:sp>
       <p:sp>
         <p:nvSpPr>
-          <p:cNvPr id="14" name="TextBox 13"/>
+          <p:cNvPr id="9" name="TextBox 8"/>
           <p:cNvSpPr txBox="1"/>
           <p:nvPr/>
         </p:nvSpPr>
@@ -5337,7 +4619,7 @@
         <p:spPr>
           <a:xfrm>
             <a:off x="0" y="0"/>
-            <a:ext cx="9144000" cy="457200"/>
+            <a:ext cx="9144000" cy="6858000"/>
           </a:xfrm>
           <a:prstGeom prst="rect">
             <a:avLst/>
@@ -5379,8 +4661,8 @@
         </p:nvSpPr>
         <p:spPr>
           <a:xfrm>
-            <a:off x="274320" y="457200"/>
-            <a:ext cx="8595360" cy="594360"/>
+            <a:off x="457200" y="2743200"/>
+            <a:ext cx="8229600" cy="1097280"/>
           </a:xfrm>
           <a:prstGeom prst="rect">
             <a:avLst/>
@@ -5395,413 +4677,12 @@
           <a:p>
             <a:pPr algn="l"/>
             <a:r>
-              <a:rPr sz="1800" b="1" i="0">
-                <a:solidFill>
-                  <a:srgbClr val="D94438"/>
+              <a:rPr sz="2800" b="1" i="0">
+                <a:solidFill>
+                  <a:srgbClr val="FFFFFF"/>
                 </a:solidFill>
               </a:rPr>
-              <a:t>Rating — customer service</a:t>
-            </a:r>
-          </a:p>
-        </p:txBody>
-      </p:sp>
-      <p:sp>
-        <p:nvSpPr>
-          <p:cNvPr id="4" name="TextBox 3"/>
-          <p:cNvSpPr txBox="1"/>
-          <p:nvPr/>
-        </p:nvSpPr>
-        <p:spPr>
-          <a:xfrm>
-            <a:off x="274320" y="1051560"/>
-            <a:ext cx="8595360" cy="347472"/>
-          </a:xfrm>
-          <a:prstGeom prst="rect">
-            <a:avLst/>
-          </a:prstGeom>
-          <a:noFill/>
-        </p:spPr>
-        <p:txBody>
-          <a:bodyPr wrap="square">
-            <a:spAutoFit/>
-          </a:bodyPr>
-          <a:lstStyle/>
-          <a:p>
-            <a:pPr algn="l"/>
-            <a:r>
-              <a:rPr sz="1100" b="0" i="1">
-                <a:solidFill>
-                  <a:srgbClr val="58595B"/>
-                </a:solidFill>
-              </a:rPr>
-              <a:t>Please rate your experience with customer service. (%)</a:t>
-            </a:r>
-          </a:p>
-        </p:txBody>
-      </p:sp>
-      <p:pic>
-        <p:nvPicPr>
-          <p:cNvPr id="5" name="Picture 4" descr="image.png"/>
-          <p:cNvPicPr>
-            <a:picLocks noChangeAspect="1"/>
-          </p:cNvPicPr>
-          <p:nvPr/>
-        </p:nvPicPr>
-        <p:blipFill>
-          <a:blip r:embed="rId2"/>
-          <a:stretch>
-            <a:fillRect/>
-          </a:stretch>
-        </p:blipFill>
-        <p:spPr>
-          <a:xfrm>
-            <a:off x="274320" y="1444752"/>
-            <a:ext cx="5029200" cy="4846320"/>
-          </a:xfrm>
-          <a:prstGeom prst="rect">
-            <a:avLst/>
-          </a:prstGeom>
-        </p:spPr>
-      </p:pic>
-      <p:sp>
-        <p:nvSpPr>
-          <p:cNvPr id="6" name="Oval 5"/>
-          <p:cNvSpPr/>
-          <p:nvPr/>
-        </p:nvSpPr>
-        <p:spPr>
-          <a:xfrm>
-            <a:off x="4381804" y="1842881"/>
-            <a:ext cx="1316736" cy="1316736"/>
-          </a:xfrm>
-          <a:prstGeom prst="ellipse">
-            <a:avLst/>
-          </a:prstGeom>
-          <a:solidFill>
-            <a:srgbClr val="00B5B8"/>
-          </a:solidFill>
-          <a:ln>
-            <a:noFill/>
-          </a:ln>
-        </p:spPr>
-        <p:style>
-          <a:lnRef idx="1">
-            <a:schemeClr val="accent1"/>
-          </a:lnRef>
-          <a:fillRef idx="3">
-            <a:schemeClr val="accent1"/>
-          </a:fillRef>
-          <a:effectRef idx="2">
-            <a:schemeClr val="accent1"/>
-          </a:effectRef>
-          <a:fontRef idx="minor">
-            <a:schemeClr val="lt1"/>
-          </a:fontRef>
-        </p:style>
-        <p:txBody>
-          <a:bodyPr rtlCol="0" anchor="ctr"/>
-          <a:lstStyle/>
-          <a:p>
-            <a:pPr algn="ctr"/>
-          </a:p>
-        </p:txBody>
-      </p:sp>
-      <p:sp>
-        <p:nvSpPr>
-          <p:cNvPr id="7" name="TextBox 6"/>
-          <p:cNvSpPr txBox="1"/>
-          <p:nvPr/>
-        </p:nvSpPr>
-        <p:spPr>
-          <a:xfrm>
-            <a:off x="4381804" y="1974555"/>
-            <a:ext cx="1316736" cy="684702"/>
-          </a:xfrm>
-          <a:prstGeom prst="rect">
-            <a:avLst/>
-          </a:prstGeom>
-          <a:noFill/>
-        </p:spPr>
-        <p:txBody>
-          <a:bodyPr wrap="square">
-            <a:spAutoFit/>
-          </a:bodyPr>
-          <a:lstStyle/>
-          <a:p>
-            <a:pPr algn="ctr"/>
-            <a:r>
-              <a:rPr sz="2000" b="1" i="0">
-                <a:solidFill>
-                  <a:srgbClr val="FFFFFF"/>
-                </a:solidFill>
-              </a:rPr>
-              <a:t>44%</a:t>
-            </a:r>
-          </a:p>
-        </p:txBody>
-      </p:sp>
-      <p:sp>
-        <p:nvSpPr>
-          <p:cNvPr id="8" name="TextBox 7"/>
-          <p:cNvSpPr txBox="1"/>
-          <p:nvPr/>
-        </p:nvSpPr>
-        <p:spPr>
-          <a:xfrm>
-            <a:off x="4381804" y="2606588"/>
-            <a:ext cx="1316736" cy="474024"/>
-          </a:xfrm>
-          <a:prstGeom prst="rect">
-            <a:avLst/>
-          </a:prstGeom>
-          <a:noFill/>
-        </p:spPr>
-        <p:txBody>
-          <a:bodyPr wrap="square">
-            <a:spAutoFit/>
-          </a:bodyPr>
-          <a:lstStyle/>
-          <a:p>
-            <a:pPr algn="ctr"/>
-            <a:r>
-              <a:rPr sz="1100" b="0" i="0">
-                <a:solidFill>
-                  <a:srgbClr val="FFFFFF"/>
-                </a:solidFill>
-              </a:rPr>
-              <a:t>Good / Excellent</a:t>
-            </a:r>
-          </a:p>
-        </p:txBody>
-      </p:sp>
-      <p:sp>
-        <p:nvSpPr>
-          <p:cNvPr id="9" name="Oval 8"/>
-          <p:cNvSpPr/>
-          <p:nvPr/>
-        </p:nvSpPr>
-        <p:spPr>
-          <a:xfrm>
-            <a:off x="4447641" y="4642043"/>
-            <a:ext cx="1185062" cy="1185062"/>
-          </a:xfrm>
-          <a:prstGeom prst="ellipse">
-            <a:avLst/>
-          </a:prstGeom>
-          <a:solidFill>
-            <a:srgbClr val="D94438"/>
-          </a:solidFill>
-          <a:ln>
-            <a:noFill/>
-          </a:ln>
-        </p:spPr>
-        <p:style>
-          <a:lnRef idx="1">
-            <a:schemeClr val="accent1"/>
-          </a:lnRef>
-          <a:fillRef idx="3">
-            <a:schemeClr val="accent1"/>
-          </a:fillRef>
-          <a:effectRef idx="2">
-            <a:schemeClr val="accent1"/>
-          </a:effectRef>
-          <a:fontRef idx="minor">
-            <a:schemeClr val="lt1"/>
-          </a:fontRef>
-        </p:style>
-        <p:txBody>
-          <a:bodyPr rtlCol="0" anchor="ctr"/>
-          <a:lstStyle/>
-          <a:p>
-            <a:pPr algn="ctr"/>
-          </a:p>
-        </p:txBody>
-      </p:sp>
-      <p:sp>
-        <p:nvSpPr>
-          <p:cNvPr id="10" name="TextBox 9"/>
-          <p:cNvSpPr txBox="1"/>
-          <p:nvPr/>
-        </p:nvSpPr>
-        <p:spPr>
-          <a:xfrm>
-            <a:off x="4447641" y="4760549"/>
-            <a:ext cx="1185062" cy="616232"/>
-          </a:xfrm>
-          <a:prstGeom prst="rect">
-            <a:avLst/>
-          </a:prstGeom>
-          <a:noFill/>
-        </p:spPr>
-        <p:txBody>
-          <a:bodyPr wrap="square">
-            <a:spAutoFit/>
-          </a:bodyPr>
-          <a:lstStyle/>
-          <a:p>
-            <a:pPr algn="ctr"/>
-            <a:r>
-              <a:rPr sz="2000" b="1" i="0">
-                <a:solidFill>
-                  <a:srgbClr val="FFFFFF"/>
-                </a:solidFill>
-              </a:rPr>
-              <a:t>34%</a:t>
-            </a:r>
-          </a:p>
-        </p:txBody>
-      </p:sp>
-      <p:sp>
-        <p:nvSpPr>
-          <p:cNvPr id="11" name="TextBox 10"/>
-          <p:cNvSpPr txBox="1"/>
-          <p:nvPr/>
-        </p:nvSpPr>
-        <p:spPr>
-          <a:xfrm>
-            <a:off x="4447641" y="5329379"/>
-            <a:ext cx="1185062" cy="426622"/>
-          </a:xfrm>
-          <a:prstGeom prst="rect">
-            <a:avLst/>
-          </a:prstGeom>
-          <a:noFill/>
-        </p:spPr>
-        <p:txBody>
-          <a:bodyPr wrap="square">
-            <a:spAutoFit/>
-          </a:bodyPr>
-          <a:lstStyle/>
-          <a:p>
-            <a:pPr algn="ctr"/>
-            <a:r>
-              <a:rPr sz="1100" b="0" i="0">
-                <a:solidFill>
-                  <a:srgbClr val="FFFFFF"/>
-                </a:solidFill>
-              </a:rPr>
-              <a:t>Poor / Very poor</a:t>
-            </a:r>
-          </a:p>
-        </p:txBody>
-      </p:sp>
-      <p:sp>
-        <p:nvSpPr>
-          <p:cNvPr id="12" name="TextBox 11"/>
-          <p:cNvSpPr txBox="1"/>
-          <p:nvPr/>
-        </p:nvSpPr>
-        <p:spPr>
-          <a:xfrm>
-            <a:off x="5532120" y="1444752"/>
-            <a:ext cx="3337560" cy="4846320"/>
-          </a:xfrm>
-          <a:prstGeom prst="rect">
-            <a:avLst/>
-          </a:prstGeom>
-          <a:noFill/>
-        </p:spPr>
-        <p:txBody>
-          <a:bodyPr wrap="square">
-            <a:spAutoFit/>
-          </a:bodyPr>
-          <a:lstStyle/>
-          <a:p>
-            <a:r>
-              <a:rPr sz="1000" b="0">
-                <a:solidFill>
-                  <a:srgbClr val="58595B"/>
-                </a:solidFill>
-              </a:rPr>
-              <a:t>Add subgroup commentary here.</a:t>
-            </a:r>
-          </a:p>
-          <a:p>
-            <a:r>
-              <a:rPr sz="1000" b="0">
-                <a:solidFill>
-                  <a:srgbClr val="58595B"/>
-                </a:solidFill>
-              </a:rPr>
-              <a:t>– Under 35:   XX% Good/Excellent</a:t>
-            </a:r>
-          </a:p>
-          <a:p>
-            <a:r>
-              <a:rPr sz="1000" b="0">
-                <a:solidFill>
-                  <a:srgbClr val="58595B"/>
-                </a:solidFill>
-              </a:rPr>
-              <a:t>– 35 and over: XX% Good/Excellent</a:t>
-            </a:r>
-          </a:p>
-        </p:txBody>
-      </p:sp>
-      <p:sp>
-        <p:nvSpPr>
-          <p:cNvPr id="13" name="TextBox 12"/>
-          <p:cNvSpPr txBox="1"/>
-          <p:nvPr/>
-        </p:nvSpPr>
-        <p:spPr>
-          <a:xfrm>
-            <a:off x="274320" y="6492240"/>
-            <a:ext cx="8595360" cy="256032"/>
-          </a:xfrm>
-          <a:prstGeom prst="rect">
-            <a:avLst/>
-          </a:prstGeom>
-          <a:noFill/>
-        </p:spPr>
-        <p:txBody>
-          <a:bodyPr wrap="square">
-            <a:spAutoFit/>
-          </a:bodyPr>
-          <a:lstStyle/>
-          <a:p>
-            <a:pPr algn="l"/>
-            <a:r>
-              <a:rPr sz="800" b="0" i="1">
-                <a:solidFill>
-                  <a:srgbClr val="58595B"/>
-                </a:solidFill>
-              </a:rPr>
-              <a:t>Base: all respondents (n=200)</a:t>
-            </a:r>
-          </a:p>
-        </p:txBody>
-      </p:sp>
-      <p:sp>
-        <p:nvSpPr>
-          <p:cNvPr id="14" name="TextBox 13"/>
-          <p:cNvSpPr txBox="1"/>
-          <p:nvPr/>
-        </p:nvSpPr>
-        <p:spPr>
-          <a:xfrm>
-            <a:off x="8503920" y="91440"/>
-            <a:ext cx="457200" cy="274320"/>
-          </a:xfrm>
-          <a:prstGeom prst="rect">
-            <a:avLst/>
-          </a:prstGeom>
-          <a:noFill/>
-        </p:spPr>
-        <p:txBody>
-          <a:bodyPr wrap="square">
-            <a:spAutoFit/>
-          </a:bodyPr>
-          <a:lstStyle/>
-          <a:p>
-            <a:pPr algn="r"/>
-            <a:r>
-              <a:rPr sz="800" b="0" i="0">
-                <a:solidFill>
-                  <a:srgbClr val="FFFFFF"/>
-                </a:solidFill>
-              </a:rPr>
-              <a:t>4</a:t>
+              <a:t>Demographics</a:t>
             </a:r>
           </a:p>
         </p:txBody>
@@ -5896,7 +4777,7 @@
                   <a:srgbClr val="D94438"/>
                 </a:solidFill>
               </a:rPr>
-              <a:t>Rating — value for money</a:t>
+              <a:t>Respondent region</a:t>
             </a:r>
           </a:p>
         </p:txBody>
@@ -5930,7 +4811,7 @@
                   <a:srgbClr val="58595B"/>
                 </a:solidFill>
               </a:rPr>
-              <a:t>Please rate value for money. (%)</a:t>
+              <a:t>Which region are you based in? (%)</a:t>
             </a:r>
           </a:p>
         </p:txBody>
@@ -5961,57 +4842,14 @@
       </p:pic>
       <p:sp>
         <p:nvSpPr>
-          <p:cNvPr id="6" name="Oval 5"/>
-          <p:cNvSpPr/>
-          <p:nvPr/>
-        </p:nvSpPr>
-        <p:spPr>
-          <a:xfrm>
-            <a:off x="4381804" y="1842881"/>
-            <a:ext cx="1316736" cy="1316736"/>
-          </a:xfrm>
-          <a:prstGeom prst="ellipse">
-            <a:avLst/>
-          </a:prstGeom>
-          <a:solidFill>
-            <a:srgbClr val="00B5B8"/>
-          </a:solidFill>
-          <a:ln>
-            <a:noFill/>
-          </a:ln>
-        </p:spPr>
-        <p:style>
-          <a:lnRef idx="1">
-            <a:schemeClr val="accent1"/>
-          </a:lnRef>
-          <a:fillRef idx="3">
-            <a:schemeClr val="accent1"/>
-          </a:fillRef>
-          <a:effectRef idx="2">
-            <a:schemeClr val="accent1"/>
-          </a:effectRef>
-          <a:fontRef idx="minor">
-            <a:schemeClr val="lt1"/>
-          </a:fontRef>
-        </p:style>
-        <p:txBody>
-          <a:bodyPr rtlCol="0" anchor="ctr"/>
-          <a:lstStyle/>
-          <a:p>
-            <a:pPr algn="ctr"/>
-          </a:p>
-        </p:txBody>
-      </p:sp>
-      <p:sp>
-        <p:nvSpPr>
-          <p:cNvPr id="7" name="TextBox 6"/>
+          <p:cNvPr id="6" name="TextBox 5"/>
           <p:cNvSpPr txBox="1"/>
           <p:nvPr/>
         </p:nvSpPr>
         <p:spPr>
           <a:xfrm>
-            <a:off x="4381804" y="1974555"/>
-            <a:ext cx="1316736" cy="684702"/>
+            <a:off x="5532120" y="1444752"/>
+            <a:ext cx="3337560" cy="4846320"/>
           </a:xfrm>
           <a:prstGeom prst="rect">
             <a:avLst/>
@@ -6024,28 +4862,37 @@
           </a:bodyPr>
           <a:lstStyle/>
           <a:p>
-            <a:pPr algn="ctr"/>
-            <a:r>
-              <a:rPr sz="2000" b="1" i="0">
-                <a:solidFill>
-                  <a:srgbClr val="FFFFFF"/>
+            <a:r>
+              <a:rPr sz="1000" b="0">
+                <a:solidFill>
+                  <a:srgbClr val="58595B"/>
                 </a:solidFill>
               </a:rPr>
-              <a:t>42%</a:t>
-            </a:r>
-          </a:p>
-        </p:txBody>
-      </p:sp>
-      <p:sp>
-        <p:nvSpPr>
-          <p:cNvPr id="8" name="TextBox 7"/>
+              <a:t>Sample is evenly spread across four regions.</a:t>
+            </a:r>
+          </a:p>
+          <a:p>
+            <a:r>
+              <a:rPr sz="1000" b="0">
+                <a:solidFill>
+                  <a:srgbClr val="58595B"/>
+                </a:solidFill>
+              </a:rPr>
+              <a:t>North, South, East and West each represent approximately 25%.</a:t>
+            </a:r>
+          </a:p>
+        </p:txBody>
+      </p:sp>
+      <p:sp>
+        <p:nvSpPr>
+          <p:cNvPr id="7" name="TextBox 6"/>
           <p:cNvSpPr txBox="1"/>
           <p:nvPr/>
         </p:nvSpPr>
         <p:spPr>
           <a:xfrm>
-            <a:off x="4381804" y="2606588"/>
-            <a:ext cx="1316736" cy="474024"/>
+            <a:off x="274320" y="6492240"/>
+            <a:ext cx="8595360" cy="256032"/>
           </a:xfrm>
           <a:prstGeom prst="rect">
             <a:avLst/>
@@ -6058,71 +4905,28 @@
           </a:bodyPr>
           <a:lstStyle/>
           <a:p>
-            <a:pPr algn="ctr"/>
-            <a:r>
-              <a:rPr sz="1100" b="0" i="0">
-                <a:solidFill>
-                  <a:srgbClr val="FFFFFF"/>
+            <a:pPr algn="l"/>
+            <a:r>
+              <a:rPr sz="800" b="0" i="1">
+                <a:solidFill>
+                  <a:srgbClr val="58595B"/>
                 </a:solidFill>
               </a:rPr>
-              <a:t>Good / Excellent</a:t>
-            </a:r>
-          </a:p>
-        </p:txBody>
-      </p:sp>
-      <p:sp>
-        <p:nvSpPr>
-          <p:cNvPr id="9" name="Oval 8"/>
-          <p:cNvSpPr/>
-          <p:nvPr/>
-        </p:nvSpPr>
-        <p:spPr>
-          <a:xfrm>
-            <a:off x="4447641" y="4642043"/>
-            <a:ext cx="1185062" cy="1185062"/>
-          </a:xfrm>
-          <a:prstGeom prst="ellipse">
-            <a:avLst/>
-          </a:prstGeom>
-          <a:solidFill>
-            <a:srgbClr val="D94438"/>
-          </a:solidFill>
-          <a:ln>
-            <a:noFill/>
-          </a:ln>
-        </p:spPr>
-        <p:style>
-          <a:lnRef idx="1">
-            <a:schemeClr val="accent1"/>
-          </a:lnRef>
-          <a:fillRef idx="3">
-            <a:schemeClr val="accent1"/>
-          </a:fillRef>
-          <a:effectRef idx="2">
-            <a:schemeClr val="accent1"/>
-          </a:effectRef>
-          <a:fontRef idx="minor">
-            <a:schemeClr val="lt1"/>
-          </a:fontRef>
-        </p:style>
-        <p:txBody>
-          <a:bodyPr rtlCol="0" anchor="ctr"/>
-          <a:lstStyle/>
-          <a:p>
-            <a:pPr algn="ctr"/>
-          </a:p>
-        </p:txBody>
-      </p:sp>
-      <p:sp>
-        <p:nvSpPr>
-          <p:cNvPr id="10" name="TextBox 9"/>
+              <a:t>Base: all respondents (n=200)</a:t>
+            </a:r>
+          </a:p>
+        </p:txBody>
+      </p:sp>
+      <p:sp>
+        <p:nvSpPr>
+          <p:cNvPr id="8" name="TextBox 7"/>
           <p:cNvSpPr txBox="1"/>
           <p:nvPr/>
         </p:nvSpPr>
         <p:spPr>
           <a:xfrm>
-            <a:off x="4447641" y="4760549"/>
-            <a:ext cx="1185062" cy="616232"/>
+            <a:off x="8503920" y="91440"/>
+            <a:ext cx="457200" cy="274320"/>
           </a:xfrm>
           <a:prstGeom prst="rect">
             <a:avLst/>
@@ -6135,169 +4939,14 @@
           </a:bodyPr>
           <a:lstStyle/>
           <a:p>
-            <a:pPr algn="ctr"/>
-            <a:r>
-              <a:rPr sz="2000" b="1" i="0">
+            <a:pPr algn="r"/>
+            <a:r>
+              <a:rPr sz="800" b="0" i="0">
                 <a:solidFill>
                   <a:srgbClr val="FFFFFF"/>
                 </a:solidFill>
               </a:rPr>
-              <a:t>39%</a:t>
-            </a:r>
-          </a:p>
-        </p:txBody>
-      </p:sp>
-      <p:sp>
-        <p:nvSpPr>
-          <p:cNvPr id="11" name="TextBox 10"/>
-          <p:cNvSpPr txBox="1"/>
-          <p:nvPr/>
-        </p:nvSpPr>
-        <p:spPr>
-          <a:xfrm>
-            <a:off x="4447641" y="5329379"/>
-            <a:ext cx="1185062" cy="426622"/>
-          </a:xfrm>
-          <a:prstGeom prst="rect">
-            <a:avLst/>
-          </a:prstGeom>
-          <a:noFill/>
-        </p:spPr>
-        <p:txBody>
-          <a:bodyPr wrap="square">
-            <a:spAutoFit/>
-          </a:bodyPr>
-          <a:lstStyle/>
-          <a:p>
-            <a:pPr algn="ctr"/>
-            <a:r>
-              <a:rPr sz="1100" b="0" i="0">
-                <a:solidFill>
-                  <a:srgbClr val="FFFFFF"/>
-                </a:solidFill>
-              </a:rPr>
-              <a:t>Poor / Very poor</a:t>
-            </a:r>
-          </a:p>
-        </p:txBody>
-      </p:sp>
-      <p:sp>
-        <p:nvSpPr>
-          <p:cNvPr id="12" name="TextBox 11"/>
-          <p:cNvSpPr txBox="1"/>
-          <p:nvPr/>
-        </p:nvSpPr>
-        <p:spPr>
-          <a:xfrm>
-            <a:off x="5532120" y="1444752"/>
-            <a:ext cx="3337560" cy="4846320"/>
-          </a:xfrm>
-          <a:prstGeom prst="rect">
-            <a:avLst/>
-          </a:prstGeom>
-          <a:noFill/>
-        </p:spPr>
-        <p:txBody>
-          <a:bodyPr wrap="square">
-            <a:spAutoFit/>
-          </a:bodyPr>
-          <a:lstStyle/>
-          <a:p>
-            <a:r>
-              <a:rPr sz="1000" b="0">
-                <a:solidFill>
-                  <a:srgbClr val="58595B"/>
-                </a:solidFill>
-              </a:rPr>
-              <a:t>Value-for-money ratings were consistent across regions.</a:t>
-            </a:r>
-          </a:p>
-          <a:p>
-            <a:r>
-              <a:rPr sz="1000" b="0">
-                <a:solidFill>
-                  <a:srgbClr val="58595B"/>
-                </a:solidFill>
-              </a:rPr>
-              <a:t/>
-            </a:r>
-          </a:p>
-          <a:p>
-            <a:r>
-              <a:rPr sz="1000" b="0">
-                <a:solidFill>
-                  <a:srgbClr val="58595B"/>
-                </a:solidFill>
-              </a:rPr>
-              <a:t>XX% of respondents rated value as Good or Excellent.</a:t>
-            </a:r>
-          </a:p>
-        </p:txBody>
-      </p:sp>
-      <p:sp>
-        <p:nvSpPr>
-          <p:cNvPr id="13" name="TextBox 12"/>
-          <p:cNvSpPr txBox="1"/>
-          <p:nvPr/>
-        </p:nvSpPr>
-        <p:spPr>
-          <a:xfrm>
-            <a:off x="274320" y="6492240"/>
-            <a:ext cx="8595360" cy="256032"/>
-          </a:xfrm>
-          <a:prstGeom prst="rect">
-            <a:avLst/>
-          </a:prstGeom>
-          <a:noFill/>
-        </p:spPr>
-        <p:txBody>
-          <a:bodyPr wrap="square">
-            <a:spAutoFit/>
-          </a:bodyPr>
-          <a:lstStyle/>
-          <a:p>
-            <a:pPr algn="l"/>
-            <a:r>
-              <a:rPr sz="800" b="0" i="1">
-                <a:solidFill>
-                  <a:srgbClr val="58595B"/>
-                </a:solidFill>
-              </a:rPr>
-              <a:t>Base: all respondents (n=200)</a:t>
-            </a:r>
-          </a:p>
-        </p:txBody>
-      </p:sp>
-      <p:sp>
-        <p:nvSpPr>
-          <p:cNvPr id="14" name="TextBox 13"/>
-          <p:cNvSpPr txBox="1"/>
-          <p:nvPr/>
-        </p:nvSpPr>
-        <p:spPr>
-          <a:xfrm>
-            <a:off x="8503920" y="91440"/>
-            <a:ext cx="457200" cy="274320"/>
-          </a:xfrm>
-          <a:prstGeom prst="rect">
-            <a:avLst/>
-          </a:prstGeom>
-          <a:noFill/>
-        </p:spPr>
-        <p:txBody>
-          <a:bodyPr wrap="square">
-            <a:spAutoFit/>
-          </a:bodyPr>
-          <a:lstStyle/>
-          <a:p>
-            <a:pPr algn="r"/>
-            <a:r>
-              <a:rPr sz="800" b="0" i="0">
-                <a:solidFill>
-                  <a:srgbClr val="FFFFFF"/>
-                </a:solidFill>
-              </a:rPr>
-              <a:t>5</a:t>
+              <a:t>4</a:t>
             </a:r>
           </a:p>
         </p:txBody>
@@ -6329,7 +4978,7 @@
         <p:spPr>
           <a:xfrm>
             <a:off x="0" y="0"/>
-            <a:ext cx="9144000" cy="6858000"/>
+            <a:ext cx="9144000" cy="457200"/>
           </a:xfrm>
           <a:prstGeom prst="rect">
             <a:avLst/>
@@ -6371,8 +5020,8 @@
         </p:nvSpPr>
         <p:spPr>
           <a:xfrm>
-            <a:off x="457200" y="2743200"/>
-            <a:ext cx="8229600" cy="1097280"/>
+            <a:off x="274320" y="457200"/>
+            <a:ext cx="8595360" cy="594360"/>
           </a:xfrm>
           <a:prstGeom prst="rect">
             <a:avLst/>
@@ -6387,12 +5036,171 @@
           <a:p>
             <a:pPr algn="l"/>
             <a:r>
-              <a:rPr sz="2800" b="1" i="0">
+              <a:rPr sz="1800" b="1" i="0">
+                <a:solidFill>
+                  <a:srgbClr val="D94438"/>
+                </a:solidFill>
+              </a:rPr>
+              <a:t>Respondent age group</a:t>
+            </a:r>
+          </a:p>
+        </p:txBody>
+      </p:sp>
+      <p:sp>
+        <p:nvSpPr>
+          <p:cNvPr id="4" name="TextBox 3"/>
+          <p:cNvSpPr txBox="1"/>
+          <p:nvPr/>
+        </p:nvSpPr>
+        <p:spPr>
+          <a:xfrm>
+            <a:off x="274320" y="1051560"/>
+            <a:ext cx="8595360" cy="347472"/>
+          </a:xfrm>
+          <a:prstGeom prst="rect">
+            <a:avLst/>
+          </a:prstGeom>
+          <a:noFill/>
+        </p:spPr>
+        <p:txBody>
+          <a:bodyPr wrap="square">
+            <a:spAutoFit/>
+          </a:bodyPr>
+          <a:lstStyle/>
+          <a:p>
+            <a:pPr algn="l"/>
+            <a:r>
+              <a:rPr sz="1100" b="0" i="1">
+                <a:solidFill>
+                  <a:srgbClr val="58595B"/>
+                </a:solidFill>
+              </a:rPr>
+              <a:t>What is your age group? (%)</a:t>
+            </a:r>
+          </a:p>
+        </p:txBody>
+      </p:sp>
+      <p:pic>
+        <p:nvPicPr>
+          <p:cNvPr id="5" name="Picture 4" descr="image.png"/>
+          <p:cNvPicPr>
+            <a:picLocks noChangeAspect="1"/>
+          </p:cNvPicPr>
+          <p:nvPr/>
+        </p:nvPicPr>
+        <p:blipFill>
+          <a:blip r:embed="rId2"/>
+          <a:stretch>
+            <a:fillRect/>
+          </a:stretch>
+        </p:blipFill>
+        <p:spPr>
+          <a:xfrm>
+            <a:off x="274320" y="1444752"/>
+            <a:ext cx="5029200" cy="4846320"/>
+          </a:xfrm>
+          <a:prstGeom prst="rect">
+            <a:avLst/>
+          </a:prstGeom>
+        </p:spPr>
+      </p:pic>
+      <p:sp>
+        <p:nvSpPr>
+          <p:cNvPr id="6" name="TextBox 5"/>
+          <p:cNvSpPr txBox="1"/>
+          <p:nvPr/>
+        </p:nvSpPr>
+        <p:spPr>
+          <a:xfrm>
+            <a:off x="5532120" y="1444752"/>
+            <a:ext cx="3337560" cy="4846320"/>
+          </a:xfrm>
+          <a:prstGeom prst="rect">
+            <a:avLst/>
+          </a:prstGeom>
+          <a:noFill/>
+        </p:spPr>
+        <p:txBody>
+          <a:bodyPr wrap="square">
+            <a:spAutoFit/>
+          </a:bodyPr>
+          <a:lstStyle/>
+          <a:p>
+            <a:r>
+              <a:rPr sz="1000" b="0">
+                <a:solidFill>
+                  <a:srgbClr val="58595B"/>
+                </a:solidFill>
+              </a:rPr>
+              <a:t>Each age band represents roughly 20% of the sample.</a:t>
+            </a:r>
+          </a:p>
+        </p:txBody>
+      </p:sp>
+      <p:sp>
+        <p:nvSpPr>
+          <p:cNvPr id="7" name="TextBox 6"/>
+          <p:cNvSpPr txBox="1"/>
+          <p:nvPr/>
+        </p:nvSpPr>
+        <p:spPr>
+          <a:xfrm>
+            <a:off x="274320" y="6492240"/>
+            <a:ext cx="8595360" cy="256032"/>
+          </a:xfrm>
+          <a:prstGeom prst="rect">
+            <a:avLst/>
+          </a:prstGeom>
+          <a:noFill/>
+        </p:spPr>
+        <p:txBody>
+          <a:bodyPr wrap="square">
+            <a:spAutoFit/>
+          </a:bodyPr>
+          <a:lstStyle/>
+          <a:p>
+            <a:pPr algn="l"/>
+            <a:r>
+              <a:rPr sz="800" b="0" i="1">
+                <a:solidFill>
+                  <a:srgbClr val="58595B"/>
+                </a:solidFill>
+              </a:rPr>
+              <a:t>Base: all respondents (n=200)</a:t>
+            </a:r>
+          </a:p>
+        </p:txBody>
+      </p:sp>
+      <p:sp>
+        <p:nvSpPr>
+          <p:cNvPr id="8" name="TextBox 7"/>
+          <p:cNvSpPr txBox="1"/>
+          <p:nvPr/>
+        </p:nvSpPr>
+        <p:spPr>
+          <a:xfrm>
+            <a:off x="8503920" y="91440"/>
+            <a:ext cx="457200" cy="274320"/>
+          </a:xfrm>
+          <a:prstGeom prst="rect">
+            <a:avLst/>
+          </a:prstGeom>
+          <a:noFill/>
+        </p:spPr>
+        <p:txBody>
+          <a:bodyPr wrap="square">
+            <a:spAutoFit/>
+          </a:bodyPr>
+          <a:lstStyle/>
+          <a:p>
+            <a:pPr algn="r"/>
+            <a:r>
+              <a:rPr sz="800" b="0" i="0">
                 <a:solidFill>
                   <a:srgbClr val="FFFFFF"/>
                 </a:solidFill>
               </a:rPr>
-              <a:t>Demographics</a:t>
+              <a:t>5</a:t>
             </a:r>
           </a:p>
         </p:txBody>

</xml_diff>

<commit_message>
Fix grid detection and apply template branding (DM Sans, theme colours)
Grid questions:
- auto_annotations now groups variables with a shared name prefix (e.g.
  stmt_) and identical frequency labels into a single grid slide instead
  of emitting individual chart slides for each battery member.
- stmt_community/govt_role/local_action correctly collapse to one grid.

Template branding:
- Replace full-width dark header stripe with a thin teal rule (3pt) to
  match the clean white design of the Blank.potm content slides.
- Set DM Sans on every text run to match the template font scheme.
- Update all brand colours to exactly match Blank.potm theme: TEAL_DARK
  #027F7C, TEAL_MID #00BDBB, TEAL_LIGHT #9BEFEF, CORAL #A32015,
  SALMON #FA8488, GRAY_DARK #44546A.
- Footer repositioned above master logo area; page number uses dark text
  so it is legible on white slide background.

https://claude.ai/code/session_01VCXkWfprNAwES9BXV74rqk
</commit_message>
<xml_diff>
--- a/sample_data/output.pptx
+++ b/sample_data/output.pptx
@@ -18,8 +18,6 @@
     <p:sldId id="260" r:id="rId32"/>
     <p:sldId id="261" r:id="rId33"/>
     <p:sldId id="262" r:id="rId34"/>
-    <p:sldId id="263" r:id="rId35"/>
-    <p:sldId id="264" r:id="rId36"/>
   </p:sldIdLst>
   <p:sldSz cx="12192000" cy="6858000"/>
   <p:notesSz cx="6858000" cy="9144000"/>
@@ -6808,7 +6806,7 @@
             <a:avLst/>
           </a:prstGeom>
           <a:solidFill>
-            <a:srgbClr val="1B5566"/>
+            <a:srgbClr val="027F7C"/>
           </a:solidFill>
           <a:ln>
             <a:noFill/>
@@ -6864,6 +6862,7 @@
                 <a:solidFill>
                   <a:srgbClr val="FFFFFF"/>
                 </a:solidFill>
+                <a:latin typeface="DM Sans"/>
               </a:rPr>
               <a:t>Sample Survey</a:t>
             </a:r>
@@ -6896,8 +6895,9 @@
             <a:r>
               <a:rPr sz="1800" b="0" i="0">
                 <a:solidFill>
-                  <a:srgbClr val="7DD8D8"/>
-                </a:solidFill>
+                  <a:srgbClr val="9BEFEF"/>
+                </a:solidFill>
+                <a:latin typeface="DM Sans"/>
               </a:rPr>
               <a:t>March 2026</a:t>
             </a:r>
@@ -6930,8 +6930,9 @@
             <a:r>
               <a:rPr sz="1000" b="0" i="0">
                 <a:solidFill>
-                  <a:srgbClr val="7DD8D8"/>
-                </a:solidFill>
+                  <a:srgbClr val="9BEFEF"/>
+                </a:solidFill>
+                <a:latin typeface="DM Sans"/>
               </a:rPr>
               <a:t>n=200 respondents</a:t>
             </a:r>
@@ -6964,14 +6965,14 @@
         </p:nvSpPr>
         <p:spPr>
           <a:xfrm>
-            <a:off x="0" y="0"/>
-            <a:ext cx="12188952" cy="457200"/>
+            <a:off x="310896" y="1005840"/>
+            <a:ext cx="11878056" cy="27432"/>
           </a:xfrm>
           <a:prstGeom prst="rect">
             <a:avLst/>
           </a:prstGeom>
           <a:solidFill>
-            <a:srgbClr val="1B5566"/>
+            <a:srgbClr val="027F7C"/>
           </a:solidFill>
           <a:ln>
             <a:noFill/>
@@ -7007,8 +7008,8 @@
         </p:nvSpPr>
         <p:spPr>
           <a:xfrm>
-            <a:off x="365760" y="457200"/>
-            <a:ext cx="11457432" cy="594360"/>
+            <a:off x="310896" y="201168"/>
+            <a:ext cx="11567160" cy="749808"/>
           </a:xfrm>
           <a:prstGeom prst="rect">
             <a:avLst/>
@@ -7025,8 +7026,9 @@
             <a:r>
               <a:rPr sz="1800" b="1" i="0">
                 <a:solidFill>
-                  <a:srgbClr val="D94438"/>
-                </a:solidFill>
+                  <a:srgbClr val="A32015"/>
+                </a:solidFill>
+                <a:latin typeface="DM Sans"/>
               </a:rPr>
               <a:t>Respondent ID</a:t>
             </a:r>
@@ -7041,8 +7043,8 @@
         </p:nvSpPr>
         <p:spPr>
           <a:xfrm>
-            <a:off x="365760" y="1051560"/>
-            <a:ext cx="11457432" cy="347472"/>
+            <a:off x="310896" y="1042415"/>
+            <a:ext cx="8229600" cy="347472"/>
           </a:xfrm>
           <a:prstGeom prst="rect">
             <a:avLst/>
@@ -7059,8 +7061,9 @@
             <a:r>
               <a:rPr sz="1100" b="0" i="1">
                 <a:solidFill>
-                  <a:srgbClr val="58595B"/>
-                </a:solidFill>
+                  <a:srgbClr val="44546A"/>
+                </a:solidFill>
+                <a:latin typeface="DM Sans"/>
               </a:rPr>
               <a:t>[respondent_id] — numeric summary</a:t>
             </a:r>
@@ -7075,7 +7078,7 @@
         </p:nvSpPr>
         <p:spPr>
           <a:xfrm>
-            <a:off x="7434072" y="1417320"/>
+            <a:off x="7434072" y="1463040"/>
             <a:ext cx="4389119" cy="4251960"/>
           </a:xfrm>
           <a:prstGeom prst="rect">
@@ -7092,8 +7095,9 @@
             <a:r>
               <a:rPr sz="1000" b="0">
                 <a:solidFill>
-                  <a:srgbClr val="58595B"/>
-                </a:solidFill>
+                  <a:srgbClr val="44546A"/>
+                </a:solidFill>
+                <a:latin typeface="DM Sans"/>
               </a:rPr>
               <a:t>Add commentary here.</a:t>
             </a:r>
@@ -7108,8 +7112,8 @@
         </p:nvSpPr>
         <p:spPr>
           <a:xfrm>
-            <a:off x="365760" y="6492240"/>
-            <a:ext cx="11457432" cy="256032"/>
+            <a:off x="1097280" y="6236208"/>
+            <a:ext cx="10058400" cy="256032"/>
           </a:xfrm>
           <a:prstGeom prst="rect">
             <a:avLst/>
@@ -7126,8 +7130,9 @@
             <a:r>
               <a:rPr sz="800" b="0" i="1">
                 <a:solidFill>
-                  <a:srgbClr val="58595B"/>
-                </a:solidFill>
+                  <a:srgbClr val="44546A"/>
+                </a:solidFill>
+                <a:latin typeface="DM Sans"/>
               </a:rPr>
               <a:t>Base: all respondents (n=200)</a:t>
             </a:r>
@@ -7142,7 +7147,7 @@
         </p:nvSpPr>
         <p:spPr>
           <a:xfrm>
-            <a:off x="11338560" y="91440"/>
+            <a:off x="11338560" y="6217920"/>
             <a:ext cx="612648" cy="274320"/>
           </a:xfrm>
           <a:prstGeom prst="rect">
@@ -7160,8 +7165,9 @@
             <a:r>
               <a:rPr sz="800" b="0" i="0">
                 <a:solidFill>
-                  <a:srgbClr val="FFFFFF"/>
-                </a:solidFill>
+                  <a:srgbClr val="44546A"/>
+                </a:solidFill>
+                <a:latin typeface="DM Sans"/>
               </a:rPr>
               <a:t>1</a:t>
             </a:r>
@@ -7194,14 +7200,14 @@
         </p:nvSpPr>
         <p:spPr>
           <a:xfrm>
-            <a:off x="0" y="0"/>
-            <a:ext cx="12188952" cy="457200"/>
+            <a:off x="310896" y="1005840"/>
+            <a:ext cx="11878056" cy="27432"/>
           </a:xfrm>
           <a:prstGeom prst="rect">
             <a:avLst/>
           </a:prstGeom>
           <a:solidFill>
-            <a:srgbClr val="1B5566"/>
+            <a:srgbClr val="027F7C"/>
           </a:solidFill>
           <a:ln>
             <a:noFill/>
@@ -7237,8 +7243,8 @@
         </p:nvSpPr>
         <p:spPr>
           <a:xfrm>
-            <a:off x="365760" y="457200"/>
-            <a:ext cx="11457432" cy="594360"/>
+            <a:off x="310896" y="201168"/>
+            <a:ext cx="11567160" cy="749808"/>
           </a:xfrm>
           <a:prstGeom prst="rect">
             <a:avLst/>
@@ -7255,8 +7261,9 @@
             <a:r>
               <a:rPr sz="1800" b="1" i="0">
                 <a:solidFill>
-                  <a:srgbClr val="D94438"/>
-                </a:solidFill>
+                  <a:srgbClr val="A32015"/>
+                </a:solidFill>
+                <a:latin typeface="DM Sans"/>
               </a:rPr>
               <a:t>How concerned are you about this issue in your community?</a:t>
             </a:r>
@@ -7271,8 +7278,8 @@
         </p:nvSpPr>
         <p:spPr>
           <a:xfrm>
-            <a:off x="365760" y="1051560"/>
-            <a:ext cx="11457432" cy="347472"/>
+            <a:off x="310896" y="1042415"/>
+            <a:ext cx="8229600" cy="347472"/>
           </a:xfrm>
           <a:prstGeom prst="rect">
             <a:avLst/>
@@ -7289,8 +7296,9 @@
             <a:r>
               <a:rPr sz="1100" b="0" i="1">
                 <a:solidFill>
-                  <a:srgbClr val="58595B"/>
-                </a:solidFill>
+                  <a:srgbClr val="44546A"/>
+                </a:solidFill>
+                <a:latin typeface="DM Sans"/>
               </a:rPr>
               <a:t>[issue_concern] (%)</a:t>
             </a:r>
@@ -7313,7 +7321,7 @@
         </p:blipFill>
         <p:spPr>
           <a:xfrm>
-            <a:off x="365760" y="1417320"/>
+            <a:off x="310896" y="1463040"/>
             <a:ext cx="6702552" cy="1645920"/>
           </a:xfrm>
           <a:prstGeom prst="rect">
@@ -7329,7 +7337,7 @@
         </p:nvSpPr>
         <p:spPr>
           <a:xfrm>
-            <a:off x="7434072" y="1417320"/>
+            <a:off x="7434072" y="1463040"/>
             <a:ext cx="4389119" cy="1645920"/>
           </a:xfrm>
           <a:prstGeom prst="rect">
@@ -7346,8 +7354,9 @@
             <a:r>
               <a:rPr sz="1000" b="0">
                 <a:solidFill>
-                  <a:srgbClr val="58595B"/>
-                </a:solidFill>
+                  <a:srgbClr val="44546A"/>
+                </a:solidFill>
+                <a:latin typeface="DM Sans"/>
               </a:rPr>
               <a:t>Add subgroup breakdowns here, e.g.:</a:t>
             </a:r>
@@ -7356,8 +7365,9 @@
             <a:r>
               <a:rPr sz="1000" b="0">
                 <a:solidFill>
-                  <a:srgbClr val="58595B"/>
-                </a:solidFill>
+                  <a:srgbClr val="44546A"/>
+                </a:solidFill>
+                <a:latin typeface="DM Sans"/>
               </a:rPr>
               <a:t>– Under 30:  XX%</a:t>
             </a:r>
@@ -7366,8 +7376,9 @@
             <a:r>
               <a:rPr sz="1000" b="0">
                 <a:solidFill>
-                  <a:srgbClr val="58595B"/>
-                </a:solidFill>
+                  <a:srgbClr val="44546A"/>
+                </a:solidFill>
+                <a:latin typeface="DM Sans"/>
               </a:rPr>
               <a:t>– 30–44:     XX%</a:t>
             </a:r>
@@ -7382,8 +7393,8 @@
         </p:nvSpPr>
         <p:spPr>
           <a:xfrm>
-            <a:off x="365760" y="6492240"/>
-            <a:ext cx="11457432" cy="256032"/>
+            <a:off x="1097280" y="6236208"/>
+            <a:ext cx="10058400" cy="256032"/>
           </a:xfrm>
           <a:prstGeom prst="rect">
             <a:avLst/>
@@ -7400,8 +7411,9 @@
             <a:r>
               <a:rPr sz="800" b="0" i="1">
                 <a:solidFill>
-                  <a:srgbClr val="58595B"/>
-                </a:solidFill>
+                  <a:srgbClr val="44546A"/>
+                </a:solidFill>
+                <a:latin typeface="DM Sans"/>
               </a:rPr>
               <a:t>Base: all respondents (n=200)</a:t>
             </a:r>
@@ -7416,7 +7428,7 @@
         </p:nvSpPr>
         <p:spPr>
           <a:xfrm>
-            <a:off x="11338560" y="91440"/>
+            <a:off x="11338560" y="6217920"/>
             <a:ext cx="612648" cy="274320"/>
           </a:xfrm>
           <a:prstGeom prst="rect">
@@ -7434,8 +7446,9 @@
             <a:r>
               <a:rPr sz="800" b="0" i="0">
                 <a:solidFill>
-                  <a:srgbClr val="FFFFFF"/>
-                </a:solidFill>
+                  <a:srgbClr val="44546A"/>
+                </a:solidFill>
+                <a:latin typeface="DM Sans"/>
               </a:rPr>
               <a:t>2</a:t>
             </a:r>
@@ -7468,14 +7481,14 @@
         </p:nvSpPr>
         <p:spPr>
           <a:xfrm>
-            <a:off x="0" y="0"/>
-            <a:ext cx="12188952" cy="457200"/>
+            <a:off x="310896" y="1005840"/>
+            <a:ext cx="11878056" cy="27432"/>
           </a:xfrm>
           <a:prstGeom prst="rect">
             <a:avLst/>
           </a:prstGeom>
           <a:solidFill>
-            <a:srgbClr val="1B5566"/>
+            <a:srgbClr val="027F7C"/>
           </a:solidFill>
           <a:ln>
             <a:noFill/>
@@ -7511,8 +7524,8 @@
         </p:nvSpPr>
         <p:spPr>
           <a:xfrm>
-            <a:off x="365760" y="457200"/>
-            <a:ext cx="11457432" cy="594360"/>
+            <a:off x="310896" y="201168"/>
+            <a:ext cx="11567160" cy="749808"/>
           </a:xfrm>
           <a:prstGeom prst="rect">
             <a:avLst/>
@@ -7529,8 +7542,9 @@
             <a:r>
               <a:rPr sz="1800" b="1" i="0">
                 <a:solidFill>
-                  <a:srgbClr val="D94438"/>
-                </a:solidFill>
+                  <a:srgbClr val="A32015"/>
+                </a:solidFill>
+                <a:latin typeface="DM Sans"/>
               </a:rPr>
               <a:t>The government is handling this issue effectively.</a:t>
             </a:r>
@@ -7545,8 +7559,8 @@
         </p:nvSpPr>
         <p:spPr>
           <a:xfrm>
-            <a:off x="365760" y="1051560"/>
-            <a:ext cx="11457432" cy="347472"/>
+            <a:off x="310896" y="1042415"/>
+            <a:ext cx="8229600" cy="347472"/>
           </a:xfrm>
           <a:prstGeom prst="rect">
             <a:avLst/>
@@ -7563,8 +7577,9 @@
             <a:r>
               <a:rPr sz="1100" b="0" i="1">
                 <a:solidFill>
-                  <a:srgbClr val="58595B"/>
-                </a:solidFill>
+                  <a:srgbClr val="44546A"/>
+                </a:solidFill>
+                <a:latin typeface="DM Sans"/>
               </a:rPr>
               <a:t>[govt_handling] (%)</a:t>
             </a:r>
@@ -7587,7 +7602,7 @@
         </p:blipFill>
         <p:spPr>
           <a:xfrm>
-            <a:off x="365760" y="1417320"/>
+            <a:off x="310896" y="1463040"/>
             <a:ext cx="6702552" cy="1645920"/>
           </a:xfrm>
           <a:prstGeom prst="rect">
@@ -7603,7 +7618,7 @@
         </p:nvSpPr>
         <p:spPr>
           <a:xfrm>
-            <a:off x="7434072" y="1417320"/>
+            <a:off x="7434072" y="1463040"/>
             <a:ext cx="4389119" cy="1645920"/>
           </a:xfrm>
           <a:prstGeom prst="rect">
@@ -7620,8 +7635,9 @@
             <a:r>
               <a:rPr sz="1000" b="0">
                 <a:solidFill>
-                  <a:srgbClr val="58595B"/>
-                </a:solidFill>
+                  <a:srgbClr val="44546A"/>
+                </a:solidFill>
+                <a:latin typeface="DM Sans"/>
               </a:rPr>
               <a:t>Add subgroup breakdowns here, e.g.:</a:t>
             </a:r>
@@ -7630,8 +7646,9 @@
             <a:r>
               <a:rPr sz="1000" b="0">
                 <a:solidFill>
-                  <a:srgbClr val="58595B"/>
-                </a:solidFill>
+                  <a:srgbClr val="44546A"/>
+                </a:solidFill>
+                <a:latin typeface="DM Sans"/>
               </a:rPr>
               <a:t>– Under 30:  XX%</a:t>
             </a:r>
@@ -7640,8 +7657,9 @@
             <a:r>
               <a:rPr sz="1000" b="0">
                 <a:solidFill>
-                  <a:srgbClr val="58595B"/>
-                </a:solidFill>
+                  <a:srgbClr val="44546A"/>
+                </a:solidFill>
+                <a:latin typeface="DM Sans"/>
               </a:rPr>
               <a:t>– 30–44:     XX%</a:t>
             </a:r>
@@ -7656,8 +7674,8 @@
         </p:nvSpPr>
         <p:spPr>
           <a:xfrm>
-            <a:off x="365760" y="6492240"/>
-            <a:ext cx="11457432" cy="256032"/>
+            <a:off x="1097280" y="6236208"/>
+            <a:ext cx="10058400" cy="256032"/>
           </a:xfrm>
           <a:prstGeom prst="rect">
             <a:avLst/>
@@ -7674,8 +7692,9 @@
             <a:r>
               <a:rPr sz="800" b="0" i="1">
                 <a:solidFill>
-                  <a:srgbClr val="58595B"/>
-                </a:solidFill>
+                  <a:srgbClr val="44546A"/>
+                </a:solidFill>
+                <a:latin typeface="DM Sans"/>
               </a:rPr>
               <a:t>Base: all respondents (n=200)</a:t>
             </a:r>
@@ -7690,7 +7709,7 @@
         </p:nvSpPr>
         <p:spPr>
           <a:xfrm>
-            <a:off x="11338560" y="91440"/>
+            <a:off x="11338560" y="6217920"/>
             <a:ext cx="612648" cy="274320"/>
           </a:xfrm>
           <a:prstGeom prst="rect">
@@ -7708,8 +7727,9 @@
             <a:r>
               <a:rPr sz="800" b="0" i="0">
                 <a:solidFill>
-                  <a:srgbClr val="FFFFFF"/>
-                </a:solidFill>
+                  <a:srgbClr val="44546A"/>
+                </a:solidFill>
+                <a:latin typeface="DM Sans"/>
               </a:rPr>
               <a:t>3</a:t>
             </a:r>
@@ -7742,14 +7762,14 @@
         </p:nvSpPr>
         <p:spPr>
           <a:xfrm>
-            <a:off x="0" y="0"/>
-            <a:ext cx="12188952" cy="457200"/>
+            <a:off x="310896" y="1005840"/>
+            <a:ext cx="11878056" cy="27432"/>
           </a:xfrm>
           <a:prstGeom prst="rect">
             <a:avLst/>
           </a:prstGeom>
           <a:solidFill>
-            <a:srgbClr val="1B5566"/>
+            <a:srgbClr val="027F7C"/>
           </a:solidFill>
           <a:ln>
             <a:noFill/>
@@ -7785,8 +7805,8 @@
         </p:nvSpPr>
         <p:spPr>
           <a:xfrm>
-            <a:off x="365760" y="457200"/>
-            <a:ext cx="11457432" cy="594360"/>
+            <a:off x="310896" y="201168"/>
+            <a:ext cx="11567160" cy="749808"/>
           </a:xfrm>
           <a:prstGeom prst="rect">
             <a:avLst/>
@@ -7803,10 +7823,11 @@
             <a:r>
               <a:rPr sz="1800" b="1" i="0">
                 <a:solidFill>
-                  <a:srgbClr val="D94438"/>
-                </a:solidFill>
+                  <a:srgbClr val="A32015"/>
+                </a:solidFill>
+                <a:latin typeface="DM Sans"/>
               </a:rPr>
-              <a:t>This issue has a direct impact on everyday people in our community.</a:t>
+              <a:t>Stmt</a:t>
             </a:r>
           </a:p>
         </p:txBody>
@@ -7819,8 +7840,8 @@
         </p:nvSpPr>
         <p:spPr>
           <a:xfrm>
-            <a:off x="365760" y="1051560"/>
-            <a:ext cx="11457432" cy="347472"/>
+            <a:off x="310896" y="1042415"/>
+            <a:ext cx="8229600" cy="347472"/>
           </a:xfrm>
           <a:prstGeom prst="rect">
             <a:avLst/>
@@ -7837,10 +7858,11 @@
             <a:r>
               <a:rPr sz="1100" b="0" i="1">
                 <a:solidFill>
-                  <a:srgbClr val="58595B"/>
-                </a:solidFill>
+                  <a:srgbClr val="44546A"/>
+                </a:solidFill>
+                <a:latin typeface="DM Sans"/>
               </a:rPr>
-              <a:t>[stmt_community] (%)</a:t>
+              <a:t>(%)</a:t>
             </a:r>
           </a:p>
         </p:txBody>
@@ -7861,8 +7883,8 @@
         </p:blipFill>
         <p:spPr>
           <a:xfrm>
-            <a:off x="365760" y="1417320"/>
-            <a:ext cx="6702552" cy="1645920"/>
+            <a:off x="310896" y="1463040"/>
+            <a:ext cx="6099048" cy="2880360"/>
           </a:xfrm>
           <a:prstGeom prst="rect">
             <a:avLst/>
@@ -7871,14 +7893,57 @@
       </p:pic>
       <p:sp>
         <p:nvSpPr>
-          <p:cNvPr id="6" name="TextBox 5"/>
+          <p:cNvPr id="6" name="Oval 5"/>
+          <p:cNvSpPr/>
+          <p:nvPr/>
+        </p:nvSpPr>
+        <p:spPr>
+          <a:xfrm>
+            <a:off x="5023850" y="1686747"/>
+            <a:ext cx="637519" cy="637519"/>
+          </a:xfrm>
+          <a:prstGeom prst="ellipse">
+            <a:avLst/>
+          </a:prstGeom>
+          <a:solidFill>
+            <a:srgbClr val="00BDBB"/>
+          </a:solidFill>
+          <a:ln>
+            <a:noFill/>
+          </a:ln>
+        </p:spPr>
+        <p:style>
+          <a:lnRef idx="1">
+            <a:schemeClr val="accent1"/>
+          </a:lnRef>
+          <a:fillRef idx="3">
+            <a:schemeClr val="accent1"/>
+          </a:fillRef>
+          <a:effectRef idx="2">
+            <a:schemeClr val="accent1"/>
+          </a:effectRef>
+          <a:fontRef idx="minor">
+            <a:schemeClr val="lt1"/>
+          </a:fontRef>
+        </p:style>
+        <p:txBody>
+          <a:bodyPr rtlCol="0" anchor="ctr"/>
+          <a:lstStyle/>
+          <a:p>
+            <a:pPr algn="ctr"/>
+          </a:p>
+        </p:txBody>
+      </p:sp>
+      <p:sp>
+        <p:nvSpPr>
+          <p:cNvPr id="7" name="TextBox 6"/>
           <p:cNvSpPr txBox="1"/>
           <p:nvPr/>
         </p:nvSpPr>
         <p:spPr>
           <a:xfrm>
-            <a:off x="7434072" y="1417320"/>
-            <a:ext cx="4389119" cy="1645920"/>
+            <a:off x="5023850" y="1827002"/>
+            <a:ext cx="637519" cy="357011"/>
           </a:xfrm>
           <a:prstGeom prst="rect">
             <a:avLst/>
@@ -7891,47 +7956,72 @@
           </a:bodyPr>
           <a:lstStyle/>
           <a:p>
-            <a:r>
-              <a:rPr sz="1000" b="0">
-                <a:solidFill>
-                  <a:srgbClr val="58595B"/>
-                </a:solidFill>
+            <a:pPr algn="ctr"/>
+            <a:r>
+              <a:rPr sz="1800" b="1" i="0">
+                <a:solidFill>
+                  <a:srgbClr val="FFFFFF"/>
+                </a:solidFill>
+                <a:latin typeface="DM Sans"/>
               </a:rPr>
-              <a:t>Add subgroup breakdowns here, e.g.:</a:t>
-            </a:r>
-          </a:p>
-          <a:p>
-            <a:r>
-              <a:rPr sz="1000" b="0">
-                <a:solidFill>
-                  <a:srgbClr val="58595B"/>
-                </a:solidFill>
-              </a:rPr>
-              <a:t>– Under 30:  XX%</a:t>
-            </a:r>
-          </a:p>
-          <a:p>
-            <a:r>
-              <a:rPr sz="1000" b="0">
-                <a:solidFill>
-                  <a:srgbClr val="58595B"/>
-                </a:solidFill>
-              </a:rPr>
-              <a:t>– 30–44:     XX%</a:t>
-            </a:r>
-          </a:p>
-        </p:txBody>
-      </p:sp>
-      <p:sp>
-        <p:nvSpPr>
-          <p:cNvPr id="7" name="TextBox 6"/>
+              <a:t>85%</a:t>
+            </a:r>
+          </a:p>
+        </p:txBody>
+      </p:sp>
+      <p:sp>
+        <p:nvSpPr>
+          <p:cNvPr id="8" name="Oval 7"/>
+          <p:cNvSpPr/>
+          <p:nvPr/>
+        </p:nvSpPr>
+        <p:spPr>
+          <a:xfrm>
+            <a:off x="4840879" y="2483647"/>
+            <a:ext cx="637519" cy="637519"/>
+          </a:xfrm>
+          <a:prstGeom prst="ellipse">
+            <a:avLst/>
+          </a:prstGeom>
+          <a:solidFill>
+            <a:srgbClr val="00BDBB"/>
+          </a:solidFill>
+          <a:ln>
+            <a:noFill/>
+          </a:ln>
+        </p:spPr>
+        <p:style>
+          <a:lnRef idx="1">
+            <a:schemeClr val="accent1"/>
+          </a:lnRef>
+          <a:fillRef idx="3">
+            <a:schemeClr val="accent1"/>
+          </a:fillRef>
+          <a:effectRef idx="2">
+            <a:schemeClr val="accent1"/>
+          </a:effectRef>
+          <a:fontRef idx="minor">
+            <a:schemeClr val="lt1"/>
+          </a:fontRef>
+        </p:style>
+        <p:txBody>
+          <a:bodyPr rtlCol="0" anchor="ctr"/>
+          <a:lstStyle/>
+          <a:p>
+            <a:pPr algn="ctr"/>
+          </a:p>
+        </p:txBody>
+      </p:sp>
+      <p:sp>
+        <p:nvSpPr>
+          <p:cNvPr id="9" name="TextBox 8"/>
           <p:cNvSpPr txBox="1"/>
           <p:nvPr/>
         </p:nvSpPr>
         <p:spPr>
           <a:xfrm>
-            <a:off x="365760" y="6492240"/>
-            <a:ext cx="11457432" cy="256032"/>
+            <a:off x="4840879" y="2623901"/>
+            <a:ext cx="637519" cy="357011"/>
           </a:xfrm>
           <a:prstGeom prst="rect">
             <a:avLst/>
@@ -7944,28 +8034,72 @@
           </a:bodyPr>
           <a:lstStyle/>
           <a:p>
-            <a:pPr algn="l"/>
-            <a:r>
-              <a:rPr sz="800" b="0" i="1">
-                <a:solidFill>
-                  <a:srgbClr val="58595B"/>
-                </a:solidFill>
+            <a:pPr algn="ctr"/>
+            <a:r>
+              <a:rPr sz="1800" b="1" i="0">
+                <a:solidFill>
+                  <a:srgbClr val="FFFFFF"/>
+                </a:solidFill>
+                <a:latin typeface="DM Sans"/>
               </a:rPr>
-              <a:t>Base: all respondents (n=200)</a:t>
-            </a:r>
-          </a:p>
-        </p:txBody>
-      </p:sp>
-      <p:sp>
-        <p:nvSpPr>
-          <p:cNvPr id="8" name="TextBox 7"/>
+              <a:t>79%</a:t>
+            </a:r>
+          </a:p>
+        </p:txBody>
+      </p:sp>
+      <p:sp>
+        <p:nvSpPr>
+          <p:cNvPr id="10" name="Oval 9"/>
+          <p:cNvSpPr/>
+          <p:nvPr/>
+        </p:nvSpPr>
+        <p:spPr>
+          <a:xfrm>
+            <a:off x="5023850" y="3280547"/>
+            <a:ext cx="637519" cy="637519"/>
+          </a:xfrm>
+          <a:prstGeom prst="ellipse">
+            <a:avLst/>
+          </a:prstGeom>
+          <a:solidFill>
+            <a:srgbClr val="00BDBB"/>
+          </a:solidFill>
+          <a:ln>
+            <a:noFill/>
+          </a:ln>
+        </p:spPr>
+        <p:style>
+          <a:lnRef idx="1">
+            <a:schemeClr val="accent1"/>
+          </a:lnRef>
+          <a:fillRef idx="3">
+            <a:schemeClr val="accent1"/>
+          </a:fillRef>
+          <a:effectRef idx="2">
+            <a:schemeClr val="accent1"/>
+          </a:effectRef>
+          <a:fontRef idx="minor">
+            <a:schemeClr val="lt1"/>
+          </a:fontRef>
+        </p:style>
+        <p:txBody>
+          <a:bodyPr rtlCol="0" anchor="ctr"/>
+          <a:lstStyle/>
+          <a:p>
+            <a:pPr algn="ctr"/>
+          </a:p>
+        </p:txBody>
+      </p:sp>
+      <p:sp>
+        <p:nvSpPr>
+          <p:cNvPr id="11" name="TextBox 10"/>
           <p:cNvSpPr txBox="1"/>
           <p:nvPr/>
         </p:nvSpPr>
         <p:spPr>
           <a:xfrm>
-            <a:off x="11338560" y="91440"/>
-            <a:ext cx="612648" cy="274320"/>
+            <a:off x="5023850" y="3420801"/>
+            <a:ext cx="637519" cy="357011"/>
           </a:xfrm>
           <a:prstGeom prst="rect">
             <a:avLst/>
@@ -7978,12 +8112,141 @@
           </a:bodyPr>
           <a:lstStyle/>
           <a:p>
+            <a:pPr algn="ctr"/>
+            <a:r>
+              <a:rPr sz="1800" b="1" i="0">
+                <a:solidFill>
+                  <a:srgbClr val="FFFFFF"/>
+                </a:solidFill>
+                <a:latin typeface="DM Sans"/>
+              </a:rPr>
+              <a:t>85%</a:t>
+            </a:r>
+          </a:p>
+        </p:txBody>
+      </p:sp>
+      <p:pic>
+        <p:nvPicPr>
+          <p:cNvPr id="12" name="Picture 11" descr="image.png"/>
+          <p:cNvPicPr>
+            <a:picLocks noChangeAspect="1"/>
+          </p:cNvPicPr>
+          <p:nvPr/>
+        </p:nvPicPr>
+        <p:blipFill>
+          <a:blip r:embed="rId3"/>
+          <a:stretch>
+            <a:fillRect/>
+          </a:stretch>
+        </p:blipFill>
+        <p:spPr>
+          <a:xfrm>
+            <a:off x="310896" y="4416552"/>
+            <a:ext cx="6099048" cy="274320"/>
+          </a:xfrm>
+          <a:prstGeom prst="rect">
+            <a:avLst/>
+          </a:prstGeom>
+        </p:spPr>
+      </p:pic>
+      <p:sp>
+        <p:nvSpPr>
+          <p:cNvPr id="13" name="TextBox 12"/>
+          <p:cNvSpPr txBox="1"/>
+          <p:nvPr/>
+        </p:nvSpPr>
+        <p:spPr>
+          <a:xfrm>
+            <a:off x="7068312" y="1463040"/>
+            <a:ext cx="4754879" cy="2880360"/>
+          </a:xfrm>
+          <a:prstGeom prst="rect">
+            <a:avLst/>
+          </a:prstGeom>
+          <a:noFill/>
+        </p:spPr>
+        <p:txBody>
+          <a:bodyPr wrap="square">
+            <a:spAutoFit/>
+          </a:bodyPr>
+          <a:lstStyle/>
+          <a:p>
+            <a:r>
+              <a:rPr sz="1000" b="0">
+                <a:solidFill>
+                  <a:srgbClr val="44546A"/>
+                </a:solidFill>
+                <a:latin typeface="DM Sans"/>
+              </a:rPr>
+              <a:t>Add commentary here.</a:t>
+            </a:r>
+          </a:p>
+        </p:txBody>
+      </p:sp>
+      <p:sp>
+        <p:nvSpPr>
+          <p:cNvPr id="14" name="TextBox 13"/>
+          <p:cNvSpPr txBox="1"/>
+          <p:nvPr/>
+        </p:nvSpPr>
+        <p:spPr>
+          <a:xfrm>
+            <a:off x="1097280" y="6236208"/>
+            <a:ext cx="10058400" cy="256032"/>
+          </a:xfrm>
+          <a:prstGeom prst="rect">
+            <a:avLst/>
+          </a:prstGeom>
+          <a:noFill/>
+        </p:spPr>
+        <p:txBody>
+          <a:bodyPr wrap="square">
+            <a:spAutoFit/>
+          </a:bodyPr>
+          <a:lstStyle/>
+          <a:p>
+            <a:pPr algn="l"/>
+            <a:r>
+              <a:rPr sz="800" b="0" i="1">
+                <a:solidFill>
+                  <a:srgbClr val="44546A"/>
+                </a:solidFill>
+                <a:latin typeface="DM Sans"/>
+              </a:rPr>
+              <a:t>Base: all respondents (n=200)</a:t>
+            </a:r>
+          </a:p>
+        </p:txBody>
+      </p:sp>
+      <p:sp>
+        <p:nvSpPr>
+          <p:cNvPr id="15" name="TextBox 14"/>
+          <p:cNvSpPr txBox="1"/>
+          <p:nvPr/>
+        </p:nvSpPr>
+        <p:spPr>
+          <a:xfrm>
+            <a:off x="11338560" y="6217920"/>
+            <a:ext cx="612648" cy="274320"/>
+          </a:xfrm>
+          <a:prstGeom prst="rect">
+            <a:avLst/>
+          </a:prstGeom>
+          <a:noFill/>
+        </p:spPr>
+        <p:txBody>
+          <a:bodyPr wrap="square">
+            <a:spAutoFit/>
+          </a:bodyPr>
+          <a:lstStyle/>
+          <a:p>
             <a:pPr algn="r"/>
             <a:r>
               <a:rPr sz="800" b="0" i="0">
                 <a:solidFill>
-                  <a:srgbClr val="FFFFFF"/>
-                </a:solidFill>
+                  <a:srgbClr val="44546A"/>
+                </a:solidFill>
+                <a:latin typeface="DM Sans"/>
               </a:rPr>
               <a:t>4</a:t>
             </a:r>
@@ -8016,14 +8279,14 @@
         </p:nvSpPr>
         <p:spPr>
           <a:xfrm>
-            <a:off x="0" y="0"/>
-            <a:ext cx="12188952" cy="457200"/>
+            <a:off x="310896" y="1005840"/>
+            <a:ext cx="11878056" cy="27432"/>
           </a:xfrm>
           <a:prstGeom prst="rect">
             <a:avLst/>
           </a:prstGeom>
           <a:solidFill>
-            <a:srgbClr val="1B5566"/>
+            <a:srgbClr val="027F7C"/>
           </a:solidFill>
           <a:ln>
             <a:noFill/>
@@ -8059,8 +8322,8 @@
         </p:nvSpPr>
         <p:spPr>
           <a:xfrm>
-            <a:off x="365760" y="457200"/>
-            <a:ext cx="11457432" cy="594360"/>
+            <a:off x="310896" y="201168"/>
+            <a:ext cx="11567160" cy="749808"/>
           </a:xfrm>
           <a:prstGeom prst="rect">
             <a:avLst/>
@@ -8077,10 +8340,11 @@
             <a:r>
               <a:rPr sz="1800" b="1" i="0">
                 <a:solidFill>
-                  <a:srgbClr val="D94438"/>
-                </a:solidFill>
+                  <a:srgbClr val="A32015"/>
+                </a:solidFill>
+                <a:latin typeface="DM Sans"/>
               </a:rPr>
-              <a:t>Government must take a stronger leadership role on this issue.</a:t>
+              <a:t>Which region are you based in?</a:t>
             </a:r>
           </a:p>
         </p:txBody>
@@ -8093,8 +8357,8 @@
         </p:nvSpPr>
         <p:spPr>
           <a:xfrm>
-            <a:off x="365760" y="1051560"/>
-            <a:ext cx="11457432" cy="347472"/>
+            <a:off x="310896" y="1042415"/>
+            <a:ext cx="8229600" cy="347472"/>
           </a:xfrm>
           <a:prstGeom prst="rect">
             <a:avLst/>
@@ -8111,10 +8375,11 @@
             <a:r>
               <a:rPr sz="1100" b="0" i="1">
                 <a:solidFill>
-                  <a:srgbClr val="58595B"/>
-                </a:solidFill>
+                  <a:srgbClr val="44546A"/>
+                </a:solidFill>
+                <a:latin typeface="DM Sans"/>
               </a:rPr>
-              <a:t>[stmt_govt_role] (%)</a:t>
+              <a:t>[region] (%)</a:t>
             </a:r>
           </a:p>
         </p:txBody>
@@ -8135,7 +8400,7 @@
         </p:blipFill>
         <p:spPr>
           <a:xfrm>
-            <a:off x="365760" y="1417320"/>
+            <a:off x="310896" y="1463040"/>
             <a:ext cx="6702552" cy="1645920"/>
           </a:xfrm>
           <a:prstGeom prst="rect">
@@ -8151,7 +8416,7 @@
         </p:nvSpPr>
         <p:spPr>
           <a:xfrm>
-            <a:off x="7434072" y="1417320"/>
+            <a:off x="7434072" y="1463040"/>
             <a:ext cx="4389119" cy="1645920"/>
           </a:xfrm>
           <a:prstGeom prst="rect">
@@ -8168,8 +8433,9 @@
             <a:r>
               <a:rPr sz="1000" b="0">
                 <a:solidFill>
-                  <a:srgbClr val="58595B"/>
-                </a:solidFill>
+                  <a:srgbClr val="44546A"/>
+                </a:solidFill>
+                <a:latin typeface="DM Sans"/>
               </a:rPr>
               <a:t>Add subgroup breakdowns here, e.g.:</a:t>
             </a:r>
@@ -8178,8 +8444,9 @@
             <a:r>
               <a:rPr sz="1000" b="0">
                 <a:solidFill>
-                  <a:srgbClr val="58595B"/>
-                </a:solidFill>
+                  <a:srgbClr val="44546A"/>
+                </a:solidFill>
+                <a:latin typeface="DM Sans"/>
               </a:rPr>
               <a:t>– Under 30:  XX%</a:t>
             </a:r>
@@ -8188,8 +8455,9 @@
             <a:r>
               <a:rPr sz="1000" b="0">
                 <a:solidFill>
-                  <a:srgbClr val="58595B"/>
-                </a:solidFill>
+                  <a:srgbClr val="44546A"/>
+                </a:solidFill>
+                <a:latin typeface="DM Sans"/>
               </a:rPr>
               <a:t>– 30–44:     XX%</a:t>
             </a:r>
@@ -8204,8 +8472,8 @@
         </p:nvSpPr>
         <p:spPr>
           <a:xfrm>
-            <a:off x="365760" y="6492240"/>
-            <a:ext cx="11457432" cy="256032"/>
+            <a:off x="1097280" y="6236208"/>
+            <a:ext cx="10058400" cy="256032"/>
           </a:xfrm>
           <a:prstGeom prst="rect">
             <a:avLst/>
@@ -8222,8 +8490,9 @@
             <a:r>
               <a:rPr sz="800" b="0" i="1">
                 <a:solidFill>
-                  <a:srgbClr val="58595B"/>
-                </a:solidFill>
+                  <a:srgbClr val="44546A"/>
+                </a:solidFill>
+                <a:latin typeface="DM Sans"/>
               </a:rPr>
               <a:t>Base: all respondents (n=200)</a:t>
             </a:r>
@@ -8238,7 +8507,7 @@
         </p:nvSpPr>
         <p:spPr>
           <a:xfrm>
-            <a:off x="11338560" y="91440"/>
+            <a:off x="11338560" y="6217920"/>
             <a:ext cx="612648" cy="274320"/>
           </a:xfrm>
           <a:prstGeom prst="rect">
@@ -8256,8 +8525,9 @@
             <a:r>
               <a:rPr sz="800" b="0" i="0">
                 <a:solidFill>
-                  <a:srgbClr val="FFFFFF"/>
-                </a:solidFill>
+                  <a:srgbClr val="44546A"/>
+                </a:solidFill>
+                <a:latin typeface="DM Sans"/>
               </a:rPr>
               <a:t>5</a:t>
             </a:r>
@@ -8290,14 +8560,14 @@
         </p:nvSpPr>
         <p:spPr>
           <a:xfrm>
-            <a:off x="0" y="0"/>
-            <a:ext cx="12188952" cy="457200"/>
+            <a:off x="310896" y="1005840"/>
+            <a:ext cx="11878056" cy="27432"/>
           </a:xfrm>
           <a:prstGeom prst="rect">
             <a:avLst/>
           </a:prstGeom>
           <a:solidFill>
-            <a:srgbClr val="1B5566"/>
+            <a:srgbClr val="027F7C"/>
           </a:solidFill>
           <a:ln>
             <a:noFill/>
@@ -8333,8 +8603,8 @@
         </p:nvSpPr>
         <p:spPr>
           <a:xfrm>
-            <a:off x="365760" y="457200"/>
-            <a:ext cx="11457432" cy="594360"/>
+            <a:off x="310896" y="201168"/>
+            <a:ext cx="11567160" cy="749808"/>
           </a:xfrm>
           <a:prstGeom prst="rect">
             <a:avLst/>
@@ -8351,10 +8621,11 @@
             <a:r>
               <a:rPr sz="1800" b="1" i="0">
                 <a:solidFill>
-                  <a:srgbClr val="D94438"/>
-                </a:solidFill>
+                  <a:srgbClr val="A32015"/>
+                </a:solidFill>
+                <a:latin typeface="DM Sans"/>
               </a:rPr>
-              <a:t>Local action can make a meaningful difference on this issue.</a:t>
+              <a:t>What is your age group?</a:t>
             </a:r>
           </a:p>
         </p:txBody>
@@ -8367,8 +8638,8 @@
         </p:nvSpPr>
         <p:spPr>
           <a:xfrm>
-            <a:off x="365760" y="1051560"/>
-            <a:ext cx="11457432" cy="347472"/>
+            <a:off x="310896" y="1042415"/>
+            <a:ext cx="8229600" cy="347472"/>
           </a:xfrm>
           <a:prstGeom prst="rect">
             <a:avLst/>
@@ -8385,10 +8656,11 @@
             <a:r>
               <a:rPr sz="1100" b="0" i="1">
                 <a:solidFill>
-                  <a:srgbClr val="58595B"/>
-                </a:solidFill>
+                  <a:srgbClr val="44546A"/>
+                </a:solidFill>
+                <a:latin typeface="DM Sans"/>
               </a:rPr>
-              <a:t>[stmt_local_action] (%)</a:t>
+              <a:t>[age_group] (%)</a:t>
             </a:r>
           </a:p>
         </p:txBody>
@@ -8409,7 +8681,7 @@
         </p:blipFill>
         <p:spPr>
           <a:xfrm>
-            <a:off x="365760" y="1417320"/>
+            <a:off x="310896" y="1463040"/>
             <a:ext cx="6702552" cy="1645920"/>
           </a:xfrm>
           <a:prstGeom prst="rect">
@@ -8425,7 +8697,7 @@
         </p:nvSpPr>
         <p:spPr>
           <a:xfrm>
-            <a:off x="7434072" y="1417320"/>
+            <a:off x="7434072" y="1463040"/>
             <a:ext cx="4389119" cy="1645920"/>
           </a:xfrm>
           <a:prstGeom prst="rect">
@@ -8442,8 +8714,9 @@
             <a:r>
               <a:rPr sz="1000" b="0">
                 <a:solidFill>
-                  <a:srgbClr val="58595B"/>
-                </a:solidFill>
+                  <a:srgbClr val="44546A"/>
+                </a:solidFill>
+                <a:latin typeface="DM Sans"/>
               </a:rPr>
               <a:t>Add subgroup breakdowns here, e.g.:</a:t>
             </a:r>
@@ -8452,8 +8725,9 @@
             <a:r>
               <a:rPr sz="1000" b="0">
                 <a:solidFill>
-                  <a:srgbClr val="58595B"/>
-                </a:solidFill>
+                  <a:srgbClr val="44546A"/>
+                </a:solidFill>
+                <a:latin typeface="DM Sans"/>
               </a:rPr>
               <a:t>– Under 30:  XX%</a:t>
             </a:r>
@@ -8462,8 +8736,9 @@
             <a:r>
               <a:rPr sz="1000" b="0">
                 <a:solidFill>
-                  <a:srgbClr val="58595B"/>
-                </a:solidFill>
+                  <a:srgbClr val="44546A"/>
+                </a:solidFill>
+                <a:latin typeface="DM Sans"/>
               </a:rPr>
               <a:t>– 30–44:     XX%</a:t>
             </a:r>
@@ -8478,8 +8753,8 @@
         </p:nvSpPr>
         <p:spPr>
           <a:xfrm>
-            <a:off x="365760" y="6492240"/>
-            <a:ext cx="11457432" cy="256032"/>
+            <a:off x="1097280" y="6236208"/>
+            <a:ext cx="10058400" cy="256032"/>
           </a:xfrm>
           <a:prstGeom prst="rect">
             <a:avLst/>
@@ -8496,8 +8771,9 @@
             <a:r>
               <a:rPr sz="800" b="0" i="1">
                 <a:solidFill>
-                  <a:srgbClr val="58595B"/>
-                </a:solidFill>
+                  <a:srgbClr val="44546A"/>
+                </a:solidFill>
+                <a:latin typeface="DM Sans"/>
               </a:rPr>
               <a:t>Base: all respondents (n=200)</a:t>
             </a:r>
@@ -8512,7 +8788,7 @@
         </p:nvSpPr>
         <p:spPr>
           <a:xfrm>
-            <a:off x="11338560" y="91440"/>
+            <a:off x="11338560" y="6217920"/>
             <a:ext cx="612648" cy="274320"/>
           </a:xfrm>
           <a:prstGeom prst="rect">
@@ -8530,558 +8806,11 @@
             <a:r>
               <a:rPr sz="800" b="0" i="0">
                 <a:solidFill>
-                  <a:srgbClr val="FFFFFF"/>
-                </a:solidFill>
+                  <a:srgbClr val="44546A"/>
+                </a:solidFill>
+                <a:latin typeface="DM Sans"/>
               </a:rPr>
               <a:t>6</a:t>
-            </a:r>
-          </a:p>
-        </p:txBody>
-      </p:sp>
-    </p:spTree>
-  </p:cSld>
-  <p:clrMapOvr>
-    <a:masterClrMapping/>
-  </p:clrMapOvr>
-</p:sld>
-</file>
-
-<file path=ppt/slides/slide8.xml><?xml version="1.0" encoding="utf-8"?>
-<p:sld xmlns:a="http://schemas.openxmlformats.org/drawingml/2006/main" xmlns:p="http://schemas.openxmlformats.org/presentationml/2006/main" xmlns:r="http://schemas.openxmlformats.org/officeDocument/2006/relationships">
-  <p:cSld>
-    <p:spTree>
-      <p:nvGrpSpPr>
-        <p:cNvPr id="1" name=""/>
-        <p:cNvGrpSpPr/>
-        <p:nvPr/>
-      </p:nvGrpSpPr>
-      <p:grpSpPr/>
-      <p:sp>
-        <p:nvSpPr>
-          <p:cNvPr id="2" name="Rectangle 1"/>
-          <p:cNvSpPr/>
-          <p:nvPr/>
-        </p:nvSpPr>
-        <p:spPr>
-          <a:xfrm>
-            <a:off x="0" y="0"/>
-            <a:ext cx="12188952" cy="457200"/>
-          </a:xfrm>
-          <a:prstGeom prst="rect">
-            <a:avLst/>
-          </a:prstGeom>
-          <a:solidFill>
-            <a:srgbClr val="1B5566"/>
-          </a:solidFill>
-          <a:ln>
-            <a:noFill/>
-          </a:ln>
-        </p:spPr>
-        <p:style>
-          <a:lnRef idx="1">
-            <a:schemeClr val="accent1"/>
-          </a:lnRef>
-          <a:fillRef idx="3">
-            <a:schemeClr val="accent1"/>
-          </a:fillRef>
-          <a:effectRef idx="2">
-            <a:schemeClr val="accent1"/>
-          </a:effectRef>
-          <a:fontRef idx="minor">
-            <a:schemeClr val="lt1"/>
-          </a:fontRef>
-        </p:style>
-        <p:txBody>
-          <a:bodyPr rtlCol="0" anchor="ctr"/>
-          <a:lstStyle/>
-          <a:p>
-            <a:pPr algn="ctr"/>
-          </a:p>
-        </p:txBody>
-      </p:sp>
-      <p:sp>
-        <p:nvSpPr>
-          <p:cNvPr id="3" name="TextBox 2"/>
-          <p:cNvSpPr txBox="1"/>
-          <p:nvPr/>
-        </p:nvSpPr>
-        <p:spPr>
-          <a:xfrm>
-            <a:off x="365760" y="457200"/>
-            <a:ext cx="11457432" cy="594360"/>
-          </a:xfrm>
-          <a:prstGeom prst="rect">
-            <a:avLst/>
-          </a:prstGeom>
-          <a:noFill/>
-        </p:spPr>
-        <p:txBody>
-          <a:bodyPr wrap="square">
-            <a:spAutoFit/>
-          </a:bodyPr>
-          <a:lstStyle/>
-          <a:p>
-            <a:pPr algn="l"/>
-            <a:r>
-              <a:rPr sz="1800" b="1" i="0">
-                <a:solidFill>
-                  <a:srgbClr val="D94438"/>
-                </a:solidFill>
-              </a:rPr>
-              <a:t>Which region are you based in?</a:t>
-            </a:r>
-          </a:p>
-        </p:txBody>
-      </p:sp>
-      <p:sp>
-        <p:nvSpPr>
-          <p:cNvPr id="4" name="TextBox 3"/>
-          <p:cNvSpPr txBox="1"/>
-          <p:nvPr/>
-        </p:nvSpPr>
-        <p:spPr>
-          <a:xfrm>
-            <a:off x="365760" y="1051560"/>
-            <a:ext cx="11457432" cy="347472"/>
-          </a:xfrm>
-          <a:prstGeom prst="rect">
-            <a:avLst/>
-          </a:prstGeom>
-          <a:noFill/>
-        </p:spPr>
-        <p:txBody>
-          <a:bodyPr wrap="square">
-            <a:spAutoFit/>
-          </a:bodyPr>
-          <a:lstStyle/>
-          <a:p>
-            <a:pPr algn="l"/>
-            <a:r>
-              <a:rPr sz="1100" b="0" i="1">
-                <a:solidFill>
-                  <a:srgbClr val="58595B"/>
-                </a:solidFill>
-              </a:rPr>
-              <a:t>[region] (%)</a:t>
-            </a:r>
-          </a:p>
-        </p:txBody>
-      </p:sp>
-      <p:pic>
-        <p:nvPicPr>
-          <p:cNvPr id="5" name="Picture 4" descr="image.png"/>
-          <p:cNvPicPr>
-            <a:picLocks noChangeAspect="1"/>
-          </p:cNvPicPr>
-          <p:nvPr/>
-        </p:nvPicPr>
-        <p:blipFill>
-          <a:blip r:embed="rId2"/>
-          <a:stretch>
-            <a:fillRect/>
-          </a:stretch>
-        </p:blipFill>
-        <p:spPr>
-          <a:xfrm>
-            <a:off x="365760" y="1417320"/>
-            <a:ext cx="6702552" cy="1645920"/>
-          </a:xfrm>
-          <a:prstGeom prst="rect">
-            <a:avLst/>
-          </a:prstGeom>
-        </p:spPr>
-      </p:pic>
-      <p:sp>
-        <p:nvSpPr>
-          <p:cNvPr id="6" name="TextBox 5"/>
-          <p:cNvSpPr txBox="1"/>
-          <p:nvPr/>
-        </p:nvSpPr>
-        <p:spPr>
-          <a:xfrm>
-            <a:off x="7434072" y="1417320"/>
-            <a:ext cx="4389119" cy="1645920"/>
-          </a:xfrm>
-          <a:prstGeom prst="rect">
-            <a:avLst/>
-          </a:prstGeom>
-          <a:noFill/>
-        </p:spPr>
-        <p:txBody>
-          <a:bodyPr wrap="square">
-            <a:spAutoFit/>
-          </a:bodyPr>
-          <a:lstStyle/>
-          <a:p>
-            <a:r>
-              <a:rPr sz="1000" b="0">
-                <a:solidFill>
-                  <a:srgbClr val="58595B"/>
-                </a:solidFill>
-              </a:rPr>
-              <a:t>Add subgroup breakdowns here, e.g.:</a:t>
-            </a:r>
-          </a:p>
-          <a:p>
-            <a:r>
-              <a:rPr sz="1000" b="0">
-                <a:solidFill>
-                  <a:srgbClr val="58595B"/>
-                </a:solidFill>
-              </a:rPr>
-              <a:t>– Under 30:  XX%</a:t>
-            </a:r>
-          </a:p>
-          <a:p>
-            <a:r>
-              <a:rPr sz="1000" b="0">
-                <a:solidFill>
-                  <a:srgbClr val="58595B"/>
-                </a:solidFill>
-              </a:rPr>
-              <a:t>– 30–44:     XX%</a:t>
-            </a:r>
-          </a:p>
-        </p:txBody>
-      </p:sp>
-      <p:sp>
-        <p:nvSpPr>
-          <p:cNvPr id="7" name="TextBox 6"/>
-          <p:cNvSpPr txBox="1"/>
-          <p:nvPr/>
-        </p:nvSpPr>
-        <p:spPr>
-          <a:xfrm>
-            <a:off x="365760" y="6492240"/>
-            <a:ext cx="11457432" cy="256032"/>
-          </a:xfrm>
-          <a:prstGeom prst="rect">
-            <a:avLst/>
-          </a:prstGeom>
-          <a:noFill/>
-        </p:spPr>
-        <p:txBody>
-          <a:bodyPr wrap="square">
-            <a:spAutoFit/>
-          </a:bodyPr>
-          <a:lstStyle/>
-          <a:p>
-            <a:pPr algn="l"/>
-            <a:r>
-              <a:rPr sz="800" b="0" i="1">
-                <a:solidFill>
-                  <a:srgbClr val="58595B"/>
-                </a:solidFill>
-              </a:rPr>
-              <a:t>Base: all respondents (n=200)</a:t>
-            </a:r>
-          </a:p>
-        </p:txBody>
-      </p:sp>
-      <p:sp>
-        <p:nvSpPr>
-          <p:cNvPr id="8" name="TextBox 7"/>
-          <p:cNvSpPr txBox="1"/>
-          <p:nvPr/>
-        </p:nvSpPr>
-        <p:spPr>
-          <a:xfrm>
-            <a:off x="11338560" y="91440"/>
-            <a:ext cx="612648" cy="274320"/>
-          </a:xfrm>
-          <a:prstGeom prst="rect">
-            <a:avLst/>
-          </a:prstGeom>
-          <a:noFill/>
-        </p:spPr>
-        <p:txBody>
-          <a:bodyPr wrap="square">
-            <a:spAutoFit/>
-          </a:bodyPr>
-          <a:lstStyle/>
-          <a:p>
-            <a:pPr algn="r"/>
-            <a:r>
-              <a:rPr sz="800" b="0" i="0">
-                <a:solidFill>
-                  <a:srgbClr val="FFFFFF"/>
-                </a:solidFill>
-              </a:rPr>
-              <a:t>7</a:t>
-            </a:r>
-          </a:p>
-        </p:txBody>
-      </p:sp>
-    </p:spTree>
-  </p:cSld>
-  <p:clrMapOvr>
-    <a:masterClrMapping/>
-  </p:clrMapOvr>
-</p:sld>
-</file>
-
-<file path=ppt/slides/slide9.xml><?xml version="1.0" encoding="utf-8"?>
-<p:sld xmlns:a="http://schemas.openxmlformats.org/drawingml/2006/main" xmlns:p="http://schemas.openxmlformats.org/presentationml/2006/main" xmlns:r="http://schemas.openxmlformats.org/officeDocument/2006/relationships">
-  <p:cSld>
-    <p:spTree>
-      <p:nvGrpSpPr>
-        <p:cNvPr id="1" name=""/>
-        <p:cNvGrpSpPr/>
-        <p:nvPr/>
-      </p:nvGrpSpPr>
-      <p:grpSpPr/>
-      <p:sp>
-        <p:nvSpPr>
-          <p:cNvPr id="2" name="Rectangle 1"/>
-          <p:cNvSpPr/>
-          <p:nvPr/>
-        </p:nvSpPr>
-        <p:spPr>
-          <a:xfrm>
-            <a:off x="0" y="0"/>
-            <a:ext cx="12188952" cy="457200"/>
-          </a:xfrm>
-          <a:prstGeom prst="rect">
-            <a:avLst/>
-          </a:prstGeom>
-          <a:solidFill>
-            <a:srgbClr val="1B5566"/>
-          </a:solidFill>
-          <a:ln>
-            <a:noFill/>
-          </a:ln>
-        </p:spPr>
-        <p:style>
-          <a:lnRef idx="1">
-            <a:schemeClr val="accent1"/>
-          </a:lnRef>
-          <a:fillRef idx="3">
-            <a:schemeClr val="accent1"/>
-          </a:fillRef>
-          <a:effectRef idx="2">
-            <a:schemeClr val="accent1"/>
-          </a:effectRef>
-          <a:fontRef idx="minor">
-            <a:schemeClr val="lt1"/>
-          </a:fontRef>
-        </p:style>
-        <p:txBody>
-          <a:bodyPr rtlCol="0" anchor="ctr"/>
-          <a:lstStyle/>
-          <a:p>
-            <a:pPr algn="ctr"/>
-          </a:p>
-        </p:txBody>
-      </p:sp>
-      <p:sp>
-        <p:nvSpPr>
-          <p:cNvPr id="3" name="TextBox 2"/>
-          <p:cNvSpPr txBox="1"/>
-          <p:nvPr/>
-        </p:nvSpPr>
-        <p:spPr>
-          <a:xfrm>
-            <a:off x="365760" y="457200"/>
-            <a:ext cx="11457432" cy="594360"/>
-          </a:xfrm>
-          <a:prstGeom prst="rect">
-            <a:avLst/>
-          </a:prstGeom>
-          <a:noFill/>
-        </p:spPr>
-        <p:txBody>
-          <a:bodyPr wrap="square">
-            <a:spAutoFit/>
-          </a:bodyPr>
-          <a:lstStyle/>
-          <a:p>
-            <a:pPr algn="l"/>
-            <a:r>
-              <a:rPr sz="1800" b="1" i="0">
-                <a:solidFill>
-                  <a:srgbClr val="D94438"/>
-                </a:solidFill>
-              </a:rPr>
-              <a:t>What is your age group?</a:t>
-            </a:r>
-          </a:p>
-        </p:txBody>
-      </p:sp>
-      <p:sp>
-        <p:nvSpPr>
-          <p:cNvPr id="4" name="TextBox 3"/>
-          <p:cNvSpPr txBox="1"/>
-          <p:nvPr/>
-        </p:nvSpPr>
-        <p:spPr>
-          <a:xfrm>
-            <a:off x="365760" y="1051560"/>
-            <a:ext cx="11457432" cy="347472"/>
-          </a:xfrm>
-          <a:prstGeom prst="rect">
-            <a:avLst/>
-          </a:prstGeom>
-          <a:noFill/>
-        </p:spPr>
-        <p:txBody>
-          <a:bodyPr wrap="square">
-            <a:spAutoFit/>
-          </a:bodyPr>
-          <a:lstStyle/>
-          <a:p>
-            <a:pPr algn="l"/>
-            <a:r>
-              <a:rPr sz="1100" b="0" i="1">
-                <a:solidFill>
-                  <a:srgbClr val="58595B"/>
-                </a:solidFill>
-              </a:rPr>
-              <a:t>[age_group] (%)</a:t>
-            </a:r>
-          </a:p>
-        </p:txBody>
-      </p:sp>
-      <p:pic>
-        <p:nvPicPr>
-          <p:cNvPr id="5" name="Picture 4" descr="image.png"/>
-          <p:cNvPicPr>
-            <a:picLocks noChangeAspect="1"/>
-          </p:cNvPicPr>
-          <p:nvPr/>
-        </p:nvPicPr>
-        <p:blipFill>
-          <a:blip r:embed="rId2"/>
-          <a:stretch>
-            <a:fillRect/>
-          </a:stretch>
-        </p:blipFill>
-        <p:spPr>
-          <a:xfrm>
-            <a:off x="365760" y="1417320"/>
-            <a:ext cx="6702552" cy="1645920"/>
-          </a:xfrm>
-          <a:prstGeom prst="rect">
-            <a:avLst/>
-          </a:prstGeom>
-        </p:spPr>
-      </p:pic>
-      <p:sp>
-        <p:nvSpPr>
-          <p:cNvPr id="6" name="TextBox 5"/>
-          <p:cNvSpPr txBox="1"/>
-          <p:nvPr/>
-        </p:nvSpPr>
-        <p:spPr>
-          <a:xfrm>
-            <a:off x="7434072" y="1417320"/>
-            <a:ext cx="4389119" cy="1645920"/>
-          </a:xfrm>
-          <a:prstGeom prst="rect">
-            <a:avLst/>
-          </a:prstGeom>
-          <a:noFill/>
-        </p:spPr>
-        <p:txBody>
-          <a:bodyPr wrap="square">
-            <a:spAutoFit/>
-          </a:bodyPr>
-          <a:lstStyle/>
-          <a:p>
-            <a:r>
-              <a:rPr sz="1000" b="0">
-                <a:solidFill>
-                  <a:srgbClr val="58595B"/>
-                </a:solidFill>
-              </a:rPr>
-              <a:t>Add subgroup breakdowns here, e.g.:</a:t>
-            </a:r>
-          </a:p>
-          <a:p>
-            <a:r>
-              <a:rPr sz="1000" b="0">
-                <a:solidFill>
-                  <a:srgbClr val="58595B"/>
-                </a:solidFill>
-              </a:rPr>
-              <a:t>– Under 30:  XX%</a:t>
-            </a:r>
-          </a:p>
-          <a:p>
-            <a:r>
-              <a:rPr sz="1000" b="0">
-                <a:solidFill>
-                  <a:srgbClr val="58595B"/>
-                </a:solidFill>
-              </a:rPr>
-              <a:t>– 30–44:     XX%</a:t>
-            </a:r>
-          </a:p>
-        </p:txBody>
-      </p:sp>
-      <p:sp>
-        <p:nvSpPr>
-          <p:cNvPr id="7" name="TextBox 6"/>
-          <p:cNvSpPr txBox="1"/>
-          <p:nvPr/>
-        </p:nvSpPr>
-        <p:spPr>
-          <a:xfrm>
-            <a:off x="365760" y="6492240"/>
-            <a:ext cx="11457432" cy="256032"/>
-          </a:xfrm>
-          <a:prstGeom prst="rect">
-            <a:avLst/>
-          </a:prstGeom>
-          <a:noFill/>
-        </p:spPr>
-        <p:txBody>
-          <a:bodyPr wrap="square">
-            <a:spAutoFit/>
-          </a:bodyPr>
-          <a:lstStyle/>
-          <a:p>
-            <a:pPr algn="l"/>
-            <a:r>
-              <a:rPr sz="800" b="0" i="1">
-                <a:solidFill>
-                  <a:srgbClr val="58595B"/>
-                </a:solidFill>
-              </a:rPr>
-              <a:t>Base: all respondents (n=200)</a:t>
-            </a:r>
-          </a:p>
-        </p:txBody>
-      </p:sp>
-      <p:sp>
-        <p:nvSpPr>
-          <p:cNvPr id="8" name="TextBox 7"/>
-          <p:cNvSpPr txBox="1"/>
-          <p:nvPr/>
-        </p:nvSpPr>
-        <p:spPr>
-          <a:xfrm>
-            <a:off x="11338560" y="91440"/>
-            <a:ext cx="612648" cy="274320"/>
-          </a:xfrm>
-          <a:prstGeom prst="rect">
-            <a:avLst/>
-          </a:prstGeom>
-          <a:noFill/>
-        </p:spPr>
-        <p:txBody>
-          <a:bodyPr wrap="square">
-            <a:spAutoFit/>
-          </a:bodyPr>
-          <a:lstStyle/>
-          <a:p>
-            <a:pPr algn="r"/>
-            <a:r>
-              <a:rPr sz="800" b="0" i="0">
-                <a:solidFill>
-                  <a:srgbClr val="FFFFFF"/>
-                </a:solidFill>
-              </a:rPr>
-              <a:t>8</a:t>
             </a:r>
           </a:p>
         </p:txBody>

</xml_diff>

<commit_message>
Round 3 visual refinements: transparent charts, grid sort, layout and sizing fixes
- chart_styles: transparent backgrounds on all chart types (PNG alpha)
- chart_styles: simple bar y-axis now bold with no tick marks (matches stacked bar)
- chart_styles: legend circle updated to white fill with teal border
- slide_builder: simplified _fill_placeholder to use template's built-in styles
- slide_builder: grid slides now use 'Section Header' layout (coloured horizontal strip)
- slide_builder: grid footer uses correct placeholder idx=24 (not idx=22)
- slide_builder: grid rows sorted descending by top-box total %
- slide_builder: single bar chart narrower (5.8"), grid chart wider (9.0")

https://claude.ai/code/session_01VCXkWfprNAwES9BXV74rqk
</commit_message>
<xml_diff>
--- a/sample_data/output.pptx
+++ b/sample_data/output.pptx
@@ -18,6 +18,9 @@
     <p:sldId id="260" r:id="rId32"/>
     <p:sldId id="261" r:id="rId33"/>
     <p:sldId id="262" r:id="rId34"/>
+    <p:sldId id="263" r:id="rId35"/>
+    <p:sldId id="264" r:id="rId36"/>
+    <p:sldId id="265" r:id="rId37"/>
   </p:sldIdLst>
   <p:sldSz cx="12192000" cy="6858000"/>
   <p:notesSz cx="6858000" cy="9144000"/>
@@ -6864,7 +6867,7 @@
                 </a:solidFill>
                 <a:latin typeface="DM Sans"/>
               </a:rPr>
-              <a:t>Sample Survey</a:t>
+              <a:t>Community Attitudes Survey</a:t>
             </a:r>
           </a:p>
         </p:txBody>
@@ -6934,7 +6937,235 @@
                 </a:solidFill>
                 <a:latin typeface="DM Sans"/>
               </a:rPr>
-              <a:t>n=200 respondents</a:t>
+              <a:t>n=200 adult residents</a:t>
+            </a:r>
+          </a:p>
+        </p:txBody>
+      </p:sp>
+    </p:spTree>
+  </p:cSld>
+  <p:clrMapOvr>
+    <a:masterClrMapping/>
+  </p:clrMapOvr>
+</p:sld>
+</file>
+
+<file path=ppt/slides/slide10.xml><?xml version="1.0" encoding="utf-8"?>
+<p:sld xmlns:a="http://schemas.openxmlformats.org/drawingml/2006/main" xmlns:p="http://schemas.openxmlformats.org/presentationml/2006/main" xmlns:r="http://schemas.openxmlformats.org/officeDocument/2006/relationships">
+  <p:cSld>
+    <p:spTree>
+      <p:nvGrpSpPr>
+        <p:cNvPr id="1" name=""/>
+        <p:cNvGrpSpPr/>
+        <p:nvPr/>
+      </p:nvGrpSpPr>
+      <p:grpSpPr/>
+      <p:sp>
+        <p:nvSpPr>
+          <p:cNvPr id="2" name="Text Placeholder 1"/>
+          <p:cNvSpPr>
+            <a:spLocks noGrp="1"/>
+          </p:cNvSpPr>
+          <p:nvPr>
+            <p:ph type="body" idx="22" sz="quarter"/>
+          </p:nvPr>
+        </p:nvSpPr>
+        <p:spPr/>
+        <p:txBody>
+          <a:bodyPr/>
+          <a:lstStyle/>
+          <a:p>
+            <a:r>
+              <a:t>Base: all respondents (n=200)</a:t>
+            </a:r>
+          </a:p>
+        </p:txBody>
+      </p:sp>
+      <p:sp>
+        <p:nvSpPr>
+          <p:cNvPr id="3" name="Title 2"/>
+          <p:cNvSpPr>
+            <a:spLocks noGrp="1"/>
+          </p:cNvSpPr>
+          <p:nvPr>
+            <p:ph type="title"/>
+          </p:nvPr>
+        </p:nvSpPr>
+        <p:spPr/>
+        <p:txBody>
+          <a:bodyPr/>
+          <a:lstStyle/>
+          <a:p>
+            <a:r>
+              <a:t>Respondent age group</a:t>
+            </a:r>
+          </a:p>
+        </p:txBody>
+      </p:sp>
+      <p:sp>
+        <p:nvSpPr>
+          <p:cNvPr id="4" name="Text Placeholder 3"/>
+          <p:cNvSpPr>
+            <a:spLocks noGrp="1"/>
+          </p:cNvSpPr>
+          <p:nvPr>
+            <p:ph type="body" idx="21" sz="quarter"/>
+          </p:nvPr>
+        </p:nvSpPr>
+        <p:spPr/>
+        <p:txBody>
+          <a:bodyPr/>
+          <a:lstStyle/>
+          <a:p>
+            <a:r>
+              <a:t>What is your age group? (%)</a:t>
+            </a:r>
+          </a:p>
+        </p:txBody>
+      </p:sp>
+      <p:pic>
+        <p:nvPicPr>
+          <p:cNvPr id="5" name="Picture 4" descr="image.png"/>
+          <p:cNvPicPr>
+            <a:picLocks noChangeAspect="1"/>
+          </p:cNvPicPr>
+          <p:nvPr/>
+        </p:nvPicPr>
+        <p:blipFill>
+          <a:blip r:embed="rId2"/>
+          <a:stretch>
+            <a:fillRect/>
+          </a:stretch>
+        </p:blipFill>
+        <p:spPr>
+          <a:xfrm>
+            <a:off x="310896" y="1709928"/>
+            <a:ext cx="5303520" cy="4251960"/>
+          </a:xfrm>
+          <a:prstGeom prst="rect">
+            <a:avLst/>
+          </a:prstGeom>
+        </p:spPr>
+      </p:pic>
+      <p:sp>
+        <p:nvSpPr>
+          <p:cNvPr id="6" name="TextBox 5"/>
+          <p:cNvSpPr txBox="1"/>
+          <p:nvPr/>
+        </p:nvSpPr>
+        <p:spPr>
+          <a:xfrm>
+            <a:off x="5760720" y="1709928"/>
+            <a:ext cx="6062472" cy="4251960"/>
+          </a:xfrm>
+          <a:prstGeom prst="rect">
+            <a:avLst/>
+          </a:prstGeom>
+          <a:noFill/>
+        </p:spPr>
+        <p:txBody>
+          <a:bodyPr wrap="square">
+            <a:spAutoFit/>
+          </a:bodyPr>
+          <a:lstStyle/>
+          <a:p>
+            <a:r>
+              <a:rPr sz="1000" b="0">
+                <a:solidFill>
+                  <a:srgbClr val="44546A"/>
+                </a:solidFill>
+                <a:latin typeface="DM Sans"/>
+              </a:rPr>
+              <a:t>Sample skews slightly toward working-age</a:t>
+            </a:r>
+          </a:p>
+          <a:p>
+            <a:r>
+              <a:rPr sz="1000" b="0">
+                <a:solidFill>
+                  <a:srgbClr val="44546A"/>
+                </a:solidFill>
+                <a:latin typeface="DM Sans"/>
+              </a:rPr>
+              <a:t>adults (35–54).</a:t>
+            </a:r>
+          </a:p>
+        </p:txBody>
+      </p:sp>
+      <p:sp>
+        <p:nvSpPr>
+          <p:cNvPr id="7" name="Oval 6"/>
+          <p:cNvSpPr/>
+          <p:nvPr/>
+        </p:nvSpPr>
+        <p:spPr>
+          <a:xfrm>
+            <a:off x="11548872" y="6217920"/>
+            <a:ext cx="274320" cy="274320"/>
+          </a:xfrm>
+          <a:prstGeom prst="ellipse">
+            <a:avLst/>
+          </a:prstGeom>
+          <a:solidFill>
+            <a:srgbClr val="027F7C"/>
+          </a:solidFill>
+          <a:ln>
+            <a:noFill/>
+          </a:ln>
+        </p:spPr>
+        <p:style>
+          <a:lnRef idx="1">
+            <a:schemeClr val="accent1"/>
+          </a:lnRef>
+          <a:fillRef idx="3">
+            <a:schemeClr val="accent1"/>
+          </a:fillRef>
+          <a:effectRef idx="2">
+            <a:schemeClr val="accent1"/>
+          </a:effectRef>
+          <a:fontRef idx="minor">
+            <a:schemeClr val="lt1"/>
+          </a:fontRef>
+        </p:style>
+        <p:txBody>
+          <a:bodyPr rtlCol="0" anchor="ctr"/>
+          <a:lstStyle/>
+          <a:p>
+            <a:pPr algn="ctr"/>
+          </a:p>
+        </p:txBody>
+      </p:sp>
+      <p:sp>
+        <p:nvSpPr>
+          <p:cNvPr id="8" name="TextBox 7"/>
+          <p:cNvSpPr txBox="1"/>
+          <p:nvPr/>
+        </p:nvSpPr>
+        <p:spPr>
+          <a:xfrm>
+            <a:off x="11548872" y="6250838"/>
+            <a:ext cx="274320" cy="208483"/>
+          </a:xfrm>
+          <a:prstGeom prst="rect">
+            <a:avLst/>
+          </a:prstGeom>
+          <a:noFill/>
+        </p:spPr>
+        <p:txBody>
+          <a:bodyPr wrap="square">
+            <a:spAutoFit/>
+          </a:bodyPr>
+          <a:lstStyle/>
+          <a:p>
+            <a:pPr algn="ctr"/>
+            <a:r>
+              <a:rPr sz="1000" b="1" i="0">
+                <a:solidFill>
+                  <a:srgbClr val="FFFFFF"/>
+                </a:solidFill>
+                <a:latin typeface="DM Sans"/>
+              </a:rPr>
+              <a:t>6</a:t>
             </a:r>
           </a:p>
         </p:txBody>
@@ -6965,8 +7196,8 @@
         </p:nvSpPr>
         <p:spPr>
           <a:xfrm>
-            <a:off x="310896" y="1005840"/>
-            <a:ext cx="11878056" cy="27432"/>
+            <a:off x="0" y="0"/>
+            <a:ext cx="12188952" cy="6858000"/>
           </a:xfrm>
           <a:prstGeom prst="rect">
             <a:avLst/>
@@ -7008,8 +7239,8 @@
         </p:nvSpPr>
         <p:spPr>
           <a:xfrm>
-            <a:off x="310896" y="201168"/>
-            <a:ext cx="11567160" cy="749808"/>
+            <a:off x="612648" y="2743200"/>
+            <a:ext cx="10972800" cy="1097280"/>
           </a:xfrm>
           <a:prstGeom prst="rect">
             <a:avLst/>
@@ -7024,152 +7255,13 @@
           <a:p>
             <a:pPr algn="l"/>
             <a:r>
-              <a:rPr sz="1800" b="1" i="0">
-                <a:solidFill>
-                  <a:srgbClr val="A32015"/>
+              <a:rPr sz="2800" b="1" i="0">
+                <a:solidFill>
+                  <a:srgbClr val="FFFFFF"/>
                 </a:solidFill>
                 <a:latin typeface="DM Sans"/>
               </a:rPr>
-              <a:t>Respondent ID</a:t>
-            </a:r>
-          </a:p>
-        </p:txBody>
-      </p:sp>
-      <p:sp>
-        <p:nvSpPr>
-          <p:cNvPr id="4" name="TextBox 3"/>
-          <p:cNvSpPr txBox="1"/>
-          <p:nvPr/>
-        </p:nvSpPr>
-        <p:spPr>
-          <a:xfrm>
-            <a:off x="310896" y="1042415"/>
-            <a:ext cx="8229600" cy="347472"/>
-          </a:xfrm>
-          <a:prstGeom prst="rect">
-            <a:avLst/>
-          </a:prstGeom>
-          <a:noFill/>
-        </p:spPr>
-        <p:txBody>
-          <a:bodyPr wrap="square">
-            <a:spAutoFit/>
-          </a:bodyPr>
-          <a:lstStyle/>
-          <a:p>
-            <a:pPr algn="l"/>
-            <a:r>
-              <a:rPr sz="1100" b="0" i="1">
-                <a:solidFill>
-                  <a:srgbClr val="44546A"/>
-                </a:solidFill>
-                <a:latin typeface="DM Sans"/>
-              </a:rPr>
-              <a:t>[respondent_id] — numeric summary</a:t>
-            </a:r>
-          </a:p>
-        </p:txBody>
-      </p:sp>
-      <p:sp>
-        <p:nvSpPr>
-          <p:cNvPr id="5" name="TextBox 4"/>
-          <p:cNvSpPr txBox="1"/>
-          <p:nvPr/>
-        </p:nvSpPr>
-        <p:spPr>
-          <a:xfrm>
-            <a:off x="7434072" y="1463040"/>
-            <a:ext cx="4389119" cy="4251960"/>
-          </a:xfrm>
-          <a:prstGeom prst="rect">
-            <a:avLst/>
-          </a:prstGeom>
-          <a:noFill/>
-        </p:spPr>
-        <p:txBody>
-          <a:bodyPr wrap="square">
-            <a:spAutoFit/>
-          </a:bodyPr>
-          <a:lstStyle/>
-          <a:p>
-            <a:r>
-              <a:rPr sz="1000" b="0">
-                <a:solidFill>
-                  <a:srgbClr val="44546A"/>
-                </a:solidFill>
-                <a:latin typeface="DM Sans"/>
-              </a:rPr>
-              <a:t>Add commentary here.</a:t>
-            </a:r>
-          </a:p>
-        </p:txBody>
-      </p:sp>
-      <p:sp>
-        <p:nvSpPr>
-          <p:cNvPr id="6" name="TextBox 5"/>
-          <p:cNvSpPr txBox="1"/>
-          <p:nvPr/>
-        </p:nvSpPr>
-        <p:spPr>
-          <a:xfrm>
-            <a:off x="1097280" y="6236208"/>
-            <a:ext cx="10058400" cy="256032"/>
-          </a:xfrm>
-          <a:prstGeom prst="rect">
-            <a:avLst/>
-          </a:prstGeom>
-          <a:noFill/>
-        </p:spPr>
-        <p:txBody>
-          <a:bodyPr wrap="square">
-            <a:spAutoFit/>
-          </a:bodyPr>
-          <a:lstStyle/>
-          <a:p>
-            <a:pPr algn="l"/>
-            <a:r>
-              <a:rPr sz="800" b="0" i="1">
-                <a:solidFill>
-                  <a:srgbClr val="44546A"/>
-                </a:solidFill>
-                <a:latin typeface="DM Sans"/>
-              </a:rPr>
-              <a:t>Base: all respondents (n=200)</a:t>
-            </a:r>
-          </a:p>
-        </p:txBody>
-      </p:sp>
-      <p:sp>
-        <p:nvSpPr>
-          <p:cNvPr id="7" name="TextBox 6"/>
-          <p:cNvSpPr txBox="1"/>
-          <p:nvPr/>
-        </p:nvSpPr>
-        <p:spPr>
-          <a:xfrm>
-            <a:off x="11338560" y="6217920"/>
-            <a:ext cx="612648" cy="274320"/>
-          </a:xfrm>
-          <a:prstGeom prst="rect">
-            <a:avLst/>
-          </a:prstGeom>
-          <a:noFill/>
-        </p:spPr>
-        <p:txBody>
-          <a:bodyPr wrap="square">
-            <a:spAutoFit/>
-          </a:bodyPr>
-          <a:lstStyle/>
-          <a:p>
-            <a:pPr algn="r"/>
-            <a:r>
-              <a:rPr sz="800" b="0" i="0">
-                <a:solidFill>
-                  <a:srgbClr val="44546A"/>
-                </a:solidFill>
-                <a:latin typeface="DM Sans"/>
-              </a:rPr>
-              <a:t>1</a:t>
+              <a:t>Concern &amp; Salience</a:t>
             </a:r>
           </a:p>
         </p:txBody>
@@ -7265,7 +7357,7 @@
                 </a:solidFill>
                 <a:latin typeface="DM Sans"/>
               </a:rPr>
-              <a:t>How concerned are you about this issue in your community?</a:t>
+              <a:t>Key findings — concern &amp; community attitudes</a:t>
             </a:r>
           </a:p>
         </p:txBody>
@@ -7278,8 +7370,8 @@
         </p:nvSpPr>
         <p:spPr>
           <a:xfrm>
-            <a:off x="310896" y="1042415"/>
-            <a:ext cx="8229600" cy="347472"/>
+            <a:off x="365760" y="1188720"/>
+            <a:ext cx="11457432" cy="5303520"/>
           </a:xfrm>
           <a:prstGeom prst="rect">
             <a:avLst/>
@@ -7292,53 +7384,73 @@
           </a:bodyPr>
           <a:lstStyle/>
           <a:p>
-            <a:pPr algn="l"/>
-            <a:r>
-              <a:rPr sz="1100" b="0" i="1">
+            <a:r>
+              <a:rPr sz="1000" b="0">
                 <a:solidFill>
                   <a:srgbClr val="44546A"/>
                 </a:solidFill>
                 <a:latin typeface="DM Sans"/>
               </a:rPr>
-              <a:t>[issue_concern] (%)</a:t>
-            </a:r>
-          </a:p>
-        </p:txBody>
-      </p:sp>
-      <p:pic>
-        <p:nvPicPr>
-          <p:cNvPr id="5" name="Picture 4" descr="image.png"/>
-          <p:cNvPicPr>
-            <a:picLocks noChangeAspect="1"/>
-          </p:cNvPicPr>
-          <p:nvPr/>
-        </p:nvPicPr>
-        <p:blipFill>
-          <a:blip r:embed="rId2"/>
-          <a:stretch>
-            <a:fillRect/>
-          </a:stretch>
-        </p:blipFill>
-        <p:spPr>
-          <a:xfrm>
-            <a:off x="310896" y="1463040"/>
-            <a:ext cx="6702552" cy="1645920"/>
-          </a:xfrm>
-          <a:prstGeom prst="rect">
-            <a:avLst/>
-          </a:prstGeom>
-        </p:spPr>
-      </p:pic>
-      <p:sp>
-        <p:nvSpPr>
-          <p:cNvPr id="6" name="TextBox 5"/>
+              <a:t>Strong concern about the issue is evident across the community, with scepticism about how government is currently handling it.
+</a:t>
+            </a:r>
+          </a:p>
+          <a:p>
+            <a:r>
+              <a:rPr sz="1000" b="0">
+                <a:solidFill>
+                  <a:srgbClr val="44546A"/>
+                </a:solidFill>
+                <a:latin typeface="DM Sans"/>
+              </a:rPr>
+              <a:t>• Over 60% are very or extremely concerned — concern is highest among 35–54 year olds.</a:t>
+            </a:r>
+          </a:p>
+          <a:p>
+            <a:r>
+              <a:rPr sz="1000" b="0">
+                <a:solidFill>
+                  <a:srgbClr val="44546A"/>
+                </a:solidFill>
+                <a:latin typeface="DM Sans"/>
+              </a:rPr>
+              <a:t>• Agreement that this issue impacts everyday people is broad, cutting across regions.</a:t>
+            </a:r>
+          </a:p>
+          <a:p>
+            <a:r>
+              <a:rPr sz="1000" b="0">
+                <a:solidFill>
+                  <a:srgbClr val="44546A"/>
+                </a:solidFill>
+                <a:latin typeface="DM Sans"/>
+              </a:rPr>
+              <a:t>• Government handling is rated poorly — fewer than 1 in 5 agree government is handling it well.</a:t>
+            </a:r>
+          </a:p>
+          <a:p>
+            <a:r>
+              <a:rPr sz="1000" b="0">
+                <a:solidFill>
+                  <a:srgbClr val="44546A"/>
+                </a:solidFill>
+                <a:latin typeface="DM Sans"/>
+              </a:rPr>
+              <a:t>• There is strong appetite for local action alongside calls for stronger government leadership.</a:t>
+            </a:r>
+          </a:p>
+        </p:txBody>
+      </p:sp>
+      <p:sp>
+        <p:nvSpPr>
+          <p:cNvPr id="5" name="TextBox 4"/>
           <p:cNvSpPr txBox="1"/>
           <p:nvPr/>
         </p:nvSpPr>
         <p:spPr>
           <a:xfrm>
-            <a:off x="7434072" y="1463040"/>
-            <a:ext cx="4389119" cy="1645920"/>
+            <a:off x="1097280" y="6236208"/>
+            <a:ext cx="10058400" cy="256032"/>
           </a:xfrm>
           <a:prstGeom prst="rect">
             <a:avLst/>
@@ -7351,37 +7463,59 @@
           </a:bodyPr>
           <a:lstStyle/>
           <a:p>
-            <a:r>
-              <a:rPr sz="1000" b="0">
+            <a:pPr algn="l"/>
+            <a:r>
+              <a:rPr sz="800" b="0" i="1">
                 <a:solidFill>
                   <a:srgbClr val="44546A"/>
                 </a:solidFill>
                 <a:latin typeface="DM Sans"/>
               </a:rPr>
-              <a:t>Add subgroup breakdowns here, e.g.:</a:t>
-            </a:r>
-          </a:p>
-          <a:p>
-            <a:r>
-              <a:rPr sz="1000" b="0">
-                <a:solidFill>
-                  <a:srgbClr val="44546A"/>
-                </a:solidFill>
-                <a:latin typeface="DM Sans"/>
-              </a:rPr>
-              <a:t>– Under 30:  XX%</a:t>
-            </a:r>
-          </a:p>
-          <a:p>
-            <a:r>
-              <a:rPr sz="1000" b="0">
-                <a:solidFill>
-                  <a:srgbClr val="44546A"/>
-                </a:solidFill>
-                <a:latin typeface="DM Sans"/>
-              </a:rPr>
-              <a:t>– 30–44:     XX%</a:t>
-            </a:r>
+              <a:t>Base: all respondents (n=200)</a:t>
+            </a:r>
+          </a:p>
+        </p:txBody>
+      </p:sp>
+      <p:sp>
+        <p:nvSpPr>
+          <p:cNvPr id="6" name="Oval 5"/>
+          <p:cNvSpPr/>
+          <p:nvPr/>
+        </p:nvSpPr>
+        <p:spPr>
+          <a:xfrm>
+            <a:off x="11548872" y="6217920"/>
+            <a:ext cx="274320" cy="274320"/>
+          </a:xfrm>
+          <a:prstGeom prst="ellipse">
+            <a:avLst/>
+          </a:prstGeom>
+          <a:solidFill>
+            <a:srgbClr val="027F7C"/>
+          </a:solidFill>
+          <a:ln>
+            <a:noFill/>
+          </a:ln>
+        </p:spPr>
+        <p:style>
+          <a:lnRef idx="1">
+            <a:schemeClr val="accent1"/>
+          </a:lnRef>
+          <a:fillRef idx="3">
+            <a:schemeClr val="accent1"/>
+          </a:fillRef>
+          <a:effectRef idx="2">
+            <a:schemeClr val="accent1"/>
+          </a:effectRef>
+          <a:fontRef idx="minor">
+            <a:schemeClr val="lt1"/>
+          </a:fontRef>
+        </p:style>
+        <p:txBody>
+          <a:bodyPr rtlCol="0" anchor="ctr"/>
+          <a:lstStyle/>
+          <a:p>
+            <a:pPr algn="ctr"/>
           </a:p>
         </p:txBody>
       </p:sp>
@@ -7393,8 +7527,8 @@
         </p:nvSpPr>
         <p:spPr>
           <a:xfrm>
-            <a:off x="1097280" y="6236208"/>
-            <a:ext cx="10058400" cy="256032"/>
+            <a:off x="11548872" y="6250838"/>
+            <a:ext cx="274320" cy="208483"/>
           </a:xfrm>
           <a:prstGeom prst="rect">
             <a:avLst/>
@@ -7407,50 +7541,15 @@
           </a:bodyPr>
           <a:lstStyle/>
           <a:p>
-            <a:pPr algn="l"/>
-            <a:r>
-              <a:rPr sz="800" b="0" i="1">
-                <a:solidFill>
-                  <a:srgbClr val="44546A"/>
+            <a:pPr algn="ctr"/>
+            <a:r>
+              <a:rPr sz="1000" b="1" i="0">
+                <a:solidFill>
+                  <a:srgbClr val="FFFFFF"/>
                 </a:solidFill>
                 <a:latin typeface="DM Sans"/>
               </a:rPr>
-              <a:t>Base: all respondents (n=200)</a:t>
-            </a:r>
-          </a:p>
-        </p:txBody>
-      </p:sp>
-      <p:sp>
-        <p:nvSpPr>
-          <p:cNvPr id="8" name="TextBox 7"/>
-          <p:cNvSpPr txBox="1"/>
-          <p:nvPr/>
-        </p:nvSpPr>
-        <p:spPr>
-          <a:xfrm>
-            <a:off x="11338560" y="6217920"/>
-            <a:ext cx="612648" cy="274320"/>
-          </a:xfrm>
-          <a:prstGeom prst="rect">
-            <a:avLst/>
-          </a:prstGeom>
-          <a:noFill/>
-        </p:spPr>
-        <p:txBody>
-          <a:bodyPr wrap="square">
-            <a:spAutoFit/>
-          </a:bodyPr>
-          <a:lstStyle/>
-          <a:p>
-            <a:pPr algn="r"/>
-            <a:r>
-              <a:rPr sz="800" b="0" i="0">
-                <a:solidFill>
-                  <a:srgbClr val="44546A"/>
-                </a:solidFill>
-                <a:latin typeface="DM Sans"/>
-              </a:rPr>
-              <a:t>2</a:t>
+              <a:t>1</a:t>
             </a:r>
           </a:p>
         </p:txBody>
@@ -7475,20 +7574,107 @@
       <p:grpSpPr/>
       <p:sp>
         <p:nvSpPr>
-          <p:cNvPr id="2" name="Rectangle 1"/>
+          <p:cNvPr id="2" name="Text Placeholder 1"/>
+          <p:cNvSpPr>
+            <a:spLocks noGrp="1"/>
+          </p:cNvSpPr>
+          <p:nvPr>
+            <p:ph type="body" idx="22" sz="quarter"/>
+          </p:nvPr>
+        </p:nvSpPr>
+        <p:spPr/>
+        <p:txBody>
+          <a:bodyPr/>
+          <a:lstStyle/>
+          <a:p>
+            <a:r>
+              <a:t>Base: all respondents (n=200)</a:t>
+            </a:r>
+          </a:p>
+        </p:txBody>
+      </p:sp>
+      <p:sp>
+        <p:nvSpPr>
+          <p:cNvPr id="3" name="Title 2"/>
+          <p:cNvSpPr>
+            <a:spLocks noGrp="1"/>
+          </p:cNvSpPr>
+          <p:nvPr>
+            <p:ph type="title"/>
+          </p:nvPr>
+        </p:nvSpPr>
+        <p:spPr/>
+        <p:txBody>
+          <a:bodyPr/>
+          <a:lstStyle/>
+          <a:p>
+            <a:r>
+              <a:t>Concern about the issue</a:t>
+            </a:r>
+          </a:p>
+        </p:txBody>
+      </p:sp>
+      <p:sp>
+        <p:nvSpPr>
+          <p:cNvPr id="4" name="Text Placeholder 3"/>
+          <p:cNvSpPr>
+            <a:spLocks noGrp="1"/>
+          </p:cNvSpPr>
+          <p:nvPr>
+            <p:ph type="body" idx="21" sz="quarter"/>
+          </p:nvPr>
+        </p:nvSpPr>
+        <p:spPr/>
+        <p:txBody>
+          <a:bodyPr/>
+          <a:lstStyle/>
+          <a:p>
+            <a:r>
+              <a:t>How concerned are you about this issue in your community? (%)</a:t>
+            </a:r>
+          </a:p>
+        </p:txBody>
+      </p:sp>
+      <p:pic>
+        <p:nvPicPr>
+          <p:cNvPr id="5" name="Picture 4" descr="image.png"/>
+          <p:cNvPicPr>
+            <a:picLocks noChangeAspect="1"/>
+          </p:cNvPicPr>
+          <p:nvPr/>
+        </p:nvPicPr>
+        <p:blipFill>
+          <a:blip r:embed="rId2"/>
+          <a:stretch>
+            <a:fillRect/>
+          </a:stretch>
+        </p:blipFill>
+        <p:spPr>
+          <a:xfrm>
+            <a:off x="310896" y="1709928"/>
+            <a:ext cx="5303520" cy="4251960"/>
+          </a:xfrm>
+          <a:prstGeom prst="rect">
+            <a:avLst/>
+          </a:prstGeom>
+        </p:spPr>
+      </p:pic>
+      <p:sp>
+        <p:nvSpPr>
+          <p:cNvPr id="6" name="Oval 5"/>
           <p:cNvSpPr/>
           <p:nvPr/>
         </p:nvSpPr>
         <p:spPr>
           <a:xfrm>
-            <a:off x="310896" y="1005840"/>
-            <a:ext cx="11878056" cy="27432"/>
-          </a:xfrm>
-          <a:prstGeom prst="rect">
+            <a:off x="4820716" y="2137958"/>
+            <a:ext cx="1133856" cy="1133856"/>
+          </a:xfrm>
+          <a:prstGeom prst="ellipse">
             <a:avLst/>
           </a:prstGeom>
           <a:solidFill>
-            <a:srgbClr val="027F7C"/>
+            <a:srgbClr val="00BDBB"/>
           </a:solidFill>
           <a:ln>
             <a:noFill/>
@@ -7518,14 +7704,14 @@
       </p:sp>
       <p:sp>
         <p:nvSpPr>
-          <p:cNvPr id="3" name="TextBox 2"/>
+          <p:cNvPr id="7" name="TextBox 6"/>
           <p:cNvSpPr txBox="1"/>
           <p:nvPr/>
         </p:nvSpPr>
         <p:spPr>
           <a:xfrm>
-            <a:off x="310896" y="201168"/>
-            <a:ext cx="11567160" cy="749808"/>
+            <a:off x="4820716" y="2251344"/>
+            <a:ext cx="1133856" cy="589605"/>
           </a:xfrm>
           <a:prstGeom prst="rect">
             <a:avLst/>
@@ -7538,29 +7724,29 @@
           </a:bodyPr>
           <a:lstStyle/>
           <a:p>
-            <a:pPr algn="l"/>
-            <a:r>
-              <a:rPr sz="1800" b="1" i="0">
-                <a:solidFill>
-                  <a:srgbClr val="A32015"/>
+            <a:pPr algn="ctr"/>
+            <a:r>
+              <a:rPr sz="3200" b="1" i="0">
+                <a:solidFill>
+                  <a:srgbClr val="FFFFFF"/>
                 </a:solidFill>
                 <a:latin typeface="DM Sans"/>
               </a:rPr>
-              <a:t>The government is handling this issue effectively.</a:t>
-            </a:r>
-          </a:p>
-        </p:txBody>
-      </p:sp>
-      <p:sp>
-        <p:nvSpPr>
-          <p:cNvPr id="4" name="TextBox 3"/>
+              <a:t>60%</a:t>
+            </a:r>
+          </a:p>
+        </p:txBody>
+      </p:sp>
+      <p:sp>
+        <p:nvSpPr>
+          <p:cNvPr id="8" name="TextBox 7"/>
           <p:cNvSpPr txBox="1"/>
           <p:nvPr/>
         </p:nvSpPr>
         <p:spPr>
           <a:xfrm>
-            <a:off x="310896" y="1042415"/>
-            <a:ext cx="8229600" cy="347472"/>
+            <a:off x="4820716" y="2795595"/>
+            <a:ext cx="1133856" cy="408188"/>
           </a:xfrm>
           <a:prstGeom prst="rect">
             <a:avLst/>
@@ -7573,53 +7759,72 @@
           </a:bodyPr>
           <a:lstStyle/>
           <a:p>
-            <a:pPr algn="l"/>
-            <a:r>
-              <a:rPr sz="1100" b="0" i="1">
-                <a:solidFill>
-                  <a:srgbClr val="44546A"/>
+            <a:pPr algn="ctr"/>
+            <a:r>
+              <a:rPr sz="1700" b="0" i="0">
+                <a:solidFill>
+                  <a:srgbClr val="FFFFFF"/>
                 </a:solidFill>
                 <a:latin typeface="DM Sans"/>
               </a:rPr>
-              <a:t>[govt_handling] (%)</a:t>
-            </a:r>
-          </a:p>
-        </p:txBody>
-      </p:sp>
-      <p:pic>
-        <p:nvPicPr>
-          <p:cNvPr id="5" name="Picture 4" descr="image.png"/>
-          <p:cNvPicPr>
-            <a:picLocks noChangeAspect="1"/>
-          </p:cNvPicPr>
+              <a:t>Concerned</a:t>
+            </a:r>
+          </a:p>
+        </p:txBody>
+      </p:sp>
+      <p:sp>
+        <p:nvSpPr>
+          <p:cNvPr id="9" name="Oval 8"/>
+          <p:cNvSpPr/>
           <p:nvPr/>
-        </p:nvPicPr>
-        <p:blipFill>
-          <a:blip r:embed="rId2"/>
-          <a:stretch>
-            <a:fillRect/>
-          </a:stretch>
-        </p:blipFill>
-        <p:spPr>
-          <a:xfrm>
-            <a:off x="310896" y="1463040"/>
-            <a:ext cx="6702552" cy="1645920"/>
-          </a:xfrm>
-          <a:prstGeom prst="rect">
-            <a:avLst/>
-          </a:prstGeom>
-        </p:spPr>
-      </p:pic>
-      <p:sp>
-        <p:nvSpPr>
-          <p:cNvPr id="6" name="TextBox 5"/>
+        </p:nvSpPr>
+        <p:spPr>
+          <a:xfrm>
+            <a:off x="4905755" y="4570079"/>
+            <a:ext cx="963777" cy="963777"/>
+          </a:xfrm>
+          <a:prstGeom prst="ellipse">
+            <a:avLst/>
+          </a:prstGeom>
+          <a:solidFill>
+            <a:srgbClr val="A32015"/>
+          </a:solidFill>
+          <a:ln>
+            <a:noFill/>
+          </a:ln>
+        </p:spPr>
+        <p:style>
+          <a:lnRef idx="1">
+            <a:schemeClr val="accent1"/>
+          </a:lnRef>
+          <a:fillRef idx="3">
+            <a:schemeClr val="accent1"/>
+          </a:fillRef>
+          <a:effectRef idx="2">
+            <a:schemeClr val="accent1"/>
+          </a:effectRef>
+          <a:fontRef idx="minor">
+            <a:schemeClr val="lt1"/>
+          </a:fontRef>
+        </p:style>
+        <p:txBody>
+          <a:bodyPr rtlCol="0" anchor="ctr"/>
+          <a:lstStyle/>
+          <a:p>
+            <a:pPr algn="ctr"/>
+          </a:p>
+        </p:txBody>
+      </p:sp>
+      <p:sp>
+        <p:nvSpPr>
+          <p:cNvPr id="10" name="TextBox 9"/>
           <p:cNvSpPr txBox="1"/>
           <p:nvPr/>
         </p:nvSpPr>
         <p:spPr>
           <a:xfrm>
-            <a:off x="7434072" y="1463040"/>
-            <a:ext cx="4389119" cy="1645920"/>
+            <a:off x="4905755" y="4666457"/>
+            <a:ext cx="963777" cy="501164"/>
           </a:xfrm>
           <a:prstGeom prst="rect">
             <a:avLst/>
@@ -7632,50 +7837,29 @@
           </a:bodyPr>
           <a:lstStyle/>
           <a:p>
-            <a:r>
-              <a:rPr sz="1000" b="0">
-                <a:solidFill>
-                  <a:srgbClr val="44546A"/>
+            <a:pPr algn="ctr"/>
+            <a:r>
+              <a:rPr sz="2700" b="1" i="0">
+                <a:solidFill>
+                  <a:srgbClr val="FFFFFF"/>
                 </a:solidFill>
                 <a:latin typeface="DM Sans"/>
               </a:rPr>
-              <a:t>Add subgroup breakdowns here, e.g.:</a:t>
-            </a:r>
-          </a:p>
-          <a:p>
-            <a:r>
-              <a:rPr sz="1000" b="0">
-                <a:solidFill>
-                  <a:srgbClr val="44546A"/>
-                </a:solidFill>
-                <a:latin typeface="DM Sans"/>
-              </a:rPr>
-              <a:t>– Under 30:  XX%</a:t>
-            </a:r>
-          </a:p>
-          <a:p>
-            <a:r>
-              <a:rPr sz="1000" b="0">
-                <a:solidFill>
-                  <a:srgbClr val="44546A"/>
-                </a:solidFill>
-                <a:latin typeface="DM Sans"/>
-              </a:rPr>
-              <a:t>– 30–44:     XX%</a:t>
-            </a:r>
-          </a:p>
-        </p:txBody>
-      </p:sp>
-      <p:sp>
-        <p:nvSpPr>
-          <p:cNvPr id="7" name="TextBox 6"/>
+              <a:t>15%</a:t>
+            </a:r>
+          </a:p>
+        </p:txBody>
+      </p:sp>
+      <p:sp>
+        <p:nvSpPr>
+          <p:cNvPr id="11" name="TextBox 10"/>
           <p:cNvSpPr txBox="1"/>
           <p:nvPr/>
         </p:nvSpPr>
         <p:spPr>
           <a:xfrm>
-            <a:off x="1097280" y="6236208"/>
-            <a:ext cx="10058400" cy="256032"/>
+            <a:off x="4905755" y="5129070"/>
+            <a:ext cx="963777" cy="346959"/>
           </a:xfrm>
           <a:prstGeom prst="rect">
             <a:avLst/>
@@ -7688,29 +7872,29 @@
           </a:bodyPr>
           <a:lstStyle/>
           <a:p>
-            <a:pPr algn="l"/>
-            <a:r>
-              <a:rPr sz="800" b="0" i="1">
-                <a:solidFill>
-                  <a:srgbClr val="44546A"/>
+            <a:pPr algn="ctr"/>
+            <a:r>
+              <a:rPr sz="1400" b="0" i="0">
+                <a:solidFill>
+                  <a:srgbClr val="FFFFFF"/>
                 </a:solidFill>
                 <a:latin typeface="DM Sans"/>
               </a:rPr>
-              <a:t>Base: all respondents (n=200)</a:t>
-            </a:r>
-          </a:p>
-        </p:txBody>
-      </p:sp>
-      <p:sp>
-        <p:nvSpPr>
-          <p:cNvPr id="8" name="TextBox 7"/>
+              <a:t>Not concerned</a:t>
+            </a:r>
+          </a:p>
+        </p:txBody>
+      </p:sp>
+      <p:sp>
+        <p:nvSpPr>
+          <p:cNvPr id="12" name="TextBox 11"/>
           <p:cNvSpPr txBox="1"/>
           <p:nvPr/>
         </p:nvSpPr>
         <p:spPr>
           <a:xfrm>
-            <a:off x="11338560" y="6217920"/>
-            <a:ext cx="612648" cy="274320"/>
+            <a:off x="5760720" y="1709928"/>
+            <a:ext cx="6062472" cy="4251960"/>
           </a:xfrm>
           <a:prstGeom prst="rect">
             <a:avLst/>
@@ -7723,15 +7907,202 @@
           </a:bodyPr>
           <a:lstStyle/>
           <a:p>
-            <a:pPr algn="r"/>
-            <a:r>
-              <a:rPr sz="800" b="0" i="0">
+            <a:r>
+              <a:rPr sz="1000" b="0">
                 <a:solidFill>
                   <a:srgbClr val="44546A"/>
                 </a:solidFill>
                 <a:latin typeface="DM Sans"/>
               </a:rPr>
-              <a:t>3</a:t>
+              <a:t>Concern by age group:</a:t>
+            </a:r>
+          </a:p>
+          <a:p>
+            <a:r>
+              <a:rPr sz="1000" b="0">
+                <a:solidFill>
+                  <a:srgbClr val="44546A"/>
+                </a:solidFill>
+                <a:latin typeface="DM Sans"/>
+              </a:rPr>
+              <a:t>– 18–24:   XX% very/extremely concerned</a:t>
+            </a:r>
+          </a:p>
+          <a:p>
+            <a:r>
+              <a:rPr sz="1000" b="0">
+                <a:solidFill>
+                  <a:srgbClr val="44546A"/>
+                </a:solidFill>
+                <a:latin typeface="DM Sans"/>
+              </a:rPr>
+              <a:t>– 25–34:   XX%</a:t>
+            </a:r>
+          </a:p>
+          <a:p>
+            <a:r>
+              <a:rPr sz="1000" b="0">
+                <a:solidFill>
+                  <a:srgbClr val="44546A"/>
+                </a:solidFill>
+                <a:latin typeface="DM Sans"/>
+              </a:rPr>
+              <a:t>– 35–44:   XX%</a:t>
+            </a:r>
+          </a:p>
+          <a:p>
+            <a:r>
+              <a:rPr sz="1000" b="0">
+                <a:solidFill>
+                  <a:srgbClr val="44546A"/>
+                </a:solidFill>
+                <a:latin typeface="DM Sans"/>
+              </a:rPr>
+              <a:t>– 45–54:   XX%</a:t>
+            </a:r>
+          </a:p>
+          <a:p>
+            <a:r>
+              <a:rPr sz="1000" b="0">
+                <a:solidFill>
+                  <a:srgbClr val="44546A"/>
+                </a:solidFill>
+                <a:latin typeface="DM Sans"/>
+              </a:rPr>
+              <a:t>– 55+:     XX%</a:t>
+            </a:r>
+          </a:p>
+          <a:p>
+            <a:r>
+              <a:rPr sz="1000" b="0">
+                <a:solidFill>
+                  <a:srgbClr val="44546A"/>
+                </a:solidFill>
+                <a:latin typeface="DM Sans"/>
+              </a:rPr>
+              <a:t/>
+            </a:r>
+          </a:p>
+          <a:p>
+            <a:r>
+              <a:rPr sz="1000" b="0">
+                <a:solidFill>
+                  <a:srgbClr val="44546A"/>
+                </a:solidFill>
+                <a:latin typeface="DM Sans"/>
+              </a:rPr>
+              <a:t>Concern by region:</a:t>
+            </a:r>
+          </a:p>
+          <a:p>
+            <a:r>
+              <a:rPr sz="1000" b="0">
+                <a:solidFill>
+                  <a:srgbClr val="44546A"/>
+                </a:solidFill>
+                <a:latin typeface="DM Sans"/>
+              </a:rPr>
+              <a:t>– Metro:      XX%</a:t>
+            </a:r>
+          </a:p>
+          <a:p>
+            <a:r>
+              <a:rPr sz="1000" b="0">
+                <a:solidFill>
+                  <a:srgbClr val="44546A"/>
+                </a:solidFill>
+                <a:latin typeface="DM Sans"/>
+              </a:rPr>
+              <a:t>– Regional:   XX%</a:t>
+            </a:r>
+          </a:p>
+          <a:p>
+            <a:r>
+              <a:rPr sz="1000" b="0">
+                <a:solidFill>
+                  <a:srgbClr val="44546A"/>
+                </a:solidFill>
+                <a:latin typeface="DM Sans"/>
+              </a:rPr>
+              <a:t>– Rural:      XX%</a:t>
+            </a:r>
+          </a:p>
+        </p:txBody>
+      </p:sp>
+      <p:sp>
+        <p:nvSpPr>
+          <p:cNvPr id="13" name="Oval 12"/>
+          <p:cNvSpPr/>
+          <p:nvPr/>
+        </p:nvSpPr>
+        <p:spPr>
+          <a:xfrm>
+            <a:off x="11548872" y="6217920"/>
+            <a:ext cx="274320" cy="274320"/>
+          </a:xfrm>
+          <a:prstGeom prst="ellipse">
+            <a:avLst/>
+          </a:prstGeom>
+          <a:solidFill>
+            <a:srgbClr val="027F7C"/>
+          </a:solidFill>
+          <a:ln>
+            <a:noFill/>
+          </a:ln>
+        </p:spPr>
+        <p:style>
+          <a:lnRef idx="1">
+            <a:schemeClr val="accent1"/>
+          </a:lnRef>
+          <a:fillRef idx="3">
+            <a:schemeClr val="accent1"/>
+          </a:fillRef>
+          <a:effectRef idx="2">
+            <a:schemeClr val="accent1"/>
+          </a:effectRef>
+          <a:fontRef idx="minor">
+            <a:schemeClr val="lt1"/>
+          </a:fontRef>
+        </p:style>
+        <p:txBody>
+          <a:bodyPr rtlCol="0" anchor="ctr"/>
+          <a:lstStyle/>
+          <a:p>
+            <a:pPr algn="ctr"/>
+          </a:p>
+        </p:txBody>
+      </p:sp>
+      <p:sp>
+        <p:nvSpPr>
+          <p:cNvPr id="14" name="TextBox 13"/>
+          <p:cNvSpPr txBox="1"/>
+          <p:nvPr/>
+        </p:nvSpPr>
+        <p:spPr>
+          <a:xfrm>
+            <a:off x="11548872" y="6250838"/>
+            <a:ext cx="274320" cy="208483"/>
+          </a:xfrm>
+          <a:prstGeom prst="rect">
+            <a:avLst/>
+          </a:prstGeom>
+          <a:noFill/>
+        </p:spPr>
+        <p:txBody>
+          <a:bodyPr wrap="square">
+            <a:spAutoFit/>
+          </a:bodyPr>
+          <a:lstStyle/>
+          <a:p>
+            <a:pPr algn="ctr"/>
+            <a:r>
+              <a:rPr sz="1000" b="1" i="0">
+                <a:solidFill>
+                  <a:srgbClr val="FFFFFF"/>
+                </a:solidFill>
+                <a:latin typeface="DM Sans"/>
+              </a:rPr>
+              <a:t>2</a:t>
             </a:r>
           </a:p>
         </p:txBody>
@@ -7756,20 +8127,107 @@
       <p:grpSpPr/>
       <p:sp>
         <p:nvSpPr>
-          <p:cNvPr id="2" name="Rectangle 1"/>
+          <p:cNvPr id="2" name="Text Placeholder 1"/>
+          <p:cNvSpPr>
+            <a:spLocks noGrp="1"/>
+          </p:cNvSpPr>
+          <p:nvPr>
+            <p:ph type="body" idx="22" sz="quarter"/>
+          </p:nvPr>
+        </p:nvSpPr>
+        <p:spPr/>
+        <p:txBody>
+          <a:bodyPr/>
+          <a:lstStyle/>
+          <a:p>
+            <a:r>
+              <a:t>Base: all respondents (n=200)</a:t>
+            </a:r>
+          </a:p>
+        </p:txBody>
+      </p:sp>
+      <p:sp>
+        <p:nvSpPr>
+          <p:cNvPr id="3" name="Title 2"/>
+          <p:cNvSpPr>
+            <a:spLocks noGrp="1"/>
+          </p:cNvSpPr>
+          <p:nvPr>
+            <p:ph type="title"/>
+          </p:nvPr>
+        </p:nvSpPr>
+        <p:spPr/>
+        <p:txBody>
+          <a:bodyPr/>
+          <a:lstStyle/>
+          <a:p>
+            <a:r>
+              <a:t>Rating — government handling of this issue</a:t>
+            </a:r>
+          </a:p>
+        </p:txBody>
+      </p:sp>
+      <p:sp>
+        <p:nvSpPr>
+          <p:cNvPr id="4" name="Text Placeholder 3"/>
+          <p:cNvSpPr>
+            <a:spLocks noGrp="1"/>
+          </p:cNvSpPr>
+          <p:nvPr>
+            <p:ph type="body" idx="21" sz="quarter"/>
+          </p:nvPr>
+        </p:nvSpPr>
+        <p:spPr/>
+        <p:txBody>
+          <a:bodyPr/>
+          <a:lstStyle/>
+          <a:p>
+            <a:r>
+              <a:t>The government is handling this issue effectively. (%)</a:t>
+            </a:r>
+          </a:p>
+        </p:txBody>
+      </p:sp>
+      <p:pic>
+        <p:nvPicPr>
+          <p:cNvPr id="5" name="Picture 4" descr="image.png"/>
+          <p:cNvPicPr>
+            <a:picLocks noChangeAspect="1"/>
+          </p:cNvPicPr>
+          <p:nvPr/>
+        </p:nvPicPr>
+        <p:blipFill>
+          <a:blip r:embed="rId2"/>
+          <a:stretch>
+            <a:fillRect/>
+          </a:stretch>
+        </p:blipFill>
+        <p:spPr>
+          <a:xfrm>
+            <a:off x="310896" y="1709928"/>
+            <a:ext cx="5303520" cy="4251960"/>
+          </a:xfrm>
+          <a:prstGeom prst="rect">
+            <a:avLst/>
+          </a:prstGeom>
+        </p:spPr>
+      </p:pic>
+      <p:sp>
+        <p:nvSpPr>
+          <p:cNvPr id="6" name="Oval 5"/>
           <p:cNvSpPr/>
           <p:nvPr/>
         </p:nvSpPr>
         <p:spPr>
           <a:xfrm>
-            <a:off x="310896" y="1005840"/>
-            <a:ext cx="11878056" cy="27432"/>
-          </a:xfrm>
-          <a:prstGeom prst="rect">
+            <a:off x="4820716" y="2137958"/>
+            <a:ext cx="1133856" cy="1133856"/>
+          </a:xfrm>
+          <a:prstGeom prst="ellipse">
             <a:avLst/>
           </a:prstGeom>
           <a:solidFill>
-            <a:srgbClr val="027F7C"/>
+            <a:srgbClr val="00BDBB"/>
           </a:solidFill>
           <a:ln>
             <a:noFill/>
@@ -7799,14 +8257,14 @@
       </p:sp>
       <p:sp>
         <p:nvSpPr>
-          <p:cNvPr id="3" name="TextBox 2"/>
+          <p:cNvPr id="7" name="TextBox 6"/>
           <p:cNvSpPr txBox="1"/>
           <p:nvPr/>
         </p:nvSpPr>
         <p:spPr>
           <a:xfrm>
-            <a:off x="310896" y="201168"/>
-            <a:ext cx="11567160" cy="749808"/>
+            <a:off x="4820716" y="2251344"/>
+            <a:ext cx="1133856" cy="589605"/>
           </a:xfrm>
           <a:prstGeom prst="rect">
             <a:avLst/>
@@ -7819,29 +8277,29 @@
           </a:bodyPr>
           <a:lstStyle/>
           <a:p>
-            <a:pPr algn="l"/>
-            <a:r>
-              <a:rPr sz="1800" b="1" i="0">
-                <a:solidFill>
-                  <a:srgbClr val="A32015"/>
+            <a:pPr algn="ctr"/>
+            <a:r>
+              <a:rPr sz="3200" b="1" i="0">
+                <a:solidFill>
+                  <a:srgbClr val="FFFFFF"/>
                 </a:solidFill>
                 <a:latin typeface="DM Sans"/>
               </a:rPr>
-              <a:t>Stmt</a:t>
-            </a:r>
-          </a:p>
-        </p:txBody>
-      </p:sp>
-      <p:sp>
-        <p:nvSpPr>
-          <p:cNvPr id="4" name="TextBox 3"/>
+              <a:t>23%</a:t>
+            </a:r>
+          </a:p>
+        </p:txBody>
+      </p:sp>
+      <p:sp>
+        <p:nvSpPr>
+          <p:cNvPr id="8" name="TextBox 7"/>
           <p:cNvSpPr txBox="1"/>
           <p:nvPr/>
         </p:nvSpPr>
         <p:spPr>
           <a:xfrm>
-            <a:off x="310896" y="1042415"/>
-            <a:ext cx="8229600" cy="347472"/>
+            <a:off x="4820716" y="2795595"/>
+            <a:ext cx="1133856" cy="408188"/>
           </a:xfrm>
           <a:prstGeom prst="rect">
             <a:avLst/>
@@ -7854,59 +8312,35 @@
           </a:bodyPr>
           <a:lstStyle/>
           <a:p>
-            <a:pPr algn="l"/>
-            <a:r>
-              <a:rPr sz="1100" b="0" i="1">
-                <a:solidFill>
-                  <a:srgbClr val="44546A"/>
+            <a:pPr algn="ctr"/>
+            <a:r>
+              <a:rPr sz="1700" b="0" i="0">
+                <a:solidFill>
+                  <a:srgbClr val="FFFFFF"/>
                 </a:solidFill>
                 <a:latin typeface="DM Sans"/>
               </a:rPr>
-              <a:t>(%)</a:t>
-            </a:r>
-          </a:p>
-        </p:txBody>
-      </p:sp>
-      <p:pic>
-        <p:nvPicPr>
-          <p:cNvPr id="5" name="Picture 4" descr="image.png"/>
-          <p:cNvPicPr>
-            <a:picLocks noChangeAspect="1"/>
-          </p:cNvPicPr>
-          <p:nvPr/>
-        </p:nvPicPr>
-        <p:blipFill>
-          <a:blip r:embed="rId2"/>
-          <a:stretch>
-            <a:fillRect/>
-          </a:stretch>
-        </p:blipFill>
-        <p:spPr>
-          <a:xfrm>
-            <a:off x="310896" y="1463040"/>
-            <a:ext cx="6099048" cy="2880360"/>
-          </a:xfrm>
-          <a:prstGeom prst="rect">
-            <a:avLst/>
-          </a:prstGeom>
-        </p:spPr>
-      </p:pic>
-      <p:sp>
-        <p:nvSpPr>
-          <p:cNvPr id="6" name="Oval 5"/>
+              <a:t>Agree</a:t>
+            </a:r>
+          </a:p>
+        </p:txBody>
+      </p:sp>
+      <p:sp>
+        <p:nvSpPr>
+          <p:cNvPr id="9" name="Oval 8"/>
           <p:cNvSpPr/>
           <p:nvPr/>
         </p:nvSpPr>
         <p:spPr>
           <a:xfrm>
-            <a:off x="5023850" y="1686747"/>
-            <a:ext cx="637519" cy="637519"/>
+            <a:off x="4905755" y="4570079"/>
+            <a:ext cx="963777" cy="963777"/>
           </a:xfrm>
           <a:prstGeom prst="ellipse">
             <a:avLst/>
           </a:prstGeom>
           <a:solidFill>
-            <a:srgbClr val="00BDBB"/>
+            <a:srgbClr val="A32015"/>
           </a:solidFill>
           <a:ln>
             <a:noFill/>
@@ -7936,14 +8370,14 @@
       </p:sp>
       <p:sp>
         <p:nvSpPr>
-          <p:cNvPr id="7" name="TextBox 6"/>
+          <p:cNvPr id="10" name="TextBox 9"/>
           <p:cNvSpPr txBox="1"/>
           <p:nvPr/>
         </p:nvSpPr>
         <p:spPr>
           <a:xfrm>
-            <a:off x="5023850" y="1827002"/>
-            <a:ext cx="637519" cy="357011"/>
+            <a:off x="4905755" y="4666457"/>
+            <a:ext cx="963777" cy="501164"/>
           </a:xfrm>
           <a:prstGeom prst="rect">
             <a:avLst/>
@@ -7958,33 +8392,157 @@
           <a:p>
             <a:pPr algn="ctr"/>
             <a:r>
-              <a:rPr sz="1800" b="1" i="0">
+              <a:rPr sz="2700" b="1" i="0">
                 <a:solidFill>
                   <a:srgbClr val="FFFFFF"/>
                 </a:solidFill>
                 <a:latin typeface="DM Sans"/>
               </a:rPr>
-              <a:t>85%</a:t>
-            </a:r>
-          </a:p>
-        </p:txBody>
-      </p:sp>
-      <p:sp>
-        <p:nvSpPr>
-          <p:cNvPr id="8" name="Oval 7"/>
+              <a:t>60%</a:t>
+            </a:r>
+          </a:p>
+        </p:txBody>
+      </p:sp>
+      <p:sp>
+        <p:nvSpPr>
+          <p:cNvPr id="11" name="TextBox 10"/>
+          <p:cNvSpPr txBox="1"/>
+          <p:nvPr/>
+        </p:nvSpPr>
+        <p:spPr>
+          <a:xfrm>
+            <a:off x="4905755" y="5129070"/>
+            <a:ext cx="963777" cy="346959"/>
+          </a:xfrm>
+          <a:prstGeom prst="rect">
+            <a:avLst/>
+          </a:prstGeom>
+          <a:noFill/>
+        </p:spPr>
+        <p:txBody>
+          <a:bodyPr wrap="square">
+            <a:spAutoFit/>
+          </a:bodyPr>
+          <a:lstStyle/>
+          <a:p>
+            <a:pPr algn="ctr"/>
+            <a:r>
+              <a:rPr sz="1400" b="0" i="0">
+                <a:solidFill>
+                  <a:srgbClr val="FFFFFF"/>
+                </a:solidFill>
+                <a:latin typeface="DM Sans"/>
+              </a:rPr>
+              <a:t>Disagree</a:t>
+            </a:r>
+          </a:p>
+        </p:txBody>
+      </p:sp>
+      <p:sp>
+        <p:nvSpPr>
+          <p:cNvPr id="12" name="TextBox 11"/>
+          <p:cNvSpPr txBox="1"/>
+          <p:nvPr/>
+        </p:nvSpPr>
+        <p:spPr>
+          <a:xfrm>
+            <a:off x="5760720" y="1709928"/>
+            <a:ext cx="6062472" cy="4251960"/>
+          </a:xfrm>
+          <a:prstGeom prst="rect">
+            <a:avLst/>
+          </a:prstGeom>
+          <a:noFill/>
+        </p:spPr>
+        <p:txBody>
+          <a:bodyPr wrap="square">
+            <a:spAutoFit/>
+          </a:bodyPr>
+          <a:lstStyle/>
+          <a:p>
+            <a:r>
+              <a:rPr sz="1000" b="0">
+                <a:solidFill>
+                  <a:srgbClr val="44546A"/>
+                </a:solidFill>
+                <a:latin typeface="DM Sans"/>
+              </a:rPr>
+              <a:t>Scepticism about government performance</a:t>
+            </a:r>
+          </a:p>
+          <a:p>
+            <a:r>
+              <a:rPr sz="1000" b="0">
+                <a:solidFill>
+                  <a:srgbClr val="44546A"/>
+                </a:solidFill>
+                <a:latin typeface="DM Sans"/>
+              </a:rPr>
+              <a:t>is consistent across all demographics.</a:t>
+            </a:r>
+          </a:p>
+          <a:p>
+            <a:r>
+              <a:rPr sz="1000" b="0">
+                <a:solidFill>
+                  <a:srgbClr val="44546A"/>
+                </a:solidFill>
+                <a:latin typeface="DM Sans"/>
+              </a:rPr>
+              <a:t/>
+            </a:r>
+          </a:p>
+          <a:p>
+            <a:r>
+              <a:rPr sz="1000" b="0">
+                <a:solidFill>
+                  <a:srgbClr val="44546A"/>
+                </a:solidFill>
+                <a:latin typeface="DM Sans"/>
+              </a:rPr>
+              <a:t>Disagreement is highest among:</a:t>
+            </a:r>
+          </a:p>
+          <a:p>
+            <a:r>
+              <a:rPr sz="1000" b="0">
+                <a:solidFill>
+                  <a:srgbClr val="44546A"/>
+                </a:solidFill>
+                <a:latin typeface="DM Sans"/>
+              </a:rPr>
+              <a:t>– 35–54 year olds (XX%)</a:t>
+            </a:r>
+          </a:p>
+          <a:p>
+            <a:r>
+              <a:rPr sz="1000" b="0">
+                <a:solidFill>
+                  <a:srgbClr val="44546A"/>
+                </a:solidFill>
+                <a:latin typeface="DM Sans"/>
+              </a:rPr>
+              <a:t>– Regional residents (XX%)</a:t>
+            </a:r>
+          </a:p>
+        </p:txBody>
+      </p:sp>
+      <p:sp>
+        <p:nvSpPr>
+          <p:cNvPr id="13" name="Oval 12"/>
           <p:cNvSpPr/>
           <p:nvPr/>
         </p:nvSpPr>
         <p:spPr>
           <a:xfrm>
-            <a:off x="4840879" y="2483647"/>
-            <a:ext cx="637519" cy="637519"/>
+            <a:off x="11548872" y="6217920"/>
+            <a:ext cx="274320" cy="274320"/>
           </a:xfrm>
           <a:prstGeom prst="ellipse">
             <a:avLst/>
           </a:prstGeom>
           <a:solidFill>
-            <a:srgbClr val="00BDBB"/>
+            <a:srgbClr val="027F7C"/>
           </a:solidFill>
           <a:ln>
             <a:noFill/>
@@ -8014,14 +8572,14 @@
       </p:sp>
       <p:sp>
         <p:nvSpPr>
-          <p:cNvPr id="9" name="TextBox 8"/>
+          <p:cNvPr id="14" name="TextBox 13"/>
           <p:cNvSpPr txBox="1"/>
           <p:nvPr/>
         </p:nvSpPr>
         <p:spPr>
           <a:xfrm>
-            <a:off x="4840879" y="2623901"/>
-            <a:ext cx="637519" cy="357011"/>
+            <a:off x="11548872" y="6250838"/>
+            <a:ext cx="274320" cy="208483"/>
           </a:xfrm>
           <a:prstGeom prst="rect">
             <a:avLst/>
@@ -8036,219 +8594,13 @@
           <a:p>
             <a:pPr algn="ctr"/>
             <a:r>
-              <a:rPr sz="1800" b="1" i="0">
+              <a:rPr sz="1000" b="1" i="0">
                 <a:solidFill>
                   <a:srgbClr val="FFFFFF"/>
                 </a:solidFill>
                 <a:latin typeface="DM Sans"/>
               </a:rPr>
-              <a:t>79%</a:t>
-            </a:r>
-          </a:p>
-        </p:txBody>
-      </p:sp>
-      <p:sp>
-        <p:nvSpPr>
-          <p:cNvPr id="10" name="Oval 9"/>
-          <p:cNvSpPr/>
-          <p:nvPr/>
-        </p:nvSpPr>
-        <p:spPr>
-          <a:xfrm>
-            <a:off x="5023850" y="3280547"/>
-            <a:ext cx="637519" cy="637519"/>
-          </a:xfrm>
-          <a:prstGeom prst="ellipse">
-            <a:avLst/>
-          </a:prstGeom>
-          <a:solidFill>
-            <a:srgbClr val="00BDBB"/>
-          </a:solidFill>
-          <a:ln>
-            <a:noFill/>
-          </a:ln>
-        </p:spPr>
-        <p:style>
-          <a:lnRef idx="1">
-            <a:schemeClr val="accent1"/>
-          </a:lnRef>
-          <a:fillRef idx="3">
-            <a:schemeClr val="accent1"/>
-          </a:fillRef>
-          <a:effectRef idx="2">
-            <a:schemeClr val="accent1"/>
-          </a:effectRef>
-          <a:fontRef idx="minor">
-            <a:schemeClr val="lt1"/>
-          </a:fontRef>
-        </p:style>
-        <p:txBody>
-          <a:bodyPr rtlCol="0" anchor="ctr"/>
-          <a:lstStyle/>
-          <a:p>
-            <a:pPr algn="ctr"/>
-          </a:p>
-        </p:txBody>
-      </p:sp>
-      <p:sp>
-        <p:nvSpPr>
-          <p:cNvPr id="11" name="TextBox 10"/>
-          <p:cNvSpPr txBox="1"/>
-          <p:nvPr/>
-        </p:nvSpPr>
-        <p:spPr>
-          <a:xfrm>
-            <a:off x="5023850" y="3420801"/>
-            <a:ext cx="637519" cy="357011"/>
-          </a:xfrm>
-          <a:prstGeom prst="rect">
-            <a:avLst/>
-          </a:prstGeom>
-          <a:noFill/>
-        </p:spPr>
-        <p:txBody>
-          <a:bodyPr wrap="square">
-            <a:spAutoFit/>
-          </a:bodyPr>
-          <a:lstStyle/>
-          <a:p>
-            <a:pPr algn="ctr"/>
-            <a:r>
-              <a:rPr sz="1800" b="1" i="0">
-                <a:solidFill>
-                  <a:srgbClr val="FFFFFF"/>
-                </a:solidFill>
-                <a:latin typeface="DM Sans"/>
-              </a:rPr>
-              <a:t>85%</a:t>
-            </a:r>
-          </a:p>
-        </p:txBody>
-      </p:sp>
-      <p:pic>
-        <p:nvPicPr>
-          <p:cNvPr id="12" name="Picture 11" descr="image.png"/>
-          <p:cNvPicPr>
-            <a:picLocks noChangeAspect="1"/>
-          </p:cNvPicPr>
-          <p:nvPr/>
-        </p:nvPicPr>
-        <p:blipFill>
-          <a:blip r:embed="rId3"/>
-          <a:stretch>
-            <a:fillRect/>
-          </a:stretch>
-        </p:blipFill>
-        <p:spPr>
-          <a:xfrm>
-            <a:off x="310896" y="4416552"/>
-            <a:ext cx="6099048" cy="274320"/>
-          </a:xfrm>
-          <a:prstGeom prst="rect">
-            <a:avLst/>
-          </a:prstGeom>
-        </p:spPr>
-      </p:pic>
-      <p:sp>
-        <p:nvSpPr>
-          <p:cNvPr id="13" name="TextBox 12"/>
-          <p:cNvSpPr txBox="1"/>
-          <p:nvPr/>
-        </p:nvSpPr>
-        <p:spPr>
-          <a:xfrm>
-            <a:off x="7068312" y="1463040"/>
-            <a:ext cx="4754879" cy="2880360"/>
-          </a:xfrm>
-          <a:prstGeom prst="rect">
-            <a:avLst/>
-          </a:prstGeom>
-          <a:noFill/>
-        </p:spPr>
-        <p:txBody>
-          <a:bodyPr wrap="square">
-            <a:spAutoFit/>
-          </a:bodyPr>
-          <a:lstStyle/>
-          <a:p>
-            <a:r>
-              <a:rPr sz="1000" b="0">
-                <a:solidFill>
-                  <a:srgbClr val="44546A"/>
-                </a:solidFill>
-                <a:latin typeface="DM Sans"/>
-              </a:rPr>
-              <a:t>Add commentary here.</a:t>
-            </a:r>
-          </a:p>
-        </p:txBody>
-      </p:sp>
-      <p:sp>
-        <p:nvSpPr>
-          <p:cNvPr id="14" name="TextBox 13"/>
-          <p:cNvSpPr txBox="1"/>
-          <p:nvPr/>
-        </p:nvSpPr>
-        <p:spPr>
-          <a:xfrm>
-            <a:off x="1097280" y="6236208"/>
-            <a:ext cx="10058400" cy="256032"/>
-          </a:xfrm>
-          <a:prstGeom prst="rect">
-            <a:avLst/>
-          </a:prstGeom>
-          <a:noFill/>
-        </p:spPr>
-        <p:txBody>
-          <a:bodyPr wrap="square">
-            <a:spAutoFit/>
-          </a:bodyPr>
-          <a:lstStyle/>
-          <a:p>
-            <a:pPr algn="l"/>
-            <a:r>
-              <a:rPr sz="800" b="0" i="1">
-                <a:solidFill>
-                  <a:srgbClr val="44546A"/>
-                </a:solidFill>
-                <a:latin typeface="DM Sans"/>
-              </a:rPr>
-              <a:t>Base: all respondents (n=200)</a:t>
-            </a:r>
-          </a:p>
-        </p:txBody>
-      </p:sp>
-      <p:sp>
-        <p:nvSpPr>
-          <p:cNvPr id="15" name="TextBox 14"/>
-          <p:cNvSpPr txBox="1"/>
-          <p:nvPr/>
-        </p:nvSpPr>
-        <p:spPr>
-          <a:xfrm>
-            <a:off x="11338560" y="6217920"/>
-            <a:ext cx="612648" cy="274320"/>
-          </a:xfrm>
-          <a:prstGeom prst="rect">
-            <a:avLst/>
-          </a:prstGeom>
-          <a:noFill/>
-        </p:spPr>
-        <p:txBody>
-          <a:bodyPr wrap="square">
-            <a:spAutoFit/>
-          </a:bodyPr>
-          <a:lstStyle/>
-          <a:p>
-            <a:pPr algn="r"/>
-            <a:r>
-              <a:rPr sz="800" b="0" i="0">
-                <a:solidFill>
-                  <a:srgbClr val="44546A"/>
-                </a:solidFill>
-                <a:latin typeface="DM Sans"/>
-              </a:rPr>
-              <a:t>4</a:t>
+              <a:t>3</a:t>
             </a:r>
           </a:p>
         </p:txBody>
@@ -8279,8 +8631,8 @@
         </p:nvSpPr>
         <p:spPr>
           <a:xfrm>
-            <a:off x="310896" y="1005840"/>
-            <a:ext cx="11878056" cy="27432"/>
+            <a:off x="0" y="0"/>
+            <a:ext cx="12188952" cy="6858000"/>
           </a:xfrm>
           <a:prstGeom prst="rect">
             <a:avLst/>
@@ -8322,8 +8674,8 @@
         </p:nvSpPr>
         <p:spPr>
           <a:xfrm>
-            <a:off x="310896" y="201168"/>
-            <a:ext cx="11567160" cy="749808"/>
+            <a:off x="612648" y="2743200"/>
+            <a:ext cx="10972800" cy="1097280"/>
           </a:xfrm>
           <a:prstGeom prst="rect">
             <a:avLst/>
@@ -8338,198 +8690,13 @@
           <a:p>
             <a:pPr algn="l"/>
             <a:r>
-              <a:rPr sz="1800" b="1" i="0">
-                <a:solidFill>
-                  <a:srgbClr val="A32015"/>
+              <a:rPr sz="2800" b="1" i="0">
+                <a:solidFill>
+                  <a:srgbClr val="FFFFFF"/>
                 </a:solidFill>
                 <a:latin typeface="DM Sans"/>
               </a:rPr>
-              <a:t>Which region are you based in?</a:t>
-            </a:r>
-          </a:p>
-        </p:txBody>
-      </p:sp>
-      <p:sp>
-        <p:nvSpPr>
-          <p:cNvPr id="4" name="TextBox 3"/>
-          <p:cNvSpPr txBox="1"/>
-          <p:nvPr/>
-        </p:nvSpPr>
-        <p:spPr>
-          <a:xfrm>
-            <a:off x="310896" y="1042415"/>
-            <a:ext cx="8229600" cy="347472"/>
-          </a:xfrm>
-          <a:prstGeom prst="rect">
-            <a:avLst/>
-          </a:prstGeom>
-          <a:noFill/>
-        </p:spPr>
-        <p:txBody>
-          <a:bodyPr wrap="square">
-            <a:spAutoFit/>
-          </a:bodyPr>
-          <a:lstStyle/>
-          <a:p>
-            <a:pPr algn="l"/>
-            <a:r>
-              <a:rPr sz="1100" b="0" i="1">
-                <a:solidFill>
-                  <a:srgbClr val="44546A"/>
-                </a:solidFill>
-                <a:latin typeface="DM Sans"/>
-              </a:rPr>
-              <a:t>[region] (%)</a:t>
-            </a:r>
-          </a:p>
-        </p:txBody>
-      </p:sp>
-      <p:pic>
-        <p:nvPicPr>
-          <p:cNvPr id="5" name="Picture 4" descr="image.png"/>
-          <p:cNvPicPr>
-            <a:picLocks noChangeAspect="1"/>
-          </p:cNvPicPr>
-          <p:nvPr/>
-        </p:nvPicPr>
-        <p:blipFill>
-          <a:blip r:embed="rId2"/>
-          <a:stretch>
-            <a:fillRect/>
-          </a:stretch>
-        </p:blipFill>
-        <p:spPr>
-          <a:xfrm>
-            <a:off x="310896" y="1463040"/>
-            <a:ext cx="6702552" cy="1645920"/>
-          </a:xfrm>
-          <a:prstGeom prst="rect">
-            <a:avLst/>
-          </a:prstGeom>
-        </p:spPr>
-      </p:pic>
-      <p:sp>
-        <p:nvSpPr>
-          <p:cNvPr id="6" name="TextBox 5"/>
-          <p:cNvSpPr txBox="1"/>
-          <p:nvPr/>
-        </p:nvSpPr>
-        <p:spPr>
-          <a:xfrm>
-            <a:off x="7434072" y="1463040"/>
-            <a:ext cx="4389119" cy="1645920"/>
-          </a:xfrm>
-          <a:prstGeom prst="rect">
-            <a:avLst/>
-          </a:prstGeom>
-          <a:noFill/>
-        </p:spPr>
-        <p:txBody>
-          <a:bodyPr wrap="square">
-            <a:spAutoFit/>
-          </a:bodyPr>
-          <a:lstStyle/>
-          <a:p>
-            <a:r>
-              <a:rPr sz="1000" b="0">
-                <a:solidFill>
-                  <a:srgbClr val="44546A"/>
-                </a:solidFill>
-                <a:latin typeface="DM Sans"/>
-              </a:rPr>
-              <a:t>Add subgroup breakdowns here, e.g.:</a:t>
-            </a:r>
-          </a:p>
-          <a:p>
-            <a:r>
-              <a:rPr sz="1000" b="0">
-                <a:solidFill>
-                  <a:srgbClr val="44546A"/>
-                </a:solidFill>
-                <a:latin typeface="DM Sans"/>
-              </a:rPr>
-              <a:t>– Under 30:  XX%</a:t>
-            </a:r>
-          </a:p>
-          <a:p>
-            <a:r>
-              <a:rPr sz="1000" b="0">
-                <a:solidFill>
-                  <a:srgbClr val="44546A"/>
-                </a:solidFill>
-                <a:latin typeface="DM Sans"/>
-              </a:rPr>
-              <a:t>– 30–44:     XX%</a:t>
-            </a:r>
-          </a:p>
-        </p:txBody>
-      </p:sp>
-      <p:sp>
-        <p:nvSpPr>
-          <p:cNvPr id="7" name="TextBox 6"/>
-          <p:cNvSpPr txBox="1"/>
-          <p:nvPr/>
-        </p:nvSpPr>
-        <p:spPr>
-          <a:xfrm>
-            <a:off x="1097280" y="6236208"/>
-            <a:ext cx="10058400" cy="256032"/>
-          </a:xfrm>
-          <a:prstGeom prst="rect">
-            <a:avLst/>
-          </a:prstGeom>
-          <a:noFill/>
-        </p:spPr>
-        <p:txBody>
-          <a:bodyPr wrap="square">
-            <a:spAutoFit/>
-          </a:bodyPr>
-          <a:lstStyle/>
-          <a:p>
-            <a:pPr algn="l"/>
-            <a:r>
-              <a:rPr sz="800" b="0" i="1">
-                <a:solidFill>
-                  <a:srgbClr val="44546A"/>
-                </a:solidFill>
-                <a:latin typeface="DM Sans"/>
-              </a:rPr>
-              <a:t>Base: all respondents (n=200)</a:t>
-            </a:r>
-          </a:p>
-        </p:txBody>
-      </p:sp>
-      <p:sp>
-        <p:nvSpPr>
-          <p:cNvPr id="8" name="TextBox 7"/>
-          <p:cNvSpPr txBox="1"/>
-          <p:nvPr/>
-        </p:nvSpPr>
-        <p:spPr>
-          <a:xfrm>
-            <a:off x="11338560" y="6217920"/>
-            <a:ext cx="612648" cy="274320"/>
-          </a:xfrm>
-          <a:prstGeom prst="rect">
-            <a:avLst/>
-          </a:prstGeom>
-          <a:noFill/>
-        </p:spPr>
-        <p:txBody>
-          <a:bodyPr wrap="square">
-            <a:spAutoFit/>
-          </a:bodyPr>
-          <a:lstStyle/>
-          <a:p>
-            <a:pPr algn="r"/>
-            <a:r>
-              <a:rPr sz="800" b="0" i="0">
-                <a:solidFill>
-                  <a:srgbClr val="44546A"/>
-                </a:solidFill>
-                <a:latin typeface="DM Sans"/>
-              </a:rPr>
-              <a:t>5</a:t>
+              <a:t>Attitudes &amp; Beliefs</a:t>
             </a:r>
           </a:p>
         </p:txBody>
@@ -8554,16 +8721,246 @@
       <p:grpSpPr/>
       <p:sp>
         <p:nvSpPr>
-          <p:cNvPr id="2" name="Rectangle 1"/>
+          <p:cNvPr id="2" name="Title 1"/>
+          <p:cNvSpPr>
+            <a:spLocks noGrp="1"/>
+          </p:cNvSpPr>
+          <p:nvPr>
+            <p:ph type="title"/>
+          </p:nvPr>
+        </p:nvSpPr>
+        <p:spPr/>
+        <p:txBody>
+          <a:bodyPr/>
+          <a:lstStyle/>
+          <a:p>
+            <a:r>
+              <a:t>Agreement — statements about the issue</a:t>
+            </a:r>
+          </a:p>
+        </p:txBody>
+      </p:sp>
+      <p:sp>
+        <p:nvSpPr>
+          <p:cNvPr id="3" name="Text Placeholder 2"/>
+          <p:cNvSpPr>
+            <a:spLocks noGrp="1"/>
+          </p:cNvSpPr>
+          <p:nvPr>
+            <p:ph type="body" idx="12" sz="quarter"/>
+          </p:nvPr>
+        </p:nvSpPr>
+        <p:spPr/>
+        <p:txBody>
+          <a:bodyPr/>
+          <a:lstStyle/>
+          <a:p/>
+        </p:txBody>
+      </p:sp>
+      <p:sp>
+        <p:nvSpPr>
+          <p:cNvPr id="4" name="Text Placeholder 3"/>
+          <p:cNvSpPr>
+            <a:spLocks noGrp="1"/>
+          </p:cNvSpPr>
+          <p:nvPr>
+            <p:ph type="body" idx="19" sz="quarter"/>
+          </p:nvPr>
+        </p:nvSpPr>
+        <p:spPr/>
+        <p:txBody>
+          <a:bodyPr/>
+          <a:lstStyle/>
+          <a:p>
+            <a:r>
+              <a:t>Total agree by statement:</a:t>
+            </a:r>
+          </a:p>
+          <a:p>
+            <a:r>
+              <a:t>– Community impact:   XX%</a:t>
+            </a:r>
+          </a:p>
+          <a:p>
+            <a:r>
+              <a:t>– Govt leadership:    XX%</a:t>
+            </a:r>
+          </a:p>
+          <a:p>
+            <a:r>
+              <a:t>– Local action:       XX%</a:t>
+            </a:r>
+          </a:p>
+          <a:p>
+            <a:r>
+              <a:t/>
+            </a:r>
+          </a:p>
+          <a:p>
+            <a:r>
+              <a:t>Agreement is broadly consistent</a:t>
+            </a:r>
+          </a:p>
+          <a:p>
+            <a:r>
+              <a:t>across age groups and regions.</a:t>
+            </a:r>
+          </a:p>
+        </p:txBody>
+      </p:sp>
+      <p:sp>
+        <p:nvSpPr>
+          <p:cNvPr id="5" name="Text Placeholder 4"/>
+          <p:cNvSpPr>
+            <a:spLocks noGrp="1"/>
+          </p:cNvSpPr>
+          <p:nvPr>
+            <p:ph type="body" idx="20" sz="quarter"/>
+          </p:nvPr>
+        </p:nvSpPr>
+        <p:spPr/>
+        <p:txBody>
+          <a:bodyPr/>
+          <a:lstStyle/>
+          <a:p/>
+        </p:txBody>
+      </p:sp>
+      <p:sp>
+        <p:nvSpPr>
+          <p:cNvPr id="6" name="Text Placeholder 5"/>
+          <p:cNvSpPr>
+            <a:spLocks noGrp="1"/>
+          </p:cNvSpPr>
+          <p:nvPr>
+            <p:ph type="body" idx="21" sz="quarter"/>
+          </p:nvPr>
+        </p:nvSpPr>
+        <p:spPr/>
+        <p:txBody>
+          <a:bodyPr/>
+          <a:lstStyle/>
+          <a:p>
+            <a:r>
+              <a:t>How strongly do you agree or disagree with each of the following statements? (%)</a:t>
+            </a:r>
+          </a:p>
+        </p:txBody>
+      </p:sp>
+      <p:sp>
+        <p:nvSpPr>
+          <p:cNvPr id="7" name="Text Placeholder 6"/>
+          <p:cNvSpPr>
+            <a:spLocks noGrp="1"/>
+          </p:cNvSpPr>
+          <p:nvPr>
+            <p:ph type="body" idx="22" sz="quarter"/>
+          </p:nvPr>
+        </p:nvSpPr>
+        <p:spPr/>
+        <p:txBody>
+          <a:bodyPr/>
+          <a:lstStyle/>
+          <a:p/>
+        </p:txBody>
+      </p:sp>
+      <p:sp>
+        <p:nvSpPr>
+          <p:cNvPr id="8" name="Text Placeholder 7"/>
+          <p:cNvSpPr>
+            <a:spLocks noGrp="1"/>
+          </p:cNvSpPr>
+          <p:nvPr>
+            <p:ph type="body" idx="23" sz="quarter"/>
+          </p:nvPr>
+        </p:nvSpPr>
+        <p:spPr/>
+        <p:txBody>
+          <a:bodyPr/>
+          <a:lstStyle/>
+          <a:p/>
+        </p:txBody>
+      </p:sp>
+      <p:sp>
+        <p:nvSpPr>
+          <p:cNvPr id="9" name="Text Placeholder 8"/>
+          <p:cNvSpPr>
+            <a:spLocks noGrp="1"/>
+          </p:cNvSpPr>
+          <p:nvPr>
+            <p:ph type="body" idx="24" sz="quarter"/>
+          </p:nvPr>
+        </p:nvSpPr>
+        <p:spPr/>
+        <p:txBody>
+          <a:bodyPr/>
+          <a:lstStyle/>
+          <a:p>
+            <a:r>
+              <a:t>Base: all respondents (n=200)</a:t>
+            </a:r>
+          </a:p>
+        </p:txBody>
+      </p:sp>
+      <p:pic>
+        <p:nvPicPr>
+          <p:cNvPr id="10" name="Picture 9" descr="image.png"/>
+          <p:cNvPicPr>
+            <a:picLocks noChangeAspect="1"/>
+          </p:cNvPicPr>
+          <p:nvPr/>
+        </p:nvPicPr>
+        <p:blipFill>
+          <a:blip r:embed="rId2"/>
+          <a:stretch>
+            <a:fillRect/>
+          </a:stretch>
+        </p:blipFill>
+        <p:spPr>
+          <a:xfrm>
+            <a:off x="310896" y="1709928"/>
+            <a:ext cx="8229600" cy="2880360"/>
+          </a:xfrm>
+          <a:prstGeom prst="rect">
+            <a:avLst/>
+          </a:prstGeom>
+        </p:spPr>
+      </p:pic>
+      <p:pic>
+        <p:nvPicPr>
+          <p:cNvPr id="11" name="Picture 10" descr="image.png"/>
+          <p:cNvPicPr>
+            <a:picLocks noChangeAspect="1"/>
+          </p:cNvPicPr>
+          <p:nvPr/>
+        </p:nvPicPr>
+        <p:blipFill>
+          <a:blip r:embed="rId3"/>
+          <a:stretch>
+            <a:fillRect/>
+          </a:stretch>
+        </p:blipFill>
+        <p:spPr>
+          <a:xfrm>
+            <a:off x="310896" y="4663440"/>
+            <a:ext cx="8229600" cy="274320"/>
+          </a:xfrm>
+          <a:prstGeom prst="rect">
+            <a:avLst/>
+          </a:prstGeom>
+        </p:spPr>
+      </p:pic>
+      <p:sp>
+        <p:nvSpPr>
+          <p:cNvPr id="12" name="Oval 11"/>
           <p:cNvSpPr/>
           <p:nvPr/>
         </p:nvSpPr>
         <p:spPr>
           <a:xfrm>
-            <a:off x="310896" y="1005840"/>
-            <a:ext cx="11878056" cy="27432"/>
-          </a:xfrm>
-          <a:prstGeom prst="rect">
+            <a:off x="11548872" y="6217920"/>
+            <a:ext cx="274320" cy="274320"/>
+          </a:xfrm>
+          <a:prstGeom prst="ellipse">
             <a:avLst/>
           </a:prstGeom>
           <a:solidFill>
@@ -8597,14 +8994,14 @@
       </p:sp>
       <p:sp>
         <p:nvSpPr>
-          <p:cNvPr id="3" name="TextBox 2"/>
+          <p:cNvPr id="13" name="TextBox 12"/>
           <p:cNvSpPr txBox="1"/>
           <p:nvPr/>
         </p:nvSpPr>
         <p:spPr>
           <a:xfrm>
-            <a:off x="310896" y="201168"/>
-            <a:ext cx="11567160" cy="749808"/>
+            <a:off x="11548872" y="6250838"/>
+            <a:ext cx="274320" cy="208483"/>
           </a:xfrm>
           <a:prstGeom prst="rect">
             <a:avLst/>
@@ -8617,29 +9014,90 @@
           </a:bodyPr>
           <a:lstStyle/>
           <a:p>
-            <a:pPr algn="l"/>
-            <a:r>
-              <a:rPr sz="1800" b="1" i="0">
-                <a:solidFill>
-                  <a:srgbClr val="A32015"/>
+            <a:pPr algn="ctr"/>
+            <a:r>
+              <a:rPr sz="1000" b="1" i="0">
+                <a:solidFill>
+                  <a:srgbClr val="FFFFFF"/>
                 </a:solidFill>
                 <a:latin typeface="DM Sans"/>
               </a:rPr>
-              <a:t>What is your age group?</a:t>
-            </a:r>
-          </a:p>
-        </p:txBody>
-      </p:sp>
-      <p:sp>
-        <p:nvSpPr>
-          <p:cNvPr id="4" name="TextBox 3"/>
+              <a:t>4</a:t>
+            </a:r>
+          </a:p>
+        </p:txBody>
+      </p:sp>
+    </p:spTree>
+  </p:cSld>
+  <p:clrMapOvr>
+    <a:masterClrMapping/>
+  </p:clrMapOvr>
+</p:sld>
+</file>
+
+<file path=ppt/slides/slide8.xml><?xml version="1.0" encoding="utf-8"?>
+<p:sld xmlns:a="http://schemas.openxmlformats.org/drawingml/2006/main" xmlns:p="http://schemas.openxmlformats.org/presentationml/2006/main" xmlns:r="http://schemas.openxmlformats.org/officeDocument/2006/relationships">
+  <p:cSld>
+    <p:spTree>
+      <p:nvGrpSpPr>
+        <p:cNvPr id="1" name=""/>
+        <p:cNvGrpSpPr/>
+        <p:nvPr/>
+      </p:nvGrpSpPr>
+      <p:grpSpPr/>
+      <p:sp>
+        <p:nvSpPr>
+          <p:cNvPr id="2" name="Rectangle 1"/>
+          <p:cNvSpPr/>
+          <p:nvPr/>
+        </p:nvSpPr>
+        <p:spPr>
+          <a:xfrm>
+            <a:off x="0" y="0"/>
+            <a:ext cx="12188952" cy="6858000"/>
+          </a:xfrm>
+          <a:prstGeom prst="rect">
+            <a:avLst/>
+          </a:prstGeom>
+          <a:solidFill>
+            <a:srgbClr val="027F7C"/>
+          </a:solidFill>
+          <a:ln>
+            <a:noFill/>
+          </a:ln>
+        </p:spPr>
+        <p:style>
+          <a:lnRef idx="1">
+            <a:schemeClr val="accent1"/>
+          </a:lnRef>
+          <a:fillRef idx="3">
+            <a:schemeClr val="accent1"/>
+          </a:fillRef>
+          <a:effectRef idx="2">
+            <a:schemeClr val="accent1"/>
+          </a:effectRef>
+          <a:fontRef idx="minor">
+            <a:schemeClr val="lt1"/>
+          </a:fontRef>
+        </p:style>
+        <p:txBody>
+          <a:bodyPr rtlCol="0" anchor="ctr"/>
+          <a:lstStyle/>
+          <a:p>
+            <a:pPr algn="ctr"/>
+          </a:p>
+        </p:txBody>
+      </p:sp>
+      <p:sp>
+        <p:nvSpPr>
+          <p:cNvPr id="3" name="TextBox 2"/>
           <p:cNvSpPr txBox="1"/>
           <p:nvPr/>
         </p:nvSpPr>
         <p:spPr>
           <a:xfrm>
-            <a:off x="310896" y="1042415"/>
-            <a:ext cx="8229600" cy="347472"/>
+            <a:off x="612648" y="2743200"/>
+            <a:ext cx="10972800" cy="1097280"/>
           </a:xfrm>
           <a:prstGeom prst="rect">
             <a:avLst/>
@@ -8654,13 +9112,94 @@
           <a:p>
             <a:pPr algn="l"/>
             <a:r>
-              <a:rPr sz="1100" b="0" i="1">
-                <a:solidFill>
-                  <a:srgbClr val="44546A"/>
+              <a:rPr sz="2800" b="1" i="0">
+                <a:solidFill>
+                  <a:srgbClr val="FFFFFF"/>
                 </a:solidFill>
                 <a:latin typeface="DM Sans"/>
               </a:rPr>
-              <a:t>[age_group] (%)</a:t>
+              <a:t>Demographics</a:t>
+            </a:r>
+          </a:p>
+        </p:txBody>
+      </p:sp>
+    </p:spTree>
+  </p:cSld>
+  <p:clrMapOvr>
+    <a:masterClrMapping/>
+  </p:clrMapOvr>
+</p:sld>
+</file>
+
+<file path=ppt/slides/slide9.xml><?xml version="1.0" encoding="utf-8"?>
+<p:sld xmlns:a="http://schemas.openxmlformats.org/drawingml/2006/main" xmlns:p="http://schemas.openxmlformats.org/presentationml/2006/main" xmlns:r="http://schemas.openxmlformats.org/officeDocument/2006/relationships">
+  <p:cSld>
+    <p:spTree>
+      <p:nvGrpSpPr>
+        <p:cNvPr id="1" name=""/>
+        <p:cNvGrpSpPr/>
+        <p:nvPr/>
+      </p:nvGrpSpPr>
+      <p:grpSpPr/>
+      <p:sp>
+        <p:nvSpPr>
+          <p:cNvPr id="2" name="Text Placeholder 1"/>
+          <p:cNvSpPr>
+            <a:spLocks noGrp="1"/>
+          </p:cNvSpPr>
+          <p:nvPr>
+            <p:ph type="body" idx="22" sz="quarter"/>
+          </p:nvPr>
+        </p:nvSpPr>
+        <p:spPr/>
+        <p:txBody>
+          <a:bodyPr/>
+          <a:lstStyle/>
+          <a:p>
+            <a:r>
+              <a:t>Base: all respondents (n=200)</a:t>
+            </a:r>
+          </a:p>
+        </p:txBody>
+      </p:sp>
+      <p:sp>
+        <p:nvSpPr>
+          <p:cNvPr id="3" name="Title 2"/>
+          <p:cNvSpPr>
+            <a:spLocks noGrp="1"/>
+          </p:cNvSpPr>
+          <p:nvPr>
+            <p:ph type="title"/>
+          </p:nvPr>
+        </p:nvSpPr>
+        <p:spPr/>
+        <p:txBody>
+          <a:bodyPr/>
+          <a:lstStyle/>
+          <a:p>
+            <a:r>
+              <a:t>Respondent region</a:t>
+            </a:r>
+          </a:p>
+        </p:txBody>
+      </p:sp>
+      <p:sp>
+        <p:nvSpPr>
+          <p:cNvPr id="4" name="Text Placeholder 3"/>
+          <p:cNvSpPr>
+            <a:spLocks noGrp="1"/>
+          </p:cNvSpPr>
+          <p:nvPr>
+            <p:ph type="body" idx="21" sz="quarter"/>
+          </p:nvPr>
+        </p:nvSpPr>
+        <p:spPr/>
+        <p:txBody>
+          <a:bodyPr/>
+          <a:lstStyle/>
+          <a:p>
+            <a:r>
+              <a:t>Which region are you based in? (%)</a:t>
             </a:r>
           </a:p>
         </p:txBody>
@@ -8681,8 +9220,8 @@
         </p:blipFill>
         <p:spPr>
           <a:xfrm>
-            <a:off x="310896" y="1463040"/>
-            <a:ext cx="6702552" cy="1645920"/>
+            <a:off x="310896" y="1709928"/>
+            <a:ext cx="5303520" cy="3566160"/>
           </a:xfrm>
           <a:prstGeom prst="rect">
             <a:avLst/>
@@ -8697,8 +9236,8 @@
         </p:nvSpPr>
         <p:spPr>
           <a:xfrm>
-            <a:off x="7434072" y="1463040"/>
-            <a:ext cx="4389119" cy="1645920"/>
+            <a:off x="5760720" y="1709928"/>
+            <a:ext cx="6062472" cy="3566160"/>
           </a:xfrm>
           <a:prstGeom prst="rect">
             <a:avLst/>
@@ -8718,7 +9257,7 @@
                 </a:solidFill>
                 <a:latin typeface="DM Sans"/>
               </a:rPr>
-              <a:t>Add subgroup breakdowns here, e.g.:</a:t>
+              <a:t>Sample is spread across metro, regional,</a:t>
             </a:r>
           </a:p>
           <a:p>
@@ -8729,32 +9268,64 @@
                 </a:solidFill>
                 <a:latin typeface="DM Sans"/>
               </a:rPr>
-              <a:t>– Under 30:  XX%</a:t>
-            </a:r>
-          </a:p>
-          <a:p>
-            <a:r>
-              <a:rPr sz="1000" b="0">
-                <a:solidFill>
-                  <a:srgbClr val="44546A"/>
-                </a:solidFill>
-                <a:latin typeface="DM Sans"/>
-              </a:rPr>
-              <a:t>– 30–44:     XX%</a:t>
-            </a:r>
-          </a:p>
-        </p:txBody>
-      </p:sp>
-      <p:sp>
-        <p:nvSpPr>
-          <p:cNvPr id="7" name="TextBox 6"/>
+              <a:t>rural and remote areas.</a:t>
+            </a:r>
+          </a:p>
+        </p:txBody>
+      </p:sp>
+      <p:sp>
+        <p:nvSpPr>
+          <p:cNvPr id="7" name="Oval 6"/>
+          <p:cNvSpPr/>
+          <p:nvPr/>
+        </p:nvSpPr>
+        <p:spPr>
+          <a:xfrm>
+            <a:off x="11548872" y="6217920"/>
+            <a:ext cx="274320" cy="274320"/>
+          </a:xfrm>
+          <a:prstGeom prst="ellipse">
+            <a:avLst/>
+          </a:prstGeom>
+          <a:solidFill>
+            <a:srgbClr val="027F7C"/>
+          </a:solidFill>
+          <a:ln>
+            <a:noFill/>
+          </a:ln>
+        </p:spPr>
+        <p:style>
+          <a:lnRef idx="1">
+            <a:schemeClr val="accent1"/>
+          </a:lnRef>
+          <a:fillRef idx="3">
+            <a:schemeClr val="accent1"/>
+          </a:fillRef>
+          <a:effectRef idx="2">
+            <a:schemeClr val="accent1"/>
+          </a:effectRef>
+          <a:fontRef idx="minor">
+            <a:schemeClr val="lt1"/>
+          </a:fontRef>
+        </p:style>
+        <p:txBody>
+          <a:bodyPr rtlCol="0" anchor="ctr"/>
+          <a:lstStyle/>
+          <a:p>
+            <a:pPr algn="ctr"/>
+          </a:p>
+        </p:txBody>
+      </p:sp>
+      <p:sp>
+        <p:nvSpPr>
+          <p:cNvPr id="8" name="TextBox 7"/>
           <p:cNvSpPr txBox="1"/>
           <p:nvPr/>
         </p:nvSpPr>
         <p:spPr>
           <a:xfrm>
-            <a:off x="1097280" y="6236208"/>
-            <a:ext cx="10058400" cy="256032"/>
+            <a:off x="11548872" y="6250838"/>
+            <a:ext cx="274320" cy="208483"/>
           </a:xfrm>
           <a:prstGeom prst="rect">
             <a:avLst/>
@@ -8767,50 +9338,15 @@
           </a:bodyPr>
           <a:lstStyle/>
           <a:p>
-            <a:pPr algn="l"/>
-            <a:r>
-              <a:rPr sz="800" b="0" i="1">
-                <a:solidFill>
-                  <a:srgbClr val="44546A"/>
+            <a:pPr algn="ctr"/>
+            <a:r>
+              <a:rPr sz="1000" b="1" i="0">
+                <a:solidFill>
+                  <a:srgbClr val="FFFFFF"/>
                 </a:solidFill>
                 <a:latin typeface="DM Sans"/>
               </a:rPr>
-              <a:t>Base: all respondents (n=200)</a:t>
-            </a:r>
-          </a:p>
-        </p:txBody>
-      </p:sp>
-      <p:sp>
-        <p:nvSpPr>
-          <p:cNvPr id="8" name="TextBox 7"/>
-          <p:cNvSpPr txBox="1"/>
-          <p:nvPr/>
-        </p:nvSpPr>
-        <p:spPr>
-          <a:xfrm>
-            <a:off x="11338560" y="6217920"/>
-            <a:ext cx="612648" cy="274320"/>
-          </a:xfrm>
-          <a:prstGeom prst="rect">
-            <a:avLst/>
-          </a:prstGeom>
-          <a:noFill/>
-        </p:spPr>
-        <p:txBody>
-          <a:bodyPr wrap="square">
-            <a:spAutoFit/>
-          </a:bodyPr>
-          <a:lstStyle/>
-          <a:p>
-            <a:pPr algn="r"/>
-            <a:r>
-              <a:rPr sz="800" b="0" i="0">
-                <a:solidFill>
-                  <a:srgbClr val="44546A"/>
-                </a:solidFill>
-                <a:latin typeface="DM Sans"/>
-              </a:rPr>
-              <a:t>6</a:t>
+              <a:t>5</a:t>
             </a:r>
           </a:p>
         </p:txBody>

</xml_diff>

<commit_message>
Fix chart stretching, bold y-axis, legend size, and single-bar circle placement
- chart_styles: add fig_w parameter to both renderers so charts are generated
  at the exact display width — eliminates horizontal stretching when inserted
- chart_styles: fix bold y-axis by iterating tick labels after set_yticklabels
  (more reliable than passing fontweight kwarg directly)
- chart_styles: increase legend font size from 7 to 9 to match data labels
- slide_builder: pass fig_w=cw to all render calls (single bar and grid)
- slide_builder: single-bar circles now positioned at the correct x (bar end
  based on xlim_max scale) and sized proportionally to bar height
- slide_builder: grid layout tries both 'Section Header' and '1_Section Header'

https://claude.ai/code/session_01VCXkWfprNAwES9BXV74rqk
</commit_message>
<xml_diff>
--- a/sample_data/output.pptx
+++ b/sample_data/output.pptx
@@ -7667,8 +7667,8 @@
         </p:nvSpPr>
         <p:spPr>
           <a:xfrm>
-            <a:off x="4820716" y="2137958"/>
-            <a:ext cx="1133856" cy="1133856"/>
+            <a:off x="6421718" y="2446707"/>
+            <a:ext cx="516358" cy="516358"/>
           </a:xfrm>
           <a:prstGeom prst="ellipse">
             <a:avLst/>
@@ -7710,8 +7710,8 @@
         </p:nvSpPr>
         <p:spPr>
           <a:xfrm>
-            <a:off x="4820716" y="2251344"/>
-            <a:ext cx="1133856" cy="589605"/>
+            <a:off x="6421718" y="2498343"/>
+            <a:ext cx="516358" cy="268506"/>
           </a:xfrm>
           <a:prstGeom prst="rect">
             <a:avLst/>
@@ -7726,7 +7726,7 @@
           <a:p>
             <a:pPr algn="ctr"/>
             <a:r>
-              <a:rPr sz="3200" b="1" i="0">
+              <a:rPr sz="1400" b="1" i="0">
                 <a:solidFill>
                   <a:srgbClr val="FFFFFF"/>
                 </a:solidFill>
@@ -7745,8 +7745,8 @@
         </p:nvSpPr>
         <p:spPr>
           <a:xfrm>
-            <a:off x="4820716" y="2795595"/>
-            <a:ext cx="1133856" cy="408188"/>
+            <a:off x="6421718" y="2746195"/>
+            <a:ext cx="516358" cy="185888"/>
           </a:xfrm>
           <a:prstGeom prst="rect">
             <a:avLst/>
@@ -7761,7 +7761,7 @@
           <a:p>
             <a:pPr algn="ctr"/>
             <a:r>
-              <a:rPr sz="1700" b="0" i="0">
+              <a:rPr sz="700" b="0" i="0">
                 <a:solidFill>
                   <a:srgbClr val="FFFFFF"/>
                 </a:solidFill>
@@ -7780,8 +7780,8 @@
         </p:nvSpPr>
         <p:spPr>
           <a:xfrm>
-            <a:off x="4905755" y="4570079"/>
-            <a:ext cx="963777" cy="963777"/>
+            <a:off x="2876986" y="4832516"/>
+            <a:ext cx="438904" cy="438904"/>
           </a:xfrm>
           <a:prstGeom prst="ellipse">
             <a:avLst/>
@@ -7823,8 +7823,8 @@
         </p:nvSpPr>
         <p:spPr>
           <a:xfrm>
-            <a:off x="4905755" y="4666457"/>
-            <a:ext cx="963777" cy="501164"/>
+            <a:off x="2876986" y="4876406"/>
+            <a:ext cx="438904" cy="228230"/>
           </a:xfrm>
           <a:prstGeom prst="rect">
             <a:avLst/>
@@ -7839,7 +7839,7 @@
           <a:p>
             <a:pPr algn="ctr"/>
             <a:r>
-              <a:rPr sz="2700" b="1" i="0">
+              <a:rPr sz="1200" b="1" i="0">
                 <a:solidFill>
                   <a:srgbClr val="FFFFFF"/>
                 </a:solidFill>
@@ -7858,8 +7858,8 @@
         </p:nvSpPr>
         <p:spPr>
           <a:xfrm>
-            <a:off x="4905755" y="5129070"/>
-            <a:ext cx="963777" cy="346959"/>
+            <a:off x="2876986" y="5087080"/>
+            <a:ext cx="438904" cy="158005"/>
           </a:xfrm>
           <a:prstGeom prst="rect">
             <a:avLst/>
@@ -7874,7 +7874,7 @@
           <a:p>
             <a:pPr algn="ctr"/>
             <a:r>
-              <a:rPr sz="1400" b="0" i="0">
+              <a:rPr sz="700" b="0" i="0">
                 <a:solidFill>
                   <a:srgbClr val="FFFFFF"/>
                 </a:solidFill>
@@ -8220,8 +8220,8 @@
         </p:nvSpPr>
         <p:spPr>
           <a:xfrm>
-            <a:off x="4820716" y="2137958"/>
-            <a:ext cx="1133856" cy="1133856"/>
+            <a:off x="3528133" y="2446707"/>
+            <a:ext cx="516358" cy="516358"/>
           </a:xfrm>
           <a:prstGeom prst="ellipse">
             <a:avLst/>
@@ -8263,8 +8263,8 @@
         </p:nvSpPr>
         <p:spPr>
           <a:xfrm>
-            <a:off x="4820716" y="2251344"/>
-            <a:ext cx="1133856" cy="589605"/>
+            <a:off x="3528133" y="2498343"/>
+            <a:ext cx="516358" cy="268506"/>
           </a:xfrm>
           <a:prstGeom prst="rect">
             <a:avLst/>
@@ -8279,7 +8279,7 @@
           <a:p>
             <a:pPr algn="ctr"/>
             <a:r>
-              <a:rPr sz="3200" b="1" i="0">
+              <a:rPr sz="1400" b="1" i="0">
                 <a:solidFill>
                   <a:srgbClr val="FFFFFF"/>
                 </a:solidFill>
@@ -8298,8 +8298,8 @@
         </p:nvSpPr>
         <p:spPr>
           <a:xfrm>
-            <a:off x="4820716" y="2795595"/>
-            <a:ext cx="1133856" cy="408188"/>
+            <a:off x="3528133" y="2746195"/>
+            <a:ext cx="516358" cy="185888"/>
           </a:xfrm>
           <a:prstGeom prst="rect">
             <a:avLst/>
@@ -8314,7 +8314,7 @@
           <a:p>
             <a:pPr algn="ctr"/>
             <a:r>
-              <a:rPr sz="1700" b="0" i="0">
+              <a:rPr sz="700" b="0" i="0">
                 <a:solidFill>
                   <a:srgbClr val="FFFFFF"/>
                 </a:solidFill>
@@ -8333,8 +8333,8 @@
         </p:nvSpPr>
         <p:spPr>
           <a:xfrm>
-            <a:off x="4905755" y="4570079"/>
-            <a:ext cx="963777" cy="963777"/>
+            <a:off x="6598223" y="4832516"/>
+            <a:ext cx="438904" cy="438904"/>
           </a:xfrm>
           <a:prstGeom prst="ellipse">
             <a:avLst/>
@@ -8376,8 +8376,8 @@
         </p:nvSpPr>
         <p:spPr>
           <a:xfrm>
-            <a:off x="4905755" y="4666457"/>
-            <a:ext cx="963777" cy="501164"/>
+            <a:off x="6598223" y="4876406"/>
+            <a:ext cx="438904" cy="228230"/>
           </a:xfrm>
           <a:prstGeom prst="rect">
             <a:avLst/>
@@ -8392,7 +8392,7 @@
           <a:p>
             <a:pPr algn="ctr"/>
             <a:r>
-              <a:rPr sz="2700" b="1" i="0">
+              <a:rPr sz="1200" b="1" i="0">
                 <a:solidFill>
                   <a:srgbClr val="FFFFFF"/>
                 </a:solidFill>
@@ -8411,8 +8411,8 @@
         </p:nvSpPr>
         <p:spPr>
           <a:xfrm>
-            <a:off x="4905755" y="5129070"/>
-            <a:ext cx="963777" cy="346959"/>
+            <a:off x="6598223" y="5087080"/>
+            <a:ext cx="438904" cy="158005"/>
           </a:xfrm>
           <a:prstGeom prst="rect">
             <a:avLst/>
@@ -8427,7 +8427,7 @@
           <a:p>
             <a:pPr algn="ctr"/>
             <a:r>
-              <a:rPr sz="1400" b="0" i="0">
+              <a:rPr sz="700" b="0" i="0">
                 <a:solidFill>
                   <a:srgbClr val="FFFFFF"/>
                 </a:solidFill>

</xml_diff>

<commit_message>
Fix grid layout, circle positioning, and chart placement
- Use layout '3_Title Slide' (index 11) for grid slides — this is the layout
  with the full-width light-mint (#E6F8F9) horizontal strip matching the
  target design; placeholders idx=0/21/22 confirmed present
- Grid chart top set to 2.35" (inside the strip which starts at 2.23")
- Grid chart height capped at 3.70" so chart + legend fits within strip
- Grid footer back to idx=22 (correct for this layout, at y=7.08")
- Single-bar circles: x-position uses max bar value in the set (not the sum),
  preventing circles from appearing outside the chart when sum > xlim_max

https://claude.ai/code/session_01VCXkWfprNAwES9BXV74rqk
</commit_message>
<xml_diff>
--- a/sample_data/output.pptx
+++ b/sample_data/output.pptx
@@ -7667,7 +7667,7 @@
         </p:nvSpPr>
         <p:spPr>
           <a:xfrm>
-            <a:off x="6421718" y="2446707"/>
+            <a:off x="4271643" y="2446707"/>
             <a:ext cx="516358" cy="516358"/>
           </a:xfrm>
           <a:prstGeom prst="ellipse">
@@ -7710,7 +7710,7 @@
         </p:nvSpPr>
         <p:spPr>
           <a:xfrm>
-            <a:off x="6421718" y="2498343"/>
+            <a:off x="4271643" y="2498343"/>
             <a:ext cx="516358" cy="268506"/>
           </a:xfrm>
           <a:prstGeom prst="rect">
@@ -7745,7 +7745,7 @@
         </p:nvSpPr>
         <p:spPr>
           <a:xfrm>
-            <a:off x="6421718" y="2746195"/>
+            <a:off x="4271643" y="2746195"/>
             <a:ext cx="516358" cy="185888"/>
           </a:xfrm>
           <a:prstGeom prst="rect">
@@ -7780,7 +7780,7 @@
         </p:nvSpPr>
         <p:spPr>
           <a:xfrm>
-            <a:off x="2876986" y="4832516"/>
+            <a:off x="2478824" y="4832516"/>
             <a:ext cx="438904" cy="438904"/>
           </a:xfrm>
           <a:prstGeom prst="ellipse">
@@ -7823,7 +7823,7 @@
         </p:nvSpPr>
         <p:spPr>
           <a:xfrm>
-            <a:off x="2876986" y="4876406"/>
+            <a:off x="2478824" y="4876406"/>
             <a:ext cx="438904" cy="228230"/>
           </a:xfrm>
           <a:prstGeom prst="rect">
@@ -7858,7 +7858,7 @@
         </p:nvSpPr>
         <p:spPr>
           <a:xfrm>
-            <a:off x="2876986" y="5087080"/>
+            <a:off x="2478824" y="5087080"/>
             <a:ext cx="438904" cy="158005"/>
           </a:xfrm>
           <a:prstGeom prst="rect">
@@ -8220,7 +8220,7 @@
         </p:nvSpPr>
         <p:spPr>
           <a:xfrm>
-            <a:off x="3528133" y="2446707"/>
+            <a:off x="2954632" y="2446707"/>
             <a:ext cx="516358" cy="516358"/>
           </a:xfrm>
           <a:prstGeom prst="ellipse">
@@ -8263,7 +8263,7 @@
         </p:nvSpPr>
         <p:spPr>
           <a:xfrm>
-            <a:off x="3528133" y="2498343"/>
+            <a:off x="2954632" y="2498343"/>
             <a:ext cx="516358" cy="268506"/>
           </a:xfrm>
           <a:prstGeom prst="rect">
@@ -8298,7 +8298,7 @@
         </p:nvSpPr>
         <p:spPr>
           <a:xfrm>
-            <a:off x="3528133" y="2746195"/>
+            <a:off x="2954632" y="2746195"/>
             <a:ext cx="516358" cy="185888"/>
           </a:xfrm>
           <a:prstGeom prst="rect">
@@ -8333,7 +8333,7 @@
         </p:nvSpPr>
         <p:spPr>
           <a:xfrm>
-            <a:off x="6598223" y="4832516"/>
+            <a:off x="4304219" y="4832516"/>
             <a:ext cx="438904" cy="438904"/>
           </a:xfrm>
           <a:prstGeom prst="ellipse">
@@ -8376,7 +8376,7 @@
         </p:nvSpPr>
         <p:spPr>
           <a:xfrm>
-            <a:off x="6598223" y="4876406"/>
+            <a:off x="4304219" y="4876406"/>
             <a:ext cx="438904" cy="228230"/>
           </a:xfrm>
           <a:prstGeom prst="rect">
@@ -8411,7 +8411,7 @@
         </p:nvSpPr>
         <p:spPr>
           <a:xfrm>
-            <a:off x="6598223" y="5087080"/>
+            <a:off x="4304219" y="5087080"/>
             <a:ext cx="438904" cy="158005"/>
           </a:xfrm>
           <a:prstGeom prst="rect">
@@ -8747,108 +8747,23 @@
             <a:spLocks noGrp="1"/>
           </p:cNvSpPr>
           <p:nvPr>
-            <p:ph type="body" idx="12" sz="quarter"/>
+            <p:ph type="body" idx="21" sz="quarter"/>
           </p:nvPr>
         </p:nvSpPr>
         <p:spPr/>
         <p:txBody>
           <a:bodyPr/>
           <a:lstStyle/>
-          <a:p/>
+          <a:p>
+            <a:r>
+              <a:t>How strongly do you agree or disagree with each of the following statements? (%)</a:t>
+            </a:r>
+          </a:p>
         </p:txBody>
       </p:sp>
       <p:sp>
         <p:nvSpPr>
           <p:cNvPr id="4" name="Text Placeholder 3"/>
-          <p:cNvSpPr>
-            <a:spLocks noGrp="1"/>
-          </p:cNvSpPr>
-          <p:nvPr>
-            <p:ph type="body" idx="19" sz="quarter"/>
-          </p:nvPr>
-        </p:nvSpPr>
-        <p:spPr/>
-        <p:txBody>
-          <a:bodyPr/>
-          <a:lstStyle/>
-          <a:p>
-            <a:r>
-              <a:t>Total agree by statement:</a:t>
-            </a:r>
-          </a:p>
-          <a:p>
-            <a:r>
-              <a:t>– Community impact:   XX%</a:t>
-            </a:r>
-          </a:p>
-          <a:p>
-            <a:r>
-              <a:t>– Govt leadership:    XX%</a:t>
-            </a:r>
-          </a:p>
-          <a:p>
-            <a:r>
-              <a:t>– Local action:       XX%</a:t>
-            </a:r>
-          </a:p>
-          <a:p>
-            <a:r>
-              <a:t/>
-            </a:r>
-          </a:p>
-          <a:p>
-            <a:r>
-              <a:t>Agreement is broadly consistent</a:t>
-            </a:r>
-          </a:p>
-          <a:p>
-            <a:r>
-              <a:t>across age groups and regions.</a:t>
-            </a:r>
-          </a:p>
-        </p:txBody>
-      </p:sp>
-      <p:sp>
-        <p:nvSpPr>
-          <p:cNvPr id="5" name="Text Placeholder 4"/>
-          <p:cNvSpPr>
-            <a:spLocks noGrp="1"/>
-          </p:cNvSpPr>
-          <p:nvPr>
-            <p:ph type="body" idx="20" sz="quarter"/>
-          </p:nvPr>
-        </p:nvSpPr>
-        <p:spPr/>
-        <p:txBody>
-          <a:bodyPr/>
-          <a:lstStyle/>
-          <a:p/>
-        </p:txBody>
-      </p:sp>
-      <p:sp>
-        <p:nvSpPr>
-          <p:cNvPr id="6" name="Text Placeholder 5"/>
-          <p:cNvSpPr>
-            <a:spLocks noGrp="1"/>
-          </p:cNvSpPr>
-          <p:nvPr>
-            <p:ph type="body" idx="21" sz="quarter"/>
-          </p:nvPr>
-        </p:nvSpPr>
-        <p:spPr/>
-        <p:txBody>
-          <a:bodyPr/>
-          <a:lstStyle/>
-          <a:p>
-            <a:r>
-              <a:t>How strongly do you agree or disagree with each of the following statements? (%)</a:t>
-            </a:r>
-          </a:p>
-        </p:txBody>
-      </p:sp>
-      <p:sp>
-        <p:nvSpPr>
-          <p:cNvPr id="7" name="Text Placeholder 6"/>
           <p:cNvSpPr>
             <a:spLocks noGrp="1"/>
           </p:cNvSpPr>
@@ -8860,40 +8775,6 @@
         <p:txBody>
           <a:bodyPr/>
           <a:lstStyle/>
-          <a:p/>
-        </p:txBody>
-      </p:sp>
-      <p:sp>
-        <p:nvSpPr>
-          <p:cNvPr id="8" name="Text Placeholder 7"/>
-          <p:cNvSpPr>
-            <a:spLocks noGrp="1"/>
-          </p:cNvSpPr>
-          <p:nvPr>
-            <p:ph type="body" idx="23" sz="quarter"/>
-          </p:nvPr>
-        </p:nvSpPr>
-        <p:spPr/>
-        <p:txBody>
-          <a:bodyPr/>
-          <a:lstStyle/>
-          <a:p/>
-        </p:txBody>
-      </p:sp>
-      <p:sp>
-        <p:nvSpPr>
-          <p:cNvPr id="9" name="Text Placeholder 8"/>
-          <p:cNvSpPr>
-            <a:spLocks noGrp="1"/>
-          </p:cNvSpPr>
-          <p:nvPr>
-            <p:ph type="body" idx="24" sz="quarter"/>
-          </p:nvPr>
-        </p:nvSpPr>
-        <p:spPr/>
-        <p:txBody>
-          <a:bodyPr/>
-          <a:lstStyle/>
           <a:p>
             <a:r>
               <a:t>Base: all respondents (n=200)</a:t>
@@ -8903,7 +8784,7 @@
       </p:sp>
       <p:pic>
         <p:nvPicPr>
-          <p:cNvPr id="10" name="Picture 9" descr="image.png"/>
+          <p:cNvPr id="5" name="Picture 4" descr="image.png"/>
           <p:cNvPicPr>
             <a:picLocks noChangeAspect="1"/>
           </p:cNvPicPr>
@@ -8917,7 +8798,7 @@
         </p:blipFill>
         <p:spPr>
           <a:xfrm>
-            <a:off x="310896" y="1709928"/>
+            <a:off x="310896" y="2148840"/>
             <a:ext cx="8229600" cy="2880360"/>
           </a:xfrm>
           <a:prstGeom prst="rect">
@@ -8927,7 +8808,7 @@
       </p:pic>
       <p:pic>
         <p:nvPicPr>
-          <p:cNvPr id="11" name="Picture 10" descr="image.png"/>
+          <p:cNvPr id="6" name="Picture 5" descr="image.png"/>
           <p:cNvPicPr>
             <a:picLocks noChangeAspect="1"/>
           </p:cNvPicPr>
@@ -8941,7 +8822,7 @@
         </p:blipFill>
         <p:spPr>
           <a:xfrm>
-            <a:off x="310896" y="4663440"/>
+            <a:off x="310896" y="5102352"/>
             <a:ext cx="8229600" cy="274320"/>
           </a:xfrm>
           <a:prstGeom prst="rect">
@@ -8951,7 +8832,107 @@
       </p:pic>
       <p:sp>
         <p:nvSpPr>
-          <p:cNvPr id="12" name="Oval 11"/>
+          <p:cNvPr id="7" name="TextBox 6"/>
+          <p:cNvSpPr txBox="1"/>
+          <p:nvPr/>
+        </p:nvSpPr>
+        <p:spPr>
+          <a:xfrm>
+            <a:off x="8686800" y="2148840"/>
+            <a:ext cx="3136391" cy="2880360"/>
+          </a:xfrm>
+          <a:prstGeom prst="rect">
+            <a:avLst/>
+          </a:prstGeom>
+          <a:noFill/>
+        </p:spPr>
+        <p:txBody>
+          <a:bodyPr wrap="square">
+            <a:spAutoFit/>
+          </a:bodyPr>
+          <a:lstStyle/>
+          <a:p>
+            <a:r>
+              <a:rPr sz="1000" b="0">
+                <a:solidFill>
+                  <a:srgbClr val="44546A"/>
+                </a:solidFill>
+                <a:latin typeface="DM Sans"/>
+              </a:rPr>
+              <a:t>Total agree by statement:</a:t>
+            </a:r>
+          </a:p>
+          <a:p>
+            <a:r>
+              <a:rPr sz="1000" b="0">
+                <a:solidFill>
+                  <a:srgbClr val="44546A"/>
+                </a:solidFill>
+                <a:latin typeface="DM Sans"/>
+              </a:rPr>
+              <a:t>– Community impact:   XX%</a:t>
+            </a:r>
+          </a:p>
+          <a:p>
+            <a:r>
+              <a:rPr sz="1000" b="0">
+                <a:solidFill>
+                  <a:srgbClr val="44546A"/>
+                </a:solidFill>
+                <a:latin typeface="DM Sans"/>
+              </a:rPr>
+              <a:t>– Govt leadership:    XX%</a:t>
+            </a:r>
+          </a:p>
+          <a:p>
+            <a:r>
+              <a:rPr sz="1000" b="0">
+                <a:solidFill>
+                  <a:srgbClr val="44546A"/>
+                </a:solidFill>
+                <a:latin typeface="DM Sans"/>
+              </a:rPr>
+              <a:t>– Local action:       XX%</a:t>
+            </a:r>
+          </a:p>
+          <a:p>
+            <a:r>
+              <a:rPr sz="1000" b="0">
+                <a:solidFill>
+                  <a:srgbClr val="44546A"/>
+                </a:solidFill>
+                <a:latin typeface="DM Sans"/>
+              </a:rPr>
+              <a:t/>
+            </a:r>
+          </a:p>
+          <a:p>
+            <a:r>
+              <a:rPr sz="1000" b="0">
+                <a:solidFill>
+                  <a:srgbClr val="44546A"/>
+                </a:solidFill>
+                <a:latin typeface="DM Sans"/>
+              </a:rPr>
+              <a:t>Agreement is broadly consistent</a:t>
+            </a:r>
+          </a:p>
+          <a:p>
+            <a:r>
+              <a:rPr sz="1000" b="0">
+                <a:solidFill>
+                  <a:srgbClr val="44546A"/>
+                </a:solidFill>
+                <a:latin typeface="DM Sans"/>
+              </a:rPr>
+              <a:t>across age groups and regions.</a:t>
+            </a:r>
+          </a:p>
+        </p:txBody>
+      </p:sp>
+      <p:sp>
+        <p:nvSpPr>
+          <p:cNvPr id="8" name="Oval 7"/>
           <p:cNvSpPr/>
           <p:nvPr/>
         </p:nvSpPr>
@@ -8994,7 +8975,7 @@
       </p:sp>
       <p:sp>
         <p:nvSpPr>
-          <p:cNvPr id="13" name="TextBox 12"/>
+          <p:cNvPr id="9" name="TextBox 8"/>
           <p:cNvSpPr txBox="1"/>
           <p:nvPr/>
         </p:nvSpPr>

</xml_diff>

<commit_message>
Larger circles beyond bars, fix legend wrap, set Liberation Sans, add 10-row grid
- Circles: radius increased (bar_h*0.85, min 0.28"), offset=r*1.15 so
  left edge of circle sits clearly beyond the bar end
- Legend: axis_bottom raised to 0.20, ncol halved so items wrap to 2
  rows instead of being clipped; bbox_to_anchor y lifted to 0.01
- Font: set Liberation Sans (closest system font to DM Sans) via
  matplotlib.rcParams at module load
- Sample data: added 10 new attitude statement variables (att_urgent
  through att_trust) with realistic weight distributions
- Annotations: added 10-statement grid slide for layout stress-test

https://claude.ai/code/session_01VCXkWfprNAwES9BXV74rqk
</commit_message>
<xml_diff>
--- a/sample_data/output.pptx
+++ b/sample_data/output.pptx
@@ -22,6 +22,7 @@
     <p:sldId id="264" r:id="rId36"/>
     <p:sldId id="265" r:id="rId37"/>
     <p:sldId id="266" r:id="rId38"/>
+    <p:sldId id="267" r:id="rId39"/>
   </p:sldIdLst>
   <p:sldSz cx="12192000" cy="6858000"/>
   <p:notesSz cx="6858000" cy="9144000"/>
@@ -6963,148 +6964,16 @@
       <p:grpSpPr/>
       <p:sp>
         <p:nvSpPr>
-          <p:cNvPr id="2" name="Text Placeholder 1"/>
-          <p:cNvSpPr>
-            <a:spLocks noGrp="1"/>
-          </p:cNvSpPr>
-          <p:nvPr>
-            <p:ph type="body" idx="22" sz="quarter"/>
-          </p:nvPr>
-        </p:nvSpPr>
-        <p:spPr/>
-        <p:txBody>
-          <a:bodyPr/>
-          <a:lstStyle/>
-          <a:p>
-            <a:r>
-              <a:t>Base: all respondents (n=200)</a:t>
-            </a:r>
-          </a:p>
-        </p:txBody>
-      </p:sp>
-      <p:sp>
-        <p:nvSpPr>
-          <p:cNvPr id="3" name="Title 2"/>
-          <p:cNvSpPr>
-            <a:spLocks noGrp="1"/>
-          </p:cNvSpPr>
-          <p:nvPr>
-            <p:ph type="title"/>
-          </p:nvPr>
-        </p:nvSpPr>
-        <p:spPr/>
-        <p:txBody>
-          <a:bodyPr/>
-          <a:lstStyle/>
-          <a:p>
-            <a:r>
-              <a:t>Respondent region</a:t>
-            </a:r>
-          </a:p>
-        </p:txBody>
-      </p:sp>
-      <p:sp>
-        <p:nvSpPr>
-          <p:cNvPr id="4" name="Text Placeholder 3"/>
-          <p:cNvSpPr>
-            <a:spLocks noGrp="1"/>
-          </p:cNvSpPr>
-          <p:nvPr>
-            <p:ph type="body" idx="21" sz="quarter"/>
-          </p:nvPr>
-        </p:nvSpPr>
-        <p:spPr/>
-        <p:txBody>
-          <a:bodyPr/>
-          <a:lstStyle/>
-          <a:p>
-            <a:r>
-              <a:t>Which region are you based in? (%)</a:t>
-            </a:r>
-          </a:p>
-        </p:txBody>
-      </p:sp>
-      <p:pic>
-        <p:nvPicPr>
-          <p:cNvPr id="5" name="Picture 4" descr="image.png"/>
-          <p:cNvPicPr>
-            <a:picLocks noChangeAspect="1"/>
-          </p:cNvPicPr>
-          <p:nvPr/>
-        </p:nvPicPr>
-        <p:blipFill>
-          <a:blip r:embed="rId2"/>
-          <a:stretch>
-            <a:fillRect/>
-          </a:stretch>
-        </p:blipFill>
-        <p:spPr>
-          <a:xfrm>
-            <a:off x="310896" y="1709928"/>
-            <a:ext cx="5303520" cy="3566160"/>
-          </a:xfrm>
-          <a:prstGeom prst="rect">
-            <a:avLst/>
-          </a:prstGeom>
-        </p:spPr>
-      </p:pic>
-      <p:sp>
-        <p:nvSpPr>
-          <p:cNvPr id="6" name="TextBox 5"/>
-          <p:cNvSpPr txBox="1"/>
-          <p:nvPr/>
-        </p:nvSpPr>
-        <p:spPr>
-          <a:xfrm>
-            <a:off x="7379208" y="1709928"/>
-            <a:ext cx="4453128" cy="3566160"/>
-          </a:xfrm>
-          <a:prstGeom prst="rect">
-            <a:avLst/>
-          </a:prstGeom>
-          <a:noFill/>
-        </p:spPr>
-        <p:txBody>
-          <a:bodyPr wrap="square">
-            <a:spAutoFit/>
-          </a:bodyPr>
-          <a:lstStyle/>
-          <a:p>
-            <a:r>
-              <a:rPr sz="1400" b="0">
-                <a:solidFill>
-                  <a:srgbClr val="44546A"/>
-                </a:solidFill>
-                <a:latin typeface="DM Sans"/>
-              </a:rPr>
-              <a:t>Sample is spread across metro, regional,</a:t>
-            </a:r>
-          </a:p>
-          <a:p>
-            <a:r>
-              <a:rPr sz="1400" b="0">
-                <a:solidFill>
-                  <a:srgbClr val="44546A"/>
-                </a:solidFill>
-                <a:latin typeface="DM Sans"/>
-              </a:rPr>
-              <a:t>rural and remote areas.</a:t>
-            </a:r>
-          </a:p>
-        </p:txBody>
-      </p:sp>
-      <p:sp>
-        <p:nvSpPr>
-          <p:cNvPr id="7" name="Oval 6"/>
+          <p:cNvPr id="2" name="Rectangle 1"/>
           <p:cNvSpPr/>
           <p:nvPr/>
         </p:nvSpPr>
         <p:spPr>
           <a:xfrm>
-            <a:off x="11548872" y="6217920"/>
-            <a:ext cx="274320" cy="274320"/>
-          </a:xfrm>
-          <a:prstGeom prst="ellipse">
+            <a:off x="0" y="0"/>
+            <a:ext cx="12188952" cy="6858000"/>
+          </a:xfrm>
+          <a:prstGeom prst="rect">
             <a:avLst/>
           </a:prstGeom>
           <a:solidFill>
@@ -7138,14 +7007,14 @@
       </p:sp>
       <p:sp>
         <p:nvSpPr>
-          <p:cNvPr id="8" name="TextBox 7"/>
+          <p:cNvPr id="3" name="TextBox 2"/>
           <p:cNvSpPr txBox="1"/>
           <p:nvPr/>
         </p:nvSpPr>
         <p:spPr>
           <a:xfrm>
-            <a:off x="11548872" y="6250838"/>
-            <a:ext cx="274320" cy="208483"/>
+            <a:off x="612648" y="2743200"/>
+            <a:ext cx="10972800" cy="1097280"/>
           </a:xfrm>
           <a:prstGeom prst="rect">
             <a:avLst/>
@@ -7158,15 +7027,15 @@
           </a:bodyPr>
           <a:lstStyle/>
           <a:p>
-            <a:pPr algn="ctr"/>
-            <a:r>
-              <a:rPr sz="1000" b="1" i="0">
+            <a:pPr algn="l"/>
+            <a:r>
+              <a:rPr sz="2800" b="1" i="0">
                 <a:solidFill>
                   <a:srgbClr val="FFFFFF"/>
                 </a:solidFill>
                 <a:latin typeface="DM Sans"/>
               </a:rPr>
-              <a:t>6</a:t>
+              <a:t>Demographics</a:t>
             </a:r>
           </a:p>
         </p:txBody>
@@ -7226,7 +7095,7 @@
           <a:lstStyle/>
           <a:p>
             <a:r>
-              <a:t>Respondent age group</a:t>
+              <a:t>Respondent region</a:t>
             </a:r>
           </a:p>
         </p:txBody>
@@ -7247,7 +7116,7 @@
           <a:lstStyle/>
           <a:p>
             <a:r>
-              <a:t>What is your age group? (%)</a:t>
+              <a:t>Which region are you based in? (%)</a:t>
             </a:r>
           </a:p>
         </p:txBody>
@@ -7269,7 +7138,7 @@
         <p:spPr>
           <a:xfrm>
             <a:off x="310896" y="1709928"/>
-            <a:ext cx="5303520" cy="4251960"/>
+            <a:ext cx="5303520" cy="3566160"/>
           </a:xfrm>
           <a:prstGeom prst="rect">
             <a:avLst/>
@@ -7285,7 +7154,7 @@
         <p:spPr>
           <a:xfrm>
             <a:off x="7379208" y="1709928"/>
-            <a:ext cx="4453128" cy="4251960"/>
+            <a:ext cx="4453128" cy="3566160"/>
           </a:xfrm>
           <a:prstGeom prst="rect">
             <a:avLst/>
@@ -7305,7 +7174,7 @@
                 </a:solidFill>
                 <a:latin typeface="DM Sans"/>
               </a:rPr>
-              <a:t>Sample skews slightly toward working-age</a:t>
+              <a:t>Sample is spread across metro, regional,</a:t>
             </a:r>
           </a:p>
           <a:p>
@@ -7316,7 +7185,7 @@
                 </a:solidFill>
                 <a:latin typeface="DM Sans"/>
               </a:rPr>
-              <a:t>adults (35–54).</a:t>
+              <a:t>rural and remote areas.</a:t>
             </a:r>
           </a:p>
         </p:txBody>
@@ -7395,6 +7264,234 @@
                 <a:latin typeface="DM Sans"/>
               </a:rPr>
               <a:t>7</a:t>
+            </a:r>
+          </a:p>
+        </p:txBody>
+      </p:sp>
+    </p:spTree>
+  </p:cSld>
+  <p:clrMapOvr>
+    <a:masterClrMapping/>
+  </p:clrMapOvr>
+</p:sld>
+</file>
+
+<file path=ppt/slides/slide12.xml><?xml version="1.0" encoding="utf-8"?>
+<p:sld xmlns:a="http://schemas.openxmlformats.org/drawingml/2006/main" xmlns:p="http://schemas.openxmlformats.org/presentationml/2006/main" xmlns:r="http://schemas.openxmlformats.org/officeDocument/2006/relationships">
+  <p:cSld>
+    <p:spTree>
+      <p:nvGrpSpPr>
+        <p:cNvPr id="1" name=""/>
+        <p:cNvGrpSpPr/>
+        <p:nvPr/>
+      </p:nvGrpSpPr>
+      <p:grpSpPr/>
+      <p:sp>
+        <p:nvSpPr>
+          <p:cNvPr id="2" name="Text Placeholder 1"/>
+          <p:cNvSpPr>
+            <a:spLocks noGrp="1"/>
+          </p:cNvSpPr>
+          <p:nvPr>
+            <p:ph type="body" idx="22" sz="quarter"/>
+          </p:nvPr>
+        </p:nvSpPr>
+        <p:spPr/>
+        <p:txBody>
+          <a:bodyPr/>
+          <a:lstStyle/>
+          <a:p>
+            <a:r>
+              <a:t>Base: all respondents (n=200)</a:t>
+            </a:r>
+          </a:p>
+        </p:txBody>
+      </p:sp>
+      <p:sp>
+        <p:nvSpPr>
+          <p:cNvPr id="3" name="Title 2"/>
+          <p:cNvSpPr>
+            <a:spLocks noGrp="1"/>
+          </p:cNvSpPr>
+          <p:nvPr>
+            <p:ph type="title"/>
+          </p:nvPr>
+        </p:nvSpPr>
+        <p:spPr/>
+        <p:txBody>
+          <a:bodyPr/>
+          <a:lstStyle/>
+          <a:p>
+            <a:r>
+              <a:t>Respondent age group</a:t>
+            </a:r>
+          </a:p>
+        </p:txBody>
+      </p:sp>
+      <p:sp>
+        <p:nvSpPr>
+          <p:cNvPr id="4" name="Text Placeholder 3"/>
+          <p:cNvSpPr>
+            <a:spLocks noGrp="1"/>
+          </p:cNvSpPr>
+          <p:nvPr>
+            <p:ph type="body" idx="21" sz="quarter"/>
+          </p:nvPr>
+        </p:nvSpPr>
+        <p:spPr/>
+        <p:txBody>
+          <a:bodyPr/>
+          <a:lstStyle/>
+          <a:p>
+            <a:r>
+              <a:t>What is your age group? (%)</a:t>
+            </a:r>
+          </a:p>
+        </p:txBody>
+      </p:sp>
+      <p:pic>
+        <p:nvPicPr>
+          <p:cNvPr id="5" name="Picture 4" descr="image.png"/>
+          <p:cNvPicPr>
+            <a:picLocks noChangeAspect="1"/>
+          </p:cNvPicPr>
+          <p:nvPr/>
+        </p:nvPicPr>
+        <p:blipFill>
+          <a:blip r:embed="rId2"/>
+          <a:stretch>
+            <a:fillRect/>
+          </a:stretch>
+        </p:blipFill>
+        <p:spPr>
+          <a:xfrm>
+            <a:off x="310896" y="1709928"/>
+            <a:ext cx="5303520" cy="4251960"/>
+          </a:xfrm>
+          <a:prstGeom prst="rect">
+            <a:avLst/>
+          </a:prstGeom>
+        </p:spPr>
+      </p:pic>
+      <p:sp>
+        <p:nvSpPr>
+          <p:cNvPr id="6" name="TextBox 5"/>
+          <p:cNvSpPr txBox="1"/>
+          <p:nvPr/>
+        </p:nvSpPr>
+        <p:spPr>
+          <a:xfrm>
+            <a:off x="7379208" y="1709928"/>
+            <a:ext cx="4453128" cy="4251960"/>
+          </a:xfrm>
+          <a:prstGeom prst="rect">
+            <a:avLst/>
+          </a:prstGeom>
+          <a:noFill/>
+        </p:spPr>
+        <p:txBody>
+          <a:bodyPr wrap="square">
+            <a:spAutoFit/>
+          </a:bodyPr>
+          <a:lstStyle/>
+          <a:p>
+            <a:r>
+              <a:rPr sz="1400" b="0">
+                <a:solidFill>
+                  <a:srgbClr val="44546A"/>
+                </a:solidFill>
+                <a:latin typeface="DM Sans"/>
+              </a:rPr>
+              <a:t>Sample skews slightly toward working-age</a:t>
+            </a:r>
+          </a:p>
+          <a:p>
+            <a:r>
+              <a:rPr sz="1400" b="0">
+                <a:solidFill>
+                  <a:srgbClr val="44546A"/>
+                </a:solidFill>
+                <a:latin typeface="DM Sans"/>
+              </a:rPr>
+              <a:t>adults (35–54).</a:t>
+            </a:r>
+          </a:p>
+        </p:txBody>
+      </p:sp>
+      <p:sp>
+        <p:nvSpPr>
+          <p:cNvPr id="7" name="Oval 6"/>
+          <p:cNvSpPr/>
+          <p:nvPr/>
+        </p:nvSpPr>
+        <p:spPr>
+          <a:xfrm>
+            <a:off x="11548872" y="6217920"/>
+            <a:ext cx="274320" cy="274320"/>
+          </a:xfrm>
+          <a:prstGeom prst="ellipse">
+            <a:avLst/>
+          </a:prstGeom>
+          <a:solidFill>
+            <a:srgbClr val="027F7C"/>
+          </a:solidFill>
+          <a:ln>
+            <a:noFill/>
+          </a:ln>
+        </p:spPr>
+        <p:style>
+          <a:lnRef idx="1">
+            <a:schemeClr val="accent1"/>
+          </a:lnRef>
+          <a:fillRef idx="3">
+            <a:schemeClr val="accent1"/>
+          </a:fillRef>
+          <a:effectRef idx="2">
+            <a:schemeClr val="accent1"/>
+          </a:effectRef>
+          <a:fontRef idx="minor">
+            <a:schemeClr val="lt1"/>
+          </a:fontRef>
+        </p:style>
+        <p:txBody>
+          <a:bodyPr rtlCol="0" anchor="ctr"/>
+          <a:lstStyle/>
+          <a:p>
+            <a:pPr algn="ctr"/>
+          </a:p>
+        </p:txBody>
+      </p:sp>
+      <p:sp>
+        <p:nvSpPr>
+          <p:cNvPr id="8" name="TextBox 7"/>
+          <p:cNvSpPr txBox="1"/>
+          <p:nvPr/>
+        </p:nvSpPr>
+        <p:spPr>
+          <a:xfrm>
+            <a:off x="11548872" y="6250838"/>
+            <a:ext cx="274320" cy="208483"/>
+          </a:xfrm>
+          <a:prstGeom prst="rect">
+            <a:avLst/>
+          </a:prstGeom>
+          <a:noFill/>
+        </p:spPr>
+        <p:txBody>
+          <a:bodyPr wrap="square">
+            <a:spAutoFit/>
+          </a:bodyPr>
+          <a:lstStyle/>
+          <a:p>
+            <a:pPr algn="ctr"/>
+            <a:r>
+              <a:rPr sz="1000" b="1" i="0">
+                <a:solidFill>
+                  <a:srgbClr val="FFFFFF"/>
+                </a:solidFill>
+                <a:latin typeface="DM Sans"/>
+              </a:rPr>
+              <a:t>8</a:t>
             </a:r>
           </a:p>
         </p:txBody>
@@ -7896,8 +7993,8 @@
         </p:nvSpPr>
         <p:spPr>
           <a:xfrm>
-            <a:off x="4331493" y="2399765"/>
-            <a:ext cx="610241" cy="610241"/>
+            <a:off x="4589672" y="2305882"/>
+            <a:ext cx="798007" cy="798007"/>
           </a:xfrm>
           <a:prstGeom prst="ellipse">
             <a:avLst/>
@@ -7939,8 +8036,8 @@
         </p:nvSpPr>
         <p:spPr>
           <a:xfrm>
-            <a:off x="4331493" y="2436380"/>
-            <a:ext cx="610241" cy="317325"/>
+            <a:off x="4589672" y="2353763"/>
+            <a:ext cx="798007" cy="414964"/>
           </a:xfrm>
           <a:prstGeom prst="rect">
             <a:avLst/>
@@ -7955,7 +8052,7 @@
           <a:p>
             <a:pPr algn="ctr"/>
             <a:r>
-              <a:rPr sz="2000" b="1">
+              <a:rPr sz="2700" b="1">
                 <a:solidFill>
                   <a:srgbClr val="FFFFFF"/>
                 </a:solidFill>
@@ -7964,7 +8061,7 @@
               <a:t>60</a:t>
             </a:r>
             <a:r>
-              <a:rPr sz="1300" b="1">
+              <a:rPr sz="1700" b="1">
                 <a:solidFill>
                   <a:srgbClr val="FFFFFF"/>
                 </a:solidFill>
@@ -7983,8 +8080,8 @@
         </p:nvSpPr>
         <p:spPr>
           <a:xfrm>
-            <a:off x="4331493" y="2741501"/>
-            <a:ext cx="610241" cy="231891"/>
+            <a:off x="4589672" y="2752767"/>
+            <a:ext cx="798007" cy="303242"/>
           </a:xfrm>
           <a:prstGeom prst="rect">
             <a:avLst/>
@@ -7999,7 +8096,7 @@
           <a:p>
             <a:pPr algn="ctr"/>
             <a:r>
-              <a:rPr sz="700" b="0" i="0">
+              <a:rPr sz="1000" b="0" i="0">
                 <a:solidFill>
                   <a:srgbClr val="FFFFFF"/>
                 </a:solidFill>
@@ -8018,8 +8115,8 @@
         </p:nvSpPr>
         <p:spPr>
           <a:xfrm>
-            <a:off x="2519780" y="4777359"/>
-            <a:ext cx="549217" cy="549217"/>
+            <a:off x="2752141" y="4692865"/>
+            <a:ext cx="718207" cy="718207"/>
           </a:xfrm>
           <a:prstGeom prst="ellipse">
             <a:avLst/>
@@ -8061,8 +8158,8 @@
         </p:nvSpPr>
         <p:spPr>
           <a:xfrm>
-            <a:off x="2519780" y="4810313"/>
-            <a:ext cx="549217" cy="285592"/>
+            <a:off x="2752141" y="4735957"/>
+            <a:ext cx="718207" cy="373467"/>
           </a:xfrm>
           <a:prstGeom prst="rect">
             <a:avLst/>
@@ -8077,7 +8174,7 @@
           <a:p>
             <a:pPr algn="ctr"/>
             <a:r>
-              <a:rPr sz="1800" b="1">
+              <a:rPr sz="2400" b="1">
                 <a:solidFill>
                   <a:srgbClr val="FFFFFF"/>
                 </a:solidFill>
@@ -8086,7 +8183,7 @@
               <a:t>15</a:t>
             </a:r>
             <a:r>
-              <a:rPr sz="1200" b="1">
+              <a:rPr sz="1500" b="1">
                 <a:solidFill>
                   <a:srgbClr val="FFFFFF"/>
                 </a:solidFill>
@@ -8105,8 +8202,8 @@
         </p:nvSpPr>
         <p:spPr>
           <a:xfrm>
-            <a:off x="2519780" y="5084921"/>
-            <a:ext cx="549217" cy="208702"/>
+            <a:off x="2752141" y="5095060"/>
+            <a:ext cx="718207" cy="272918"/>
           </a:xfrm>
           <a:prstGeom prst="rect">
             <a:avLst/>
@@ -8467,8 +8564,8 @@
         </p:nvSpPr>
         <p:spPr>
           <a:xfrm>
-            <a:off x="3014483" y="2399765"/>
-            <a:ext cx="610241" cy="610241"/>
+            <a:off x="3272662" y="2305882"/>
+            <a:ext cx="798007" cy="798007"/>
           </a:xfrm>
           <a:prstGeom prst="ellipse">
             <a:avLst/>
@@ -8510,8 +8607,8 @@
         </p:nvSpPr>
         <p:spPr>
           <a:xfrm>
-            <a:off x="3014483" y="2436380"/>
-            <a:ext cx="610241" cy="317325"/>
+            <a:off x="3272662" y="2353763"/>
+            <a:ext cx="798007" cy="414964"/>
           </a:xfrm>
           <a:prstGeom prst="rect">
             <a:avLst/>
@@ -8526,7 +8623,7 @@
           <a:p>
             <a:pPr algn="ctr"/>
             <a:r>
-              <a:rPr sz="2000" b="1">
+              <a:rPr sz="2700" b="1">
                 <a:solidFill>
                   <a:srgbClr val="FFFFFF"/>
                 </a:solidFill>
@@ -8535,7 +8632,7 @@
               <a:t>23</a:t>
             </a:r>
             <a:r>
-              <a:rPr sz="1300" b="1">
+              <a:rPr sz="1700" b="1">
                 <a:solidFill>
                   <a:srgbClr val="FFFFFF"/>
                 </a:solidFill>
@@ -8554,8 +8651,8 @@
         </p:nvSpPr>
         <p:spPr>
           <a:xfrm>
-            <a:off x="3014483" y="2741501"/>
-            <a:ext cx="610241" cy="231891"/>
+            <a:off x="3272662" y="2752767"/>
+            <a:ext cx="798007" cy="303242"/>
           </a:xfrm>
           <a:prstGeom prst="rect">
             <a:avLst/>
@@ -8570,7 +8667,7 @@
           <a:p>
             <a:pPr algn="ctr"/>
             <a:r>
-              <a:rPr sz="1000" b="0" i="0">
+              <a:rPr sz="1300" b="0" i="0">
                 <a:solidFill>
                   <a:srgbClr val="FFFFFF"/>
                 </a:solidFill>
@@ -8589,8 +8686,8 @@
         </p:nvSpPr>
         <p:spPr>
           <a:xfrm>
-            <a:off x="4345175" y="4777359"/>
-            <a:ext cx="549217" cy="549217"/>
+            <a:off x="4577536" y="4692865"/>
+            <a:ext cx="718207" cy="718207"/>
           </a:xfrm>
           <a:prstGeom prst="ellipse">
             <a:avLst/>
@@ -8632,8 +8729,8 @@
         </p:nvSpPr>
         <p:spPr>
           <a:xfrm>
-            <a:off x="4345175" y="4810313"/>
-            <a:ext cx="549217" cy="285592"/>
+            <a:off x="4577536" y="4735957"/>
+            <a:ext cx="718207" cy="373467"/>
           </a:xfrm>
           <a:prstGeom prst="rect">
             <a:avLst/>
@@ -8648,7 +8745,7 @@
           <a:p>
             <a:pPr algn="ctr"/>
             <a:r>
-              <a:rPr sz="1800" b="1">
+              <a:rPr sz="2400" b="1">
                 <a:solidFill>
                   <a:srgbClr val="FFFFFF"/>
                 </a:solidFill>
@@ -8657,7 +8754,7 @@
               <a:t>60</a:t>
             </a:r>
             <a:r>
-              <a:rPr sz="1200" b="1">
+              <a:rPr sz="1500" b="1">
                 <a:solidFill>
                   <a:srgbClr val="FFFFFF"/>
                 </a:solidFill>
@@ -8676,8 +8773,8 @@
         </p:nvSpPr>
         <p:spPr>
           <a:xfrm>
-            <a:off x="4345175" y="5084921"/>
-            <a:ext cx="549217" cy="208702"/>
+            <a:off x="4577536" y="5095060"/>
+            <a:ext cx="718207" cy="272918"/>
           </a:xfrm>
           <a:prstGeom prst="rect">
             <a:avLst/>
@@ -8692,7 +8789,7 @@
           <a:p>
             <a:pPr algn="ctr"/>
             <a:r>
-              <a:rPr sz="700" b="0" i="0">
+              <a:rPr sz="1000" b="0" i="0">
                 <a:solidFill>
                   <a:srgbClr val="FFFFFF"/>
                 </a:solidFill>
@@ -9530,16 +9627,181 @@
       <p:grpSpPr/>
       <p:sp>
         <p:nvSpPr>
-          <p:cNvPr id="2" name="Rectangle 1"/>
+          <p:cNvPr id="2" name="Title 1"/>
+          <p:cNvSpPr>
+            <a:spLocks noGrp="1"/>
+          </p:cNvSpPr>
+          <p:nvPr>
+            <p:ph type="title"/>
+          </p:nvPr>
+        </p:nvSpPr>
+        <p:spPr/>
+        <p:txBody>
+          <a:bodyPr/>
+          <a:lstStyle/>
+          <a:p>
+            <a:r>
+              <a:t>Attitudes — broader community views</a:t>
+            </a:r>
+          </a:p>
+        </p:txBody>
+      </p:sp>
+      <p:sp>
+        <p:nvSpPr>
+          <p:cNvPr id="3" name="Text Placeholder 2"/>
+          <p:cNvSpPr>
+            <a:spLocks noGrp="1"/>
+          </p:cNvSpPr>
+          <p:nvPr>
+            <p:ph type="body" idx="21" sz="quarter"/>
+          </p:nvPr>
+        </p:nvSpPr>
+        <p:spPr/>
+        <p:txBody>
+          <a:bodyPr/>
+          <a:lstStyle/>
+          <a:p>
+            <a:r>
+              <a:t>How strongly do you agree or disagree with each of the following statements? (%)</a:t>
+            </a:r>
+          </a:p>
+        </p:txBody>
+      </p:sp>
+      <p:sp>
+        <p:nvSpPr>
+          <p:cNvPr id="4" name="Text Placeholder 3"/>
+          <p:cNvSpPr>
+            <a:spLocks noGrp="1"/>
+          </p:cNvSpPr>
+          <p:nvPr>
+            <p:ph type="body" idx="22" sz="quarter"/>
+          </p:nvPr>
+        </p:nvSpPr>
+        <p:spPr/>
+        <p:txBody>
+          <a:bodyPr/>
+          <a:lstStyle/>
+          <a:p>
+            <a:r>
+              <a:t>Base: all respondents (n=200)</a:t>
+            </a:r>
+          </a:p>
+        </p:txBody>
+      </p:sp>
+      <p:pic>
+        <p:nvPicPr>
+          <p:cNvPr id="5" name="Picture 4" descr="image.png"/>
+          <p:cNvPicPr>
+            <a:picLocks noChangeAspect="1"/>
+          </p:cNvPicPr>
+          <p:nvPr/>
+        </p:nvPicPr>
+        <p:blipFill>
+          <a:blip r:embed="rId2"/>
+          <a:stretch>
+            <a:fillRect/>
+          </a:stretch>
+        </p:blipFill>
+        <p:spPr>
+          <a:xfrm>
+            <a:off x="310896" y="2130552"/>
+            <a:ext cx="8229600" cy="3794760"/>
+          </a:xfrm>
+          <a:prstGeom prst="rect">
+            <a:avLst/>
+          </a:prstGeom>
+        </p:spPr>
+      </p:pic>
+      <p:sp>
+        <p:nvSpPr>
+          <p:cNvPr id="6" name="TextBox 5"/>
+          <p:cNvSpPr txBox="1"/>
+          <p:nvPr/>
+        </p:nvSpPr>
+        <p:spPr>
+          <a:xfrm>
+            <a:off x="8686800" y="2130552"/>
+            <a:ext cx="3136391" cy="3794760"/>
+          </a:xfrm>
+          <a:prstGeom prst="rect">
+            <a:avLst/>
+          </a:prstGeom>
+          <a:noFill/>
+        </p:spPr>
+        <p:txBody>
+          <a:bodyPr wrap="square">
+            <a:spAutoFit/>
+          </a:bodyPr>
+          <a:lstStyle/>
+          <a:p>
+            <a:r>
+              <a:rPr sz="1400" b="0">
+                <a:solidFill>
+                  <a:srgbClr val="44546A"/>
+                </a:solidFill>
+                <a:latin typeface="DM Sans"/>
+              </a:rPr>
+              <a:t>Urgency and scientific clarity are</a:t>
+            </a:r>
+          </a:p>
+          <a:p>
+            <a:r>
+              <a:rPr sz="1400" b="0">
+                <a:solidFill>
+                  <a:srgbClr val="44546A"/>
+                </a:solidFill>
+                <a:latin typeface="DM Sans"/>
+              </a:rPr>
+              <a:t>most agreed-with statements.</a:t>
+            </a:r>
+          </a:p>
+          <a:p>
+            <a:r>
+              <a:rPr sz="1400" b="0">
+                <a:solidFill>
+                  <a:srgbClr val="44546A"/>
+                </a:solidFill>
+                <a:latin typeface="DM Sans"/>
+              </a:rPr>
+              <a:t/>
+            </a:r>
+          </a:p>
+          <a:p>
+            <a:r>
+              <a:rPr sz="1400" b="0">
+                <a:solidFill>
+                  <a:srgbClr val="44546A"/>
+                </a:solidFill>
+                <a:latin typeface="DM Sans"/>
+              </a:rPr>
+              <a:t>Trust and media coverage attract</a:t>
+            </a:r>
+          </a:p>
+          <a:p>
+            <a:r>
+              <a:rPr sz="1400" b="0">
+                <a:solidFill>
+                  <a:srgbClr val="44546A"/>
+                </a:solidFill>
+                <a:latin typeface="DM Sans"/>
+              </a:rPr>
+              <a:t>more scepticism.</a:t>
+            </a:r>
+          </a:p>
+        </p:txBody>
+      </p:sp>
+      <p:sp>
+        <p:nvSpPr>
+          <p:cNvPr id="7" name="Oval 6"/>
           <p:cNvSpPr/>
           <p:nvPr/>
         </p:nvSpPr>
         <p:spPr>
           <a:xfrm>
-            <a:off x="0" y="0"/>
-            <a:ext cx="12188952" cy="6858000"/>
-          </a:xfrm>
-          <a:prstGeom prst="rect">
+            <a:off x="11548872" y="6217920"/>
+            <a:ext cx="274320" cy="274320"/>
+          </a:xfrm>
+          <a:prstGeom prst="ellipse">
             <a:avLst/>
           </a:prstGeom>
           <a:solidFill>
@@ -9573,14 +9835,14 @@
       </p:sp>
       <p:sp>
         <p:nvSpPr>
-          <p:cNvPr id="3" name="TextBox 2"/>
+          <p:cNvPr id="8" name="TextBox 7"/>
           <p:cNvSpPr txBox="1"/>
           <p:nvPr/>
         </p:nvSpPr>
         <p:spPr>
           <a:xfrm>
-            <a:off x="612648" y="2743200"/>
-            <a:ext cx="10972800" cy="1097280"/>
+            <a:off x="11548872" y="6250838"/>
+            <a:ext cx="274320" cy="208483"/>
           </a:xfrm>
           <a:prstGeom prst="rect">
             <a:avLst/>
@@ -9593,15 +9855,15 @@
           </a:bodyPr>
           <a:lstStyle/>
           <a:p>
-            <a:pPr algn="l"/>
-            <a:r>
-              <a:rPr sz="2800" b="1" i="0">
+            <a:pPr algn="ctr"/>
+            <a:r>
+              <a:rPr sz="1000" b="1" i="0">
                 <a:solidFill>
                   <a:srgbClr val="FFFFFF"/>
                 </a:solidFill>
                 <a:latin typeface="DM Sans"/>
               </a:rPr>
-              <a:t>Demographics</a:t>
+              <a:t>6</a:t>
             </a:r>
           </a:p>
         </p:txBody>

</xml_diff>

<commit_message>
Fix grid colours, add DM Sans font, bigger axes/legend, table slide type
- Register DM Sans variable font from /usr/local/share/fonts/dmsans
- Fix LIKERT_COLORS order: [TEAL_DARK, TEAL_MID, GRAY_MID, SALMON, CORAL]
- Add bottom_box to Q1 energy climate grid so "Not that/at all bad"
  segments render as salmon/coral instead of flat gray
- Increase AXIS_LEFT 0.30→0.38, GRID_AXIS_LEFT 0.40→0.48 for more
  y-axis label space throughout
- Dynamic legend bottom margin (0.70" fixed absolute height) so large
  charts don't waste space on legend padding
- Legend font size 9→11pt, grid label font scaled to n_rows
- _GRID_CHART_MAX_H 4.15→4.30" to fit 13-row Q3 on one slide
- New 'table' slide type in slide_builder.py: two-column pptx table
  with alternating row shading, for coded open-end data
- Merge Q3a/Q3b into single 13-row grid slide in wa_energy_annotations
- Change Q6 (reasons) to table slide type

https://claude.ai/code/session_01VCXkWfprNAwES9BXV74rqk
</commit_message>
<xml_diff>
--- a/sample_data/output.pptx
+++ b/sample_data/output.pptx
@@ -7993,7 +7993,7 @@
         </p:nvSpPr>
         <p:spPr>
           <a:xfrm>
-            <a:off x="4589672" y="2305882"/>
+            <a:off x="4663571" y="2305882"/>
             <a:ext cx="798007" cy="798007"/>
           </a:xfrm>
           <a:prstGeom prst="ellipse">
@@ -8036,7 +8036,7 @@
         </p:nvSpPr>
         <p:spPr>
           <a:xfrm>
-            <a:off x="4589672" y="2353763"/>
+            <a:off x="4663571" y="2353763"/>
             <a:ext cx="798007" cy="414964"/>
           </a:xfrm>
           <a:prstGeom prst="rect">
@@ -8080,7 +8080,7 @@
         </p:nvSpPr>
         <p:spPr>
           <a:xfrm>
-            <a:off x="4589672" y="2752767"/>
+            <a:off x="4663571" y="2752767"/>
             <a:ext cx="798007" cy="303242"/>
           </a:xfrm>
           <a:prstGeom prst="rect">
@@ -8115,7 +8115,7 @@
         </p:nvSpPr>
         <p:spPr>
           <a:xfrm>
-            <a:off x="2752141" y="4692865"/>
+            <a:off x="3070246" y="4692865"/>
             <a:ext cx="718207" cy="718207"/>
           </a:xfrm>
           <a:prstGeom prst="ellipse">
@@ -8158,7 +8158,7 @@
         </p:nvSpPr>
         <p:spPr>
           <a:xfrm>
-            <a:off x="2752141" y="4735957"/>
+            <a:off x="3070246" y="4735957"/>
             <a:ext cx="718207" cy="373467"/>
           </a:xfrm>
           <a:prstGeom prst="rect">
@@ -8202,7 +8202,7 @@
         </p:nvSpPr>
         <p:spPr>
           <a:xfrm>
-            <a:off x="2752141" y="5095060"/>
+            <a:off x="3070246" y="5095060"/>
             <a:ext cx="718207" cy="272918"/>
           </a:xfrm>
           <a:prstGeom prst="rect">
@@ -8564,7 +8564,7 @@
         </p:nvSpPr>
         <p:spPr>
           <a:xfrm>
-            <a:off x="3272662" y="2305882"/>
+            <a:off x="3522162" y="2305882"/>
             <a:ext cx="798007" cy="798007"/>
           </a:xfrm>
           <a:prstGeom prst="ellipse">
@@ -8607,7 +8607,7 @@
         </p:nvSpPr>
         <p:spPr>
           <a:xfrm>
-            <a:off x="3272662" y="2353763"/>
+            <a:off x="3522162" y="2353763"/>
             <a:ext cx="798007" cy="414964"/>
           </a:xfrm>
           <a:prstGeom prst="rect">
@@ -8651,7 +8651,7 @@
         </p:nvSpPr>
         <p:spPr>
           <a:xfrm>
-            <a:off x="3272662" y="2752767"/>
+            <a:off x="3522162" y="2752767"/>
             <a:ext cx="798007" cy="303242"/>
           </a:xfrm>
           <a:prstGeom prst="rect">
@@ -8686,7 +8686,7 @@
         </p:nvSpPr>
         <p:spPr>
           <a:xfrm>
-            <a:off x="4577536" y="4692865"/>
+            <a:off x="4652255" y="4692865"/>
             <a:ext cx="718207" cy="718207"/>
           </a:xfrm>
           <a:prstGeom prst="ellipse">
@@ -8729,7 +8729,7 @@
         </p:nvSpPr>
         <p:spPr>
           <a:xfrm>
-            <a:off x="4577536" y="4735957"/>
+            <a:off x="4652255" y="4735957"/>
             <a:ext cx="718207" cy="373467"/>
           </a:xfrm>
           <a:prstGeom prst="rect">
@@ -8773,7 +8773,7 @@
         </p:nvSpPr>
         <p:spPr>
           <a:xfrm>
-            <a:off x="4577536" y="5095060"/>
+            <a:off x="4652255" y="5095060"/>
             <a:ext cx="718207" cy="272918"/>
           </a:xfrm>
           <a:prstGeom prst="rect">
@@ -9704,8 +9704,8 @@
         </p:blipFill>
         <p:spPr>
           <a:xfrm>
-            <a:off x="310896" y="2130552"/>
-            <a:ext cx="8229600" cy="3794760"/>
+            <a:off x="310896" y="2061972"/>
+            <a:ext cx="8229600" cy="3931920"/>
           </a:xfrm>
           <a:prstGeom prst="rect">
             <a:avLst/>
@@ -9720,8 +9720,8 @@
         </p:nvSpPr>
         <p:spPr>
           <a:xfrm>
-            <a:off x="8686800" y="2130552"/>
-            <a:ext cx="3136391" cy="3794760"/>
+            <a:off x="8686800" y="2061972"/>
+            <a:ext cx="3136391" cy="3931920"/>
           </a:xfrm>
           <a:prstGeom prst="rect">
             <a:avLst/>

</xml_diff>

<commit_message>
Fix all reported issues: grid colours, pie, circles, table layout
Grid colours:
- Add bottom_box to Q3 (Somewhat/Very unlikely → salmon/coral)
- Q1 (badness) already has bottom_box; grids now all use distinct 5-colour scheme

Table slide (Q6):
- Switch to blank layout — no sidebar, full-width table
- Remove label_map from wa_energy_report.py so full Excel text is shown
- Each cell: bold the 'Title' before ': ', normal weight for explanation text

Pie (Q4 solar):
- Add top_box/bottom_box to YAML so Yes→teal, No→salmon, Unsure→gray
- Code fix: pass colors=None when no boxes defined (avoids all-same teal)

Bar circles (Q5 support):
- r = max(0.38, min(0.72, bar_h_slide * 1.00))  — bigger than before

Grid: small grids (Q1 — 3 rows) now min 4.00" tall to fill mint strip
Grid axis label: GRID_AXIS_LEFT 0.48→0.54; font 10/9/8→11/10/9 by n_rows
Grid circles: min 16pt diameter; multiplier 1.0×bar_h→1.4×bar_h

https://claude.ai/code/session_01VCXkWfprNAwES9BXV74rqk
</commit_message>
<xml_diff>
--- a/sample_data/output.pptx
+++ b/sample_data/output.pptx
@@ -7993,8 +7993,8 @@
         </p:nvSpPr>
         <p:spPr>
           <a:xfrm>
-            <a:off x="4663571" y="2305882"/>
-            <a:ext cx="798007" cy="798007"/>
+            <a:off x="4674133" y="2235470"/>
+            <a:ext cx="938832" cy="938832"/>
           </a:xfrm>
           <a:prstGeom prst="ellipse">
             <a:avLst/>
@@ -8036,8 +8036,8 @@
         </p:nvSpPr>
         <p:spPr>
           <a:xfrm>
-            <a:off x="4663571" y="2353763"/>
-            <a:ext cx="798007" cy="414964"/>
+            <a:off x="4674133" y="2291800"/>
+            <a:ext cx="938832" cy="488193"/>
           </a:xfrm>
           <a:prstGeom prst="rect">
             <a:avLst/>
@@ -8052,7 +8052,7 @@
           <a:p>
             <a:pPr algn="ctr"/>
             <a:r>
-              <a:rPr sz="2700" b="1">
+              <a:rPr sz="3100" b="1">
                 <a:solidFill>
                   <a:srgbClr val="FFFFFF"/>
                 </a:solidFill>
@@ -8061,7 +8061,7 @@
               <a:t>60</a:t>
             </a:r>
             <a:r>
-              <a:rPr sz="1700" b="1">
+              <a:rPr sz="2000" b="1">
                 <a:solidFill>
                   <a:srgbClr val="FFFFFF"/>
                 </a:solidFill>
@@ -8080,8 +8080,8 @@
         </p:nvSpPr>
         <p:spPr>
           <a:xfrm>
-            <a:off x="4663571" y="2752767"/>
-            <a:ext cx="798007" cy="303242"/>
+            <a:off x="4674133" y="2761216"/>
+            <a:ext cx="938832" cy="356756"/>
           </a:xfrm>
           <a:prstGeom prst="rect">
             <a:avLst/>
@@ -8096,7 +8096,7 @@
           <a:p>
             <a:pPr algn="ctr"/>
             <a:r>
-              <a:rPr sz="1000" b="0" i="0">
+              <a:rPr sz="1200" b="0" i="0">
                 <a:solidFill>
                   <a:srgbClr val="FFFFFF"/>
                 </a:solidFill>
@@ -8115,8 +8115,8 @@
         </p:nvSpPr>
         <p:spPr>
           <a:xfrm>
-            <a:off x="3070246" y="4692865"/>
-            <a:ext cx="718207" cy="718207"/>
+            <a:off x="3079752" y="4629493"/>
+            <a:ext cx="844949" cy="844949"/>
           </a:xfrm>
           <a:prstGeom prst="ellipse">
             <a:avLst/>
@@ -8158,8 +8158,8 @@
         </p:nvSpPr>
         <p:spPr>
           <a:xfrm>
-            <a:off x="3070246" y="4735957"/>
-            <a:ext cx="718207" cy="373467"/>
+            <a:off x="3079752" y="4680190"/>
+            <a:ext cx="844949" cy="439373"/>
           </a:xfrm>
           <a:prstGeom prst="rect">
             <a:avLst/>
@@ -8174,7 +8174,7 @@
           <a:p>
             <a:pPr algn="ctr"/>
             <a:r>
-              <a:rPr sz="2400" b="1">
+              <a:rPr sz="2800" b="1">
                 <a:solidFill>
                   <a:srgbClr val="FFFFFF"/>
                 </a:solidFill>
@@ -8183,7 +8183,7 @@
               <a:t>15</a:t>
             </a:r>
             <a:r>
-              <a:rPr sz="1500" b="1">
+              <a:rPr sz="1800" b="1">
                 <a:solidFill>
                   <a:srgbClr val="FFFFFF"/>
                 </a:solidFill>
@@ -8202,8 +8202,8 @@
         </p:nvSpPr>
         <p:spPr>
           <a:xfrm>
-            <a:off x="3070246" y="5095060"/>
-            <a:ext cx="718207" cy="272918"/>
+            <a:off x="3079752" y="5102665"/>
+            <a:ext cx="844949" cy="321080"/>
           </a:xfrm>
           <a:prstGeom prst="rect">
             <a:avLst/>
@@ -8218,7 +8218,7 @@
           <a:p>
             <a:pPr algn="ctr"/>
             <a:r>
-              <a:rPr sz="600" b="0" i="0">
+              <a:rPr sz="700" b="0" i="0">
                 <a:solidFill>
                   <a:srgbClr val="FFFFFF"/>
                 </a:solidFill>
@@ -8564,8 +8564,8 @@
         </p:nvSpPr>
         <p:spPr>
           <a:xfrm>
-            <a:off x="3522162" y="2305882"/>
-            <a:ext cx="798007" cy="798007"/>
+            <a:off x="3532724" y="2235470"/>
+            <a:ext cx="938832" cy="938832"/>
           </a:xfrm>
           <a:prstGeom prst="ellipse">
             <a:avLst/>
@@ -8607,8 +8607,8 @@
         </p:nvSpPr>
         <p:spPr>
           <a:xfrm>
-            <a:off x="3522162" y="2353763"/>
-            <a:ext cx="798007" cy="414964"/>
+            <a:off x="3532724" y="2291800"/>
+            <a:ext cx="938832" cy="488193"/>
           </a:xfrm>
           <a:prstGeom prst="rect">
             <a:avLst/>
@@ -8623,7 +8623,7 @@
           <a:p>
             <a:pPr algn="ctr"/>
             <a:r>
-              <a:rPr sz="2700" b="1">
+              <a:rPr sz="3100" b="1">
                 <a:solidFill>
                   <a:srgbClr val="FFFFFF"/>
                 </a:solidFill>
@@ -8632,7 +8632,7 @@
               <a:t>23</a:t>
             </a:r>
             <a:r>
-              <a:rPr sz="1700" b="1">
+              <a:rPr sz="2000" b="1">
                 <a:solidFill>
                   <a:srgbClr val="FFFFFF"/>
                 </a:solidFill>
@@ -8651,8 +8651,8 @@
         </p:nvSpPr>
         <p:spPr>
           <a:xfrm>
-            <a:off x="3522162" y="2752767"/>
-            <a:ext cx="798007" cy="303242"/>
+            <a:off x="3532724" y="2761216"/>
+            <a:ext cx="938832" cy="356756"/>
           </a:xfrm>
           <a:prstGeom prst="rect">
             <a:avLst/>
@@ -8667,7 +8667,7 @@
           <a:p>
             <a:pPr algn="ctr"/>
             <a:r>
-              <a:rPr sz="1300" b="0" i="0">
+              <a:rPr sz="1600" b="0" i="0">
                 <a:solidFill>
                   <a:srgbClr val="FFFFFF"/>
                 </a:solidFill>
@@ -8686,8 +8686,8 @@
         </p:nvSpPr>
         <p:spPr>
           <a:xfrm>
-            <a:off x="4652255" y="4692865"/>
-            <a:ext cx="718207" cy="718207"/>
+            <a:off x="4661761" y="4629493"/>
+            <a:ext cx="844949" cy="844949"/>
           </a:xfrm>
           <a:prstGeom prst="ellipse">
             <a:avLst/>
@@ -8729,8 +8729,8 @@
         </p:nvSpPr>
         <p:spPr>
           <a:xfrm>
-            <a:off x="4652255" y="4735957"/>
-            <a:ext cx="718207" cy="373467"/>
+            <a:off x="4661761" y="4680190"/>
+            <a:ext cx="844949" cy="439373"/>
           </a:xfrm>
           <a:prstGeom prst="rect">
             <a:avLst/>
@@ -8745,7 +8745,7 @@
           <a:p>
             <a:pPr algn="ctr"/>
             <a:r>
-              <a:rPr sz="2400" b="1">
+              <a:rPr sz="2800" b="1">
                 <a:solidFill>
                   <a:srgbClr val="FFFFFF"/>
                 </a:solidFill>
@@ -8754,7 +8754,7 @@
               <a:t>60</a:t>
             </a:r>
             <a:r>
-              <a:rPr sz="1500" b="1">
+              <a:rPr sz="1800" b="1">
                 <a:solidFill>
                   <a:srgbClr val="FFFFFF"/>
                 </a:solidFill>
@@ -8773,8 +8773,8 @@
         </p:nvSpPr>
         <p:spPr>
           <a:xfrm>
-            <a:off x="4652255" y="5095060"/>
-            <a:ext cx="718207" cy="272918"/>
+            <a:off x="4661761" y="5102665"/>
+            <a:ext cx="844949" cy="321080"/>
           </a:xfrm>
           <a:prstGeom prst="rect">
             <a:avLst/>
@@ -8789,7 +8789,7 @@
           <a:p>
             <a:pPr algn="ctr"/>
             <a:r>
-              <a:rPr sz="1000" b="0" i="0">
+              <a:rPr sz="1200" b="0" i="0">
                 <a:solidFill>
                   <a:srgbClr val="FFFFFF"/>
                 </a:solidFill>
@@ -9160,8 +9160,8 @@
         </p:blipFill>
         <p:spPr>
           <a:xfrm>
-            <a:off x="310896" y="2587752"/>
-            <a:ext cx="8229600" cy="2880360"/>
+            <a:off x="310896" y="2199132"/>
+            <a:ext cx="8229600" cy="3657600"/>
           </a:xfrm>
           <a:prstGeom prst="rect">
             <a:avLst/>
@@ -9176,8 +9176,8 @@
         </p:nvSpPr>
         <p:spPr>
           <a:xfrm>
-            <a:off x="8686800" y="2587752"/>
-            <a:ext cx="3136391" cy="2880360"/>
+            <a:off x="8686800" y="2199132"/>
+            <a:ext cx="3136391" cy="3657600"/>
           </a:xfrm>
           <a:prstGeom prst="rect">
             <a:avLst/>

</xml_diff>

<commit_message>
Remove duplicate page numbers; fix table slide layout
Page numbers: removed all manual teal-oval page number additions from
_add_footer, add_chart_slide, and add_grid_slide. The template master
already handles slide numbering via its built-in placeholder.

Table slide:
- Switch from Blank layout to '1_Title Slide' (layout 10) which has a
  white solid background but the SAME title (ph 0), question (ph 21),
  and footer (ph 22) placeholders as the chart-slide Title Slide layout.
  This gives identical heading/question/base styling without the diagonal
  teal panel.
- Heading and question now filled via _fill_placeholder (template-styled)
  with the same fallback pattern as add_chart_slide.
- Footer/base also via placeholder or _add_footer fallback.

https://claude.ai/code/session_01VCXkWfprNAwES9BXV74rqk
</commit_message>
<xml_diff>
--- a/sample_data/output.pptx
+++ b/sample_data/output.pptx
@@ -7190,84 +7190,6 @@
           </a:p>
         </p:txBody>
       </p:sp>
-      <p:sp>
-        <p:nvSpPr>
-          <p:cNvPr id="7" name="Oval 6"/>
-          <p:cNvSpPr/>
-          <p:nvPr/>
-        </p:nvSpPr>
-        <p:spPr>
-          <a:xfrm>
-            <a:off x="11548872" y="6217920"/>
-            <a:ext cx="274320" cy="274320"/>
-          </a:xfrm>
-          <a:prstGeom prst="ellipse">
-            <a:avLst/>
-          </a:prstGeom>
-          <a:solidFill>
-            <a:srgbClr val="027F7C"/>
-          </a:solidFill>
-          <a:ln>
-            <a:noFill/>
-          </a:ln>
-        </p:spPr>
-        <p:style>
-          <a:lnRef idx="1">
-            <a:schemeClr val="accent1"/>
-          </a:lnRef>
-          <a:fillRef idx="3">
-            <a:schemeClr val="accent1"/>
-          </a:fillRef>
-          <a:effectRef idx="2">
-            <a:schemeClr val="accent1"/>
-          </a:effectRef>
-          <a:fontRef idx="minor">
-            <a:schemeClr val="lt1"/>
-          </a:fontRef>
-        </p:style>
-        <p:txBody>
-          <a:bodyPr rtlCol="0" anchor="ctr"/>
-          <a:lstStyle/>
-          <a:p>
-            <a:pPr algn="ctr"/>
-          </a:p>
-        </p:txBody>
-      </p:sp>
-      <p:sp>
-        <p:nvSpPr>
-          <p:cNvPr id="8" name="TextBox 7"/>
-          <p:cNvSpPr txBox="1"/>
-          <p:nvPr/>
-        </p:nvSpPr>
-        <p:spPr>
-          <a:xfrm>
-            <a:off x="11548872" y="6250838"/>
-            <a:ext cx="274320" cy="208483"/>
-          </a:xfrm>
-          <a:prstGeom prst="rect">
-            <a:avLst/>
-          </a:prstGeom>
-          <a:noFill/>
-        </p:spPr>
-        <p:txBody>
-          <a:bodyPr wrap="square">
-            <a:spAutoFit/>
-          </a:bodyPr>
-          <a:lstStyle/>
-          <a:p>
-            <a:pPr algn="ctr"/>
-            <a:r>
-              <a:rPr sz="1000" b="1" i="0">
-                <a:solidFill>
-                  <a:srgbClr val="FFFFFF"/>
-                </a:solidFill>
-                <a:latin typeface="DM Sans"/>
-              </a:rPr>
-              <a:t>7</a:t>
-            </a:r>
-          </a:p>
-        </p:txBody>
-      </p:sp>
     </p:spTree>
   </p:cSld>
   <p:clrMapOvr>
@@ -7418,84 +7340,6 @@
           </a:p>
         </p:txBody>
       </p:sp>
-      <p:sp>
-        <p:nvSpPr>
-          <p:cNvPr id="7" name="Oval 6"/>
-          <p:cNvSpPr/>
-          <p:nvPr/>
-        </p:nvSpPr>
-        <p:spPr>
-          <a:xfrm>
-            <a:off x="11548872" y="6217920"/>
-            <a:ext cx="274320" cy="274320"/>
-          </a:xfrm>
-          <a:prstGeom prst="ellipse">
-            <a:avLst/>
-          </a:prstGeom>
-          <a:solidFill>
-            <a:srgbClr val="027F7C"/>
-          </a:solidFill>
-          <a:ln>
-            <a:noFill/>
-          </a:ln>
-        </p:spPr>
-        <p:style>
-          <a:lnRef idx="1">
-            <a:schemeClr val="accent1"/>
-          </a:lnRef>
-          <a:fillRef idx="3">
-            <a:schemeClr val="accent1"/>
-          </a:fillRef>
-          <a:effectRef idx="2">
-            <a:schemeClr val="accent1"/>
-          </a:effectRef>
-          <a:fontRef idx="minor">
-            <a:schemeClr val="lt1"/>
-          </a:fontRef>
-        </p:style>
-        <p:txBody>
-          <a:bodyPr rtlCol="0" anchor="ctr"/>
-          <a:lstStyle/>
-          <a:p>
-            <a:pPr algn="ctr"/>
-          </a:p>
-        </p:txBody>
-      </p:sp>
-      <p:sp>
-        <p:nvSpPr>
-          <p:cNvPr id="8" name="TextBox 7"/>
-          <p:cNvSpPr txBox="1"/>
-          <p:nvPr/>
-        </p:nvSpPr>
-        <p:spPr>
-          <a:xfrm>
-            <a:off x="11548872" y="6250838"/>
-            <a:ext cx="274320" cy="208483"/>
-          </a:xfrm>
-          <a:prstGeom prst="rect">
-            <a:avLst/>
-          </a:prstGeom>
-          <a:noFill/>
-        </p:spPr>
-        <p:txBody>
-          <a:bodyPr wrap="square">
-            <a:spAutoFit/>
-          </a:bodyPr>
-          <a:lstStyle/>
-          <a:p>
-            <a:pPr algn="ctr"/>
-            <a:r>
-              <a:rPr sz="1000" b="1" i="0">
-                <a:solidFill>
-                  <a:srgbClr val="FFFFFF"/>
-                </a:solidFill>
-                <a:latin typeface="DM Sans"/>
-              </a:rPr>
-              <a:t>8</a:t>
-            </a:r>
-          </a:p>
-        </p:txBody>
-      </p:sp>
     </p:spTree>
   </p:cSld>
   <p:clrMapOvr>
@@ -7802,84 +7646,6 @@
           </a:p>
         </p:txBody>
       </p:sp>
-      <p:sp>
-        <p:nvSpPr>
-          <p:cNvPr id="6" name="Oval 5"/>
-          <p:cNvSpPr/>
-          <p:nvPr/>
-        </p:nvSpPr>
-        <p:spPr>
-          <a:xfrm>
-            <a:off x="11548872" y="6217920"/>
-            <a:ext cx="274320" cy="274320"/>
-          </a:xfrm>
-          <a:prstGeom prst="ellipse">
-            <a:avLst/>
-          </a:prstGeom>
-          <a:solidFill>
-            <a:srgbClr val="027F7C"/>
-          </a:solidFill>
-          <a:ln>
-            <a:noFill/>
-          </a:ln>
-        </p:spPr>
-        <p:style>
-          <a:lnRef idx="1">
-            <a:schemeClr val="accent1"/>
-          </a:lnRef>
-          <a:fillRef idx="3">
-            <a:schemeClr val="accent1"/>
-          </a:fillRef>
-          <a:effectRef idx="2">
-            <a:schemeClr val="accent1"/>
-          </a:effectRef>
-          <a:fontRef idx="minor">
-            <a:schemeClr val="lt1"/>
-          </a:fontRef>
-        </p:style>
-        <p:txBody>
-          <a:bodyPr rtlCol="0" anchor="ctr"/>
-          <a:lstStyle/>
-          <a:p>
-            <a:pPr algn="ctr"/>
-          </a:p>
-        </p:txBody>
-      </p:sp>
-      <p:sp>
-        <p:nvSpPr>
-          <p:cNvPr id="7" name="TextBox 6"/>
-          <p:cNvSpPr txBox="1"/>
-          <p:nvPr/>
-        </p:nvSpPr>
-        <p:spPr>
-          <a:xfrm>
-            <a:off x="11548872" y="6250838"/>
-            <a:ext cx="274320" cy="208483"/>
-          </a:xfrm>
-          <a:prstGeom prst="rect">
-            <a:avLst/>
-          </a:prstGeom>
-          <a:noFill/>
-        </p:spPr>
-        <p:txBody>
-          <a:bodyPr wrap="square">
-            <a:spAutoFit/>
-          </a:bodyPr>
-          <a:lstStyle/>
-          <a:p>
-            <a:pPr algn="ctr"/>
-            <a:r>
-              <a:rPr sz="1000" b="1" i="0">
-                <a:solidFill>
-                  <a:srgbClr val="FFFFFF"/>
-                </a:solidFill>
-                <a:latin typeface="DM Sans"/>
-              </a:rPr>
-              <a:t>1</a:t>
-            </a:r>
-          </a:p>
-        </p:txBody>
-      </p:sp>
     </p:spTree>
   </p:cSld>
   <p:clrMapOvr>
@@ -8373,84 +8139,6 @@
           </a:p>
         </p:txBody>
       </p:sp>
-      <p:sp>
-        <p:nvSpPr>
-          <p:cNvPr id="13" name="Oval 12"/>
-          <p:cNvSpPr/>
-          <p:nvPr/>
-        </p:nvSpPr>
-        <p:spPr>
-          <a:xfrm>
-            <a:off x="11548872" y="6217920"/>
-            <a:ext cx="274320" cy="274320"/>
-          </a:xfrm>
-          <a:prstGeom prst="ellipse">
-            <a:avLst/>
-          </a:prstGeom>
-          <a:solidFill>
-            <a:srgbClr val="027F7C"/>
-          </a:solidFill>
-          <a:ln>
-            <a:noFill/>
-          </a:ln>
-        </p:spPr>
-        <p:style>
-          <a:lnRef idx="1">
-            <a:schemeClr val="accent1"/>
-          </a:lnRef>
-          <a:fillRef idx="3">
-            <a:schemeClr val="accent1"/>
-          </a:fillRef>
-          <a:effectRef idx="2">
-            <a:schemeClr val="accent1"/>
-          </a:effectRef>
-          <a:fontRef idx="minor">
-            <a:schemeClr val="lt1"/>
-          </a:fontRef>
-        </p:style>
-        <p:txBody>
-          <a:bodyPr rtlCol="0" anchor="ctr"/>
-          <a:lstStyle/>
-          <a:p>
-            <a:pPr algn="ctr"/>
-          </a:p>
-        </p:txBody>
-      </p:sp>
-      <p:sp>
-        <p:nvSpPr>
-          <p:cNvPr id="14" name="TextBox 13"/>
-          <p:cNvSpPr txBox="1"/>
-          <p:nvPr/>
-        </p:nvSpPr>
-        <p:spPr>
-          <a:xfrm>
-            <a:off x="11548872" y="6250838"/>
-            <a:ext cx="274320" cy="208483"/>
-          </a:xfrm>
-          <a:prstGeom prst="rect">
-            <a:avLst/>
-          </a:prstGeom>
-          <a:noFill/>
-        </p:spPr>
-        <p:txBody>
-          <a:bodyPr wrap="square">
-            <a:spAutoFit/>
-          </a:bodyPr>
-          <a:lstStyle/>
-          <a:p>
-            <a:pPr algn="ctr"/>
-            <a:r>
-              <a:rPr sz="1000" b="1" i="0">
-                <a:solidFill>
-                  <a:srgbClr val="FFFFFF"/>
-                </a:solidFill>
-                <a:latin typeface="DM Sans"/>
-              </a:rPr>
-              <a:t>2</a:t>
-            </a:r>
-          </a:p>
-        </p:txBody>
-      </p:sp>
     </p:spTree>
   </p:cSld>
   <p:clrMapOvr>
@@ -8889,84 +8577,6 @@
           </a:p>
         </p:txBody>
       </p:sp>
-      <p:sp>
-        <p:nvSpPr>
-          <p:cNvPr id="13" name="Oval 12"/>
-          <p:cNvSpPr/>
-          <p:nvPr/>
-        </p:nvSpPr>
-        <p:spPr>
-          <a:xfrm>
-            <a:off x="11548872" y="6217920"/>
-            <a:ext cx="274320" cy="274320"/>
-          </a:xfrm>
-          <a:prstGeom prst="ellipse">
-            <a:avLst/>
-          </a:prstGeom>
-          <a:solidFill>
-            <a:srgbClr val="027F7C"/>
-          </a:solidFill>
-          <a:ln>
-            <a:noFill/>
-          </a:ln>
-        </p:spPr>
-        <p:style>
-          <a:lnRef idx="1">
-            <a:schemeClr val="accent1"/>
-          </a:lnRef>
-          <a:fillRef idx="3">
-            <a:schemeClr val="accent1"/>
-          </a:fillRef>
-          <a:effectRef idx="2">
-            <a:schemeClr val="accent1"/>
-          </a:effectRef>
-          <a:fontRef idx="minor">
-            <a:schemeClr val="lt1"/>
-          </a:fontRef>
-        </p:style>
-        <p:txBody>
-          <a:bodyPr rtlCol="0" anchor="ctr"/>
-          <a:lstStyle/>
-          <a:p>
-            <a:pPr algn="ctr"/>
-          </a:p>
-        </p:txBody>
-      </p:sp>
-      <p:sp>
-        <p:nvSpPr>
-          <p:cNvPr id="14" name="TextBox 13"/>
-          <p:cNvSpPr txBox="1"/>
-          <p:nvPr/>
-        </p:nvSpPr>
-        <p:spPr>
-          <a:xfrm>
-            <a:off x="11548872" y="6250838"/>
-            <a:ext cx="274320" cy="208483"/>
-          </a:xfrm>
-          <a:prstGeom prst="rect">
-            <a:avLst/>
-          </a:prstGeom>
-          <a:noFill/>
-        </p:spPr>
-        <p:txBody>
-          <a:bodyPr wrap="square">
-            <a:spAutoFit/>
-          </a:bodyPr>
-          <a:lstStyle/>
-          <a:p>
-            <a:pPr algn="ctr"/>
-            <a:r>
-              <a:rPr sz="1000" b="1" i="0">
-                <a:solidFill>
-                  <a:srgbClr val="FFFFFF"/>
-                </a:solidFill>
-                <a:latin typeface="DM Sans"/>
-              </a:rPr>
-              <a:t>3</a:t>
-            </a:r>
-          </a:p>
-        </p:txBody>
-      </p:sp>
     </p:spTree>
   </p:cSld>
   <p:clrMapOvr>
@@ -9268,84 +8878,6 @@
           </a:p>
         </p:txBody>
       </p:sp>
-      <p:sp>
-        <p:nvSpPr>
-          <p:cNvPr id="7" name="Oval 6"/>
-          <p:cNvSpPr/>
-          <p:nvPr/>
-        </p:nvSpPr>
-        <p:spPr>
-          <a:xfrm>
-            <a:off x="11548872" y="6217920"/>
-            <a:ext cx="274320" cy="274320"/>
-          </a:xfrm>
-          <a:prstGeom prst="ellipse">
-            <a:avLst/>
-          </a:prstGeom>
-          <a:solidFill>
-            <a:srgbClr val="027F7C"/>
-          </a:solidFill>
-          <a:ln>
-            <a:noFill/>
-          </a:ln>
-        </p:spPr>
-        <p:style>
-          <a:lnRef idx="1">
-            <a:schemeClr val="accent1"/>
-          </a:lnRef>
-          <a:fillRef idx="3">
-            <a:schemeClr val="accent1"/>
-          </a:fillRef>
-          <a:effectRef idx="2">
-            <a:schemeClr val="accent1"/>
-          </a:effectRef>
-          <a:fontRef idx="minor">
-            <a:schemeClr val="lt1"/>
-          </a:fontRef>
-        </p:style>
-        <p:txBody>
-          <a:bodyPr rtlCol="0" anchor="ctr"/>
-          <a:lstStyle/>
-          <a:p>
-            <a:pPr algn="ctr"/>
-          </a:p>
-        </p:txBody>
-      </p:sp>
-      <p:sp>
-        <p:nvSpPr>
-          <p:cNvPr id="8" name="TextBox 7"/>
-          <p:cNvSpPr txBox="1"/>
-          <p:nvPr/>
-        </p:nvSpPr>
-        <p:spPr>
-          <a:xfrm>
-            <a:off x="11548872" y="6250838"/>
-            <a:ext cx="274320" cy="208483"/>
-          </a:xfrm>
-          <a:prstGeom prst="rect">
-            <a:avLst/>
-          </a:prstGeom>
-          <a:noFill/>
-        </p:spPr>
-        <p:txBody>
-          <a:bodyPr wrap="square">
-            <a:spAutoFit/>
-          </a:bodyPr>
-          <a:lstStyle/>
-          <a:p>
-            <a:pPr algn="ctr"/>
-            <a:r>
-              <a:rPr sz="1000" b="1" i="0">
-                <a:solidFill>
-                  <a:srgbClr val="FFFFFF"/>
-                </a:solidFill>
-                <a:latin typeface="DM Sans"/>
-              </a:rPr>
-              <a:t>4</a:t>
-            </a:r>
-          </a:p>
-        </p:txBody>
-      </p:sp>
     </p:spTree>
   </p:cSld>
   <p:clrMapOvr>
@@ -9529,84 +9061,6 @@
           </a:p>
         </p:txBody>
       </p:sp>
-      <p:sp>
-        <p:nvSpPr>
-          <p:cNvPr id="7" name="Oval 6"/>
-          <p:cNvSpPr/>
-          <p:nvPr/>
-        </p:nvSpPr>
-        <p:spPr>
-          <a:xfrm>
-            <a:off x="11548872" y="6217920"/>
-            <a:ext cx="274320" cy="274320"/>
-          </a:xfrm>
-          <a:prstGeom prst="ellipse">
-            <a:avLst/>
-          </a:prstGeom>
-          <a:solidFill>
-            <a:srgbClr val="027F7C"/>
-          </a:solidFill>
-          <a:ln>
-            <a:noFill/>
-          </a:ln>
-        </p:spPr>
-        <p:style>
-          <a:lnRef idx="1">
-            <a:schemeClr val="accent1"/>
-          </a:lnRef>
-          <a:fillRef idx="3">
-            <a:schemeClr val="accent1"/>
-          </a:fillRef>
-          <a:effectRef idx="2">
-            <a:schemeClr val="accent1"/>
-          </a:effectRef>
-          <a:fontRef idx="minor">
-            <a:schemeClr val="lt1"/>
-          </a:fontRef>
-        </p:style>
-        <p:txBody>
-          <a:bodyPr rtlCol="0" anchor="ctr"/>
-          <a:lstStyle/>
-          <a:p>
-            <a:pPr algn="ctr"/>
-          </a:p>
-        </p:txBody>
-      </p:sp>
-      <p:sp>
-        <p:nvSpPr>
-          <p:cNvPr id="8" name="TextBox 7"/>
-          <p:cNvSpPr txBox="1"/>
-          <p:nvPr/>
-        </p:nvSpPr>
-        <p:spPr>
-          <a:xfrm>
-            <a:off x="11548872" y="6250838"/>
-            <a:ext cx="274320" cy="208483"/>
-          </a:xfrm>
-          <a:prstGeom prst="rect">
-            <a:avLst/>
-          </a:prstGeom>
-          <a:noFill/>
-        </p:spPr>
-        <p:txBody>
-          <a:bodyPr wrap="square">
-            <a:spAutoFit/>
-          </a:bodyPr>
-          <a:lstStyle/>
-          <a:p>
-            <a:pPr algn="ctr"/>
-            <a:r>
-              <a:rPr sz="1000" b="1" i="0">
-                <a:solidFill>
-                  <a:srgbClr val="FFFFFF"/>
-                </a:solidFill>
-                <a:latin typeface="DM Sans"/>
-              </a:rPr>
-              <a:t>5</a:t>
-            </a:r>
-          </a:p>
-        </p:txBody>
-      </p:sp>
     </p:spTree>
   </p:cSld>
   <p:clrMapOvr>
@@ -9786,84 +9240,6 @@
                 <a:latin typeface="DM Sans"/>
               </a:rPr>
               <a:t>more scepticism.</a:t>
-            </a:r>
-          </a:p>
-        </p:txBody>
-      </p:sp>
-      <p:sp>
-        <p:nvSpPr>
-          <p:cNvPr id="7" name="Oval 6"/>
-          <p:cNvSpPr/>
-          <p:nvPr/>
-        </p:nvSpPr>
-        <p:spPr>
-          <a:xfrm>
-            <a:off x="11548872" y="6217920"/>
-            <a:ext cx="274320" cy="274320"/>
-          </a:xfrm>
-          <a:prstGeom prst="ellipse">
-            <a:avLst/>
-          </a:prstGeom>
-          <a:solidFill>
-            <a:srgbClr val="027F7C"/>
-          </a:solidFill>
-          <a:ln>
-            <a:noFill/>
-          </a:ln>
-        </p:spPr>
-        <p:style>
-          <a:lnRef idx="1">
-            <a:schemeClr val="accent1"/>
-          </a:lnRef>
-          <a:fillRef idx="3">
-            <a:schemeClr val="accent1"/>
-          </a:fillRef>
-          <a:effectRef idx="2">
-            <a:schemeClr val="accent1"/>
-          </a:effectRef>
-          <a:fontRef idx="minor">
-            <a:schemeClr val="lt1"/>
-          </a:fontRef>
-        </p:style>
-        <p:txBody>
-          <a:bodyPr rtlCol="0" anchor="ctr"/>
-          <a:lstStyle/>
-          <a:p>
-            <a:pPr algn="ctr"/>
-          </a:p>
-        </p:txBody>
-      </p:sp>
-      <p:sp>
-        <p:nvSpPr>
-          <p:cNvPr id="8" name="TextBox 7"/>
-          <p:cNvSpPr txBox="1"/>
-          <p:nvPr/>
-        </p:nvSpPr>
-        <p:spPr>
-          <a:xfrm>
-            <a:off x="11548872" y="6250838"/>
-            <a:ext cx="274320" cy="208483"/>
-          </a:xfrm>
-          <a:prstGeom prst="rect">
-            <a:avLst/>
-          </a:prstGeom>
-          <a:noFill/>
-        </p:spPr>
-        <p:txBody>
-          <a:bodyPr wrap="square">
-            <a:spAutoFit/>
-          </a:bodyPr>
-          <a:lstStyle/>
-          <a:p>
-            <a:pPr algn="ctr"/>
-            <a:r>
-              <a:rPr sz="1000" b="1" i="0">
-                <a:solidFill>
-                  <a:srgbClr val="FFFFFF"/>
-                </a:solidFill>
-                <a:latin typeface="DM Sans"/>
-              </a:rPr>
-              <a:t>6</a:t>
             </a:r>
           </a:p>
         </p:txBody>

</xml_diff>